<commit_message>
Provide scrollable PDF user guide with candidate-level scoring instructions
</commit_message>
<xml_diff>
--- a/docs/Enzora_User_Guide.pptx
+++ b/docs/Enzora_User_Guide.pptx
@@ -2,30 +2,30 @@
 <file path=ppt/presentation.xml><?xml version="1.0" encoding="utf-8"?>
 <p:presentation xmlns:p="http://schemas.openxmlformats.org/presentationml/2006/main">
   <p:sldMasterIdLst>
-    <p:sldMasterId xmlns:r="http://schemas.openxmlformats.org/officeDocument/2006/relationships" id="2147483648" r:id="Rae40fb4327504ee0"/>
+    <p:sldMasterId xmlns:r="http://schemas.openxmlformats.org/officeDocument/2006/relationships" id="2147483648" r:id="Rebbb3697621442a5"/>
   </p:sldMasterIdLst>
   <p:notesMasterIdLst>
-    <p:notesMasterId xmlns:r="http://schemas.openxmlformats.org/officeDocument/2006/relationships" r:id="Ra98cdc35d4ba44ca"/>
+    <p:notesMasterId xmlns:r="http://schemas.openxmlformats.org/officeDocument/2006/relationships" r:id="Rda0b6c41d2c44c77"/>
   </p:notesMasterIdLst>
   <p:sldIdLst>
-    <p:sldId xmlns:r="http://schemas.openxmlformats.org/officeDocument/2006/relationships" id="256" r:id="Ra977fd9732b64d86"/>
-    <p:sldId xmlns:r="http://schemas.openxmlformats.org/officeDocument/2006/relationships" id="257" r:id="R418deba8523245c3"/>
-    <p:sldId xmlns:r="http://schemas.openxmlformats.org/officeDocument/2006/relationships" id="258" r:id="Rdb142a6035e04e7f"/>
-    <p:sldId xmlns:r="http://schemas.openxmlformats.org/officeDocument/2006/relationships" id="259" r:id="R217ec0f922d64b6b"/>
-    <p:sldId xmlns:r="http://schemas.openxmlformats.org/officeDocument/2006/relationships" id="260" r:id="Rc6cba82dee6046bb"/>
-    <p:sldId xmlns:r="http://schemas.openxmlformats.org/officeDocument/2006/relationships" id="261" r:id="Rfc77d1af5a6645f3"/>
-    <p:sldId xmlns:r="http://schemas.openxmlformats.org/officeDocument/2006/relationships" id="262" r:id="R47987fdedbc34c0d"/>
-    <p:sldId xmlns:r="http://schemas.openxmlformats.org/officeDocument/2006/relationships" id="263" r:id="R572e5bf7dddb4149"/>
-    <p:sldId xmlns:r="http://schemas.openxmlformats.org/officeDocument/2006/relationships" id="264" r:id="R2349ccd39cb443c1"/>
-    <p:sldId xmlns:r="http://schemas.openxmlformats.org/officeDocument/2006/relationships" id="265" r:id="R510aa36add2b4479"/>
-    <p:sldId xmlns:r="http://schemas.openxmlformats.org/officeDocument/2006/relationships" id="266" r:id="Rab214582ec1243e5"/>
-    <p:sldId xmlns:r="http://schemas.openxmlformats.org/officeDocument/2006/relationships" id="267" r:id="R7b1364cd57ae426e"/>
-    <p:sldId xmlns:r="http://schemas.openxmlformats.org/officeDocument/2006/relationships" id="268" r:id="R65b67be76ed54b69"/>
-    <p:sldId xmlns:r="http://schemas.openxmlformats.org/officeDocument/2006/relationships" id="269" r:id="Rac2e9dfe297f460c"/>
-    <p:sldId xmlns:r="http://schemas.openxmlformats.org/officeDocument/2006/relationships" id="270" r:id="R7e031e173f28439b"/>
-    <p:sldId xmlns:r="http://schemas.openxmlformats.org/officeDocument/2006/relationships" id="271" r:id="R7579488c1de347a2"/>
-    <p:sldId xmlns:r="http://schemas.openxmlformats.org/officeDocument/2006/relationships" id="272" r:id="R89dc78fad41b46bf"/>
-    <p:sldId xmlns:r="http://schemas.openxmlformats.org/officeDocument/2006/relationships" id="273" r:id="Rfa514ce8e5764e4c"/>
+    <p:sldId xmlns:r="http://schemas.openxmlformats.org/officeDocument/2006/relationships" id="256" r:id="R39dc386694af41b1"/>
+    <p:sldId xmlns:r="http://schemas.openxmlformats.org/officeDocument/2006/relationships" id="257" r:id="R08ba758176b543fe"/>
+    <p:sldId xmlns:r="http://schemas.openxmlformats.org/officeDocument/2006/relationships" id="258" r:id="R5f3f9009ce6d4d25"/>
+    <p:sldId xmlns:r="http://schemas.openxmlformats.org/officeDocument/2006/relationships" id="259" r:id="R91fe7bb43c5342b1"/>
+    <p:sldId xmlns:r="http://schemas.openxmlformats.org/officeDocument/2006/relationships" id="260" r:id="R8c011351de0c4b1b"/>
+    <p:sldId xmlns:r="http://schemas.openxmlformats.org/officeDocument/2006/relationships" id="261" r:id="Ra9b966494fba4bb9"/>
+    <p:sldId xmlns:r="http://schemas.openxmlformats.org/officeDocument/2006/relationships" id="262" r:id="Rae7e722035844fe7"/>
+    <p:sldId xmlns:r="http://schemas.openxmlformats.org/officeDocument/2006/relationships" id="263" r:id="R7601cc72085b4675"/>
+    <p:sldId xmlns:r="http://schemas.openxmlformats.org/officeDocument/2006/relationships" id="264" r:id="R1a78b19518464cea"/>
+    <p:sldId xmlns:r="http://schemas.openxmlformats.org/officeDocument/2006/relationships" id="265" r:id="R0afe24255d8c4d9f"/>
+    <p:sldId xmlns:r="http://schemas.openxmlformats.org/officeDocument/2006/relationships" id="266" r:id="Rcb2dad023d8b400d"/>
+    <p:sldId xmlns:r="http://schemas.openxmlformats.org/officeDocument/2006/relationships" id="267" r:id="Re01b0c5e8a9d496d"/>
+    <p:sldId xmlns:r="http://schemas.openxmlformats.org/officeDocument/2006/relationships" id="268" r:id="Ree197da6db4b4e01"/>
+    <p:sldId xmlns:r="http://schemas.openxmlformats.org/officeDocument/2006/relationships" id="269" r:id="R884228e548fa4f61"/>
+    <p:sldId xmlns:r="http://schemas.openxmlformats.org/officeDocument/2006/relationships" id="270" r:id="R05794996a8224d18"/>
+    <p:sldId xmlns:r="http://schemas.openxmlformats.org/officeDocument/2006/relationships" id="271" r:id="R5ef6f811fc7a4563"/>
+    <p:sldId xmlns:r="http://schemas.openxmlformats.org/officeDocument/2006/relationships" id="272" r:id="R3c5e333872f74532"/>
+    <p:sldId xmlns:r="http://schemas.openxmlformats.org/officeDocument/2006/relationships" id="273" r:id="Rc12e43cb381148e2"/>
   </p:sldIdLst>
   <p:sldSz cx="15240000" cy="20002500"/>
   <p:notesSz cx="6858000" cy="9144000"/>
@@ -459,7 +459,7 @@
           <a:lstStyle xmlns:a="http://schemas.openxmlformats.org/drawingml/2006/main"/>
           <a:p xmlns:a="http://schemas.openxmlformats.org/drawingml/2006/main">
             <a:r>
-              <a:t>Current Enzora UI and source contracts, 16 October 2026. Screenshots labelled as the verified run use ten real computational candidates. Demo values are simulated. Sources: https://enzora-agent.com/ ; https://github.com/YuzhangLi2281/Enzora ; https://github.com/YuzhangLi2281/Phenom .</a:t>
+              <a:t>Current Enzora UI and source contracts, 16 October 2026. Screenshots labelled as the verified run use ten real computational candidates. Demo values are simulated. Sources: https://enzora-agent.com/ ; https://github.com/YuzhangLi2281/Enzora ; https://github.com/YuzhangLi2281/PHENOM .</a:t>
             </a:r>
           </a:p>
         </p:txBody>
@@ -529,7 +529,7 @@
           <a:lstStyle xmlns:a="http://schemas.openxmlformats.org/drawingml/2006/main"/>
           <a:p xmlns:a="http://schemas.openxmlformats.org/drawingml/2006/main">
             <a:r>
-              <a:t>Current Enzora UI and source contracts, 16 October 2026. Screenshots labelled as the verified run use ten real computational candidates. Demo values are simulated. Sources: https://enzora-agent.com/ ; https://github.com/YuzhangLi2281/Enzora ; https://github.com/YuzhangLi2281/Phenom .</a:t>
+              <a:t>Current Enzora UI and source contracts, 16 October 2026. Screenshots labelled as the verified run use ten real computational candidates. Demo values are simulated. Sources: https://enzora-agent.com/ ; https://github.com/YuzhangLi2281/Enzora ; https://github.com/YuzhangLi2281/PHENOM .</a:t>
             </a:r>
           </a:p>
         </p:txBody>
@@ -599,7 +599,7 @@
           <a:lstStyle xmlns:a="http://schemas.openxmlformats.org/drawingml/2006/main"/>
           <a:p xmlns:a="http://schemas.openxmlformats.org/drawingml/2006/main">
             <a:r>
-              <a:t>Current Enzora UI and source contracts, 16 October 2026. Screenshots labelled as the verified run use ten real computational candidates. Demo values are simulated. Sources: https://enzora-agent.com/ ; https://github.com/YuzhangLi2281/Enzora ; https://github.com/YuzhangLi2281/Phenom .</a:t>
+              <a:t>Current Enzora UI and source contracts, 16 October 2026. Screenshots labelled as the verified run use ten real computational candidates. Demo values are simulated. Sources: https://enzora-agent.com/ ; https://github.com/YuzhangLi2281/Enzora ; https://github.com/YuzhangLi2281/PHENOM .</a:t>
             </a:r>
           </a:p>
         </p:txBody>
@@ -669,7 +669,7 @@
           <a:lstStyle xmlns:a="http://schemas.openxmlformats.org/drawingml/2006/main"/>
           <a:p xmlns:a="http://schemas.openxmlformats.org/drawingml/2006/main">
             <a:r>
-              <a:t>Current Enzora UI and source contracts, 16 October 2026. Screenshots labelled as the verified run use ten real computational candidates. Demo values are simulated. Sources: https://enzora-agent.com/ ; https://github.com/YuzhangLi2281/Enzora ; https://github.com/YuzhangLi2281/Phenom .</a:t>
+              <a:t>Current Enzora UI and source contracts, 16 October 2026. Screenshots labelled as the verified run use ten real computational candidates. Demo values are simulated. Sources: https://enzora-agent.com/ ; https://github.com/YuzhangLi2281/Enzora ; https://github.com/YuzhangLi2281/PHENOM .</a:t>
             </a:r>
           </a:p>
         </p:txBody>
@@ -739,7 +739,7 @@
           <a:lstStyle xmlns:a="http://schemas.openxmlformats.org/drawingml/2006/main"/>
           <a:p xmlns:a="http://schemas.openxmlformats.org/drawingml/2006/main">
             <a:r>
-              <a:t>Current Enzora UI and source contracts, 16 October 2026. Screenshots labelled as the verified run use ten real computational candidates. Demo values are simulated. Sources: https://enzora-agent.com/ ; https://github.com/YuzhangLi2281/Enzora ; https://github.com/YuzhangLi2281/Phenom .</a:t>
+              <a:t>Current Enzora UI and source contracts, 16 October 2026. Screenshots labelled as the verified run use ten real computational candidates. Demo values are simulated. Sources: https://enzora-agent.com/ ; https://github.com/YuzhangLi2281/Enzora ; https://github.com/YuzhangLi2281/PHENOM .</a:t>
             </a:r>
           </a:p>
         </p:txBody>
@@ -809,7 +809,7 @@
           <a:lstStyle xmlns:a="http://schemas.openxmlformats.org/drawingml/2006/main"/>
           <a:p xmlns:a="http://schemas.openxmlformats.org/drawingml/2006/main">
             <a:r>
-              <a:t>Current Enzora UI and source contracts, 16 October 2026. Screenshots labelled as the verified run use ten real computational candidates. Demo values are simulated. Sources: https://enzora-agent.com/ ; https://github.com/YuzhangLi2281/Enzora ; https://github.com/YuzhangLi2281/Phenom .</a:t>
+              <a:t>Current Enzora UI and source contracts, 16 October 2026. Screenshots labelled as the verified run use ten real computational candidates. Demo values are simulated. Sources: https://enzora-agent.com/ ; https://github.com/YuzhangLi2281/Enzora ; https://github.com/YuzhangLi2281/PHENOM .</a:t>
             </a:r>
           </a:p>
         </p:txBody>
@@ -879,7 +879,7 @@
           <a:lstStyle xmlns:a="http://schemas.openxmlformats.org/drawingml/2006/main"/>
           <a:p xmlns:a="http://schemas.openxmlformats.org/drawingml/2006/main">
             <a:r>
-              <a:t>Current Enzora UI and source contracts, 16 October 2026. Screenshots labelled as the verified run use ten real computational candidates. Demo values are simulated. Sources: https://enzora-agent.com/ ; https://github.com/YuzhangLi2281/Enzora ; https://github.com/YuzhangLi2281/Phenom .</a:t>
+              <a:t>Current Enzora UI and source contracts, 16 October 2026. Screenshots labelled as the verified run use ten real computational candidates. Demo values are simulated. Sources: https://enzora-agent.com/ ; https://github.com/YuzhangLi2281/Enzora ; https://github.com/YuzhangLi2281/PHENOM .</a:t>
             </a:r>
           </a:p>
         </p:txBody>
@@ -949,7 +949,7 @@
           <a:lstStyle xmlns:a="http://schemas.openxmlformats.org/drawingml/2006/main"/>
           <a:p xmlns:a="http://schemas.openxmlformats.org/drawingml/2006/main">
             <a:r>
-              <a:t>Current Enzora UI and source contracts, 16 October 2026. Screenshots labelled as the verified run use ten real computational candidates. Demo values are simulated. Sources: https://enzora-agent.com/ ; https://github.com/YuzhangLi2281/Enzora ; https://github.com/YuzhangLi2281/Phenom .</a:t>
+              <a:t>Current Enzora UI and source contracts, 16 October 2026. Screenshots labelled as the verified run use ten real computational candidates. Demo values are simulated. Sources: https://enzora-agent.com/ ; https://github.com/YuzhangLi2281/Enzora ; https://github.com/YuzhangLi2281/PHENOM .</a:t>
             </a:r>
           </a:p>
         </p:txBody>
@@ -1019,7 +1019,7 @@
           <a:lstStyle xmlns:a="http://schemas.openxmlformats.org/drawingml/2006/main"/>
           <a:p xmlns:a="http://schemas.openxmlformats.org/drawingml/2006/main">
             <a:r>
-              <a:t>Current Enzora UI and source contracts, 16 October 2026. Screenshots labelled as the verified run use ten real computational candidates. Demo values are simulated. Sources: https://enzora-agent.com/ ; https://github.com/YuzhangLi2281/Enzora ; https://github.com/YuzhangLi2281/Phenom .</a:t>
+              <a:t>Current Enzora UI and source contracts, 16 October 2026. Screenshots labelled as the verified run use ten real computational candidates. Demo values are simulated. Sources: https://enzora-agent.com/ ; https://github.com/YuzhangLi2281/Enzora ; https://github.com/YuzhangLi2281/PHENOM .</a:t>
             </a:r>
           </a:p>
         </p:txBody>
@@ -1089,7 +1089,7 @@
           <a:lstStyle xmlns:a="http://schemas.openxmlformats.org/drawingml/2006/main"/>
           <a:p xmlns:a="http://schemas.openxmlformats.org/drawingml/2006/main">
             <a:r>
-              <a:t>Current Enzora UI and source contracts, 16 October 2026. Screenshots labelled as the verified run use ten real computational candidates. Demo values are simulated. Sources: https://enzora-agent.com/ ; https://github.com/YuzhangLi2281/Enzora ; https://github.com/YuzhangLi2281/Phenom .</a:t>
+              <a:t>Current Enzora UI and source contracts, 16 October 2026. Screenshots labelled as the verified run use ten real computational candidates. Demo values are simulated. Sources: https://enzora-agent.com/ ; https://github.com/YuzhangLi2281/Enzora ; https://github.com/YuzhangLi2281/PHENOM .</a:t>
             </a:r>
           </a:p>
         </p:txBody>
@@ -1159,7 +1159,7 @@
           <a:lstStyle xmlns:a="http://schemas.openxmlformats.org/drawingml/2006/main"/>
           <a:p xmlns:a="http://schemas.openxmlformats.org/drawingml/2006/main">
             <a:r>
-              <a:t>Current Enzora UI and source contracts, 16 October 2026. Screenshots labelled as the verified run use ten real computational candidates. Demo values are simulated. Sources: https://enzora-agent.com/ ; https://github.com/YuzhangLi2281/Enzora ; https://github.com/YuzhangLi2281/Phenom .</a:t>
+              <a:t>Current Enzora UI and source contracts, 16 October 2026. Screenshots labelled as the verified run use ten real computational candidates. Demo values are simulated. Sources: https://enzora-agent.com/ ; https://github.com/YuzhangLi2281/Enzora ; https://github.com/YuzhangLi2281/PHENOM .</a:t>
             </a:r>
           </a:p>
         </p:txBody>
@@ -1229,7 +1229,7 @@
           <a:lstStyle xmlns:a="http://schemas.openxmlformats.org/drawingml/2006/main"/>
           <a:p xmlns:a="http://schemas.openxmlformats.org/drawingml/2006/main">
             <a:r>
-              <a:t>Current Enzora UI and source contracts, 16 October 2026. Screenshots labelled as the verified run use ten real computational candidates. Demo values are simulated. Sources: https://enzora-agent.com/ ; https://github.com/YuzhangLi2281/Enzora ; https://github.com/YuzhangLi2281/Phenom .</a:t>
+              <a:t>Current Enzora UI and source contracts, 16 October 2026. Screenshots labelled as the verified run use ten real computational candidates. Demo values are simulated. Sources: https://enzora-agent.com/ ; https://github.com/YuzhangLi2281/Enzora ; https://github.com/YuzhangLi2281/PHENOM .</a:t>
             </a:r>
           </a:p>
         </p:txBody>
@@ -1299,7 +1299,7 @@
           <a:lstStyle xmlns:a="http://schemas.openxmlformats.org/drawingml/2006/main"/>
           <a:p xmlns:a="http://schemas.openxmlformats.org/drawingml/2006/main">
             <a:r>
-              <a:t>Current Enzora UI and source contracts, 16 October 2026. Screenshots labelled as the verified run use ten real computational candidates. Demo values are simulated. Sources: https://enzora-agent.com/ ; https://github.com/YuzhangLi2281/Enzora ; https://github.com/YuzhangLi2281/Phenom .</a:t>
+              <a:t>Current Enzora UI and source contracts, 16 October 2026. Screenshots labelled as the verified run use ten real computational candidates. Demo values are simulated. Sources: https://enzora-agent.com/ ; https://github.com/YuzhangLi2281/Enzora ; https://github.com/YuzhangLi2281/PHENOM .</a:t>
             </a:r>
           </a:p>
         </p:txBody>
@@ -1369,7 +1369,7 @@
           <a:lstStyle xmlns:a="http://schemas.openxmlformats.org/drawingml/2006/main"/>
           <a:p xmlns:a="http://schemas.openxmlformats.org/drawingml/2006/main">
             <a:r>
-              <a:t>Current Enzora UI and source contracts, 16 October 2026. Screenshots labelled as the verified run use ten real computational candidates. Demo values are simulated. Sources: https://enzora-agent.com/ ; https://github.com/YuzhangLi2281/Enzora ; https://github.com/YuzhangLi2281/Phenom .</a:t>
+              <a:t>Current Enzora UI and source contracts, 16 October 2026. Screenshots labelled as the verified run use ten real computational candidates. Demo values are simulated. Sources: https://enzora-agent.com/ ; https://github.com/YuzhangLi2281/Enzora ; https://github.com/YuzhangLi2281/PHENOM .</a:t>
             </a:r>
           </a:p>
         </p:txBody>
@@ -1439,7 +1439,7 @@
           <a:lstStyle xmlns:a="http://schemas.openxmlformats.org/drawingml/2006/main"/>
           <a:p xmlns:a="http://schemas.openxmlformats.org/drawingml/2006/main">
             <a:r>
-              <a:t>Current Enzora UI and source contracts, 16 October 2026. Screenshots labelled as the verified run use ten real computational candidates. Demo values are simulated. Sources: https://enzora-agent.com/ ; https://github.com/YuzhangLi2281/Enzora ; https://github.com/YuzhangLi2281/Phenom .</a:t>
+              <a:t>Current Enzora UI and source contracts, 16 October 2026. Screenshots labelled as the verified run use ten real computational candidates. Demo values are simulated. Sources: https://enzora-agent.com/ ; https://github.com/YuzhangLi2281/Enzora ; https://github.com/YuzhangLi2281/PHENOM .</a:t>
             </a:r>
           </a:p>
         </p:txBody>
@@ -1509,7 +1509,7 @@
           <a:lstStyle xmlns:a="http://schemas.openxmlformats.org/drawingml/2006/main"/>
           <a:p xmlns:a="http://schemas.openxmlformats.org/drawingml/2006/main">
             <a:r>
-              <a:t>Current Enzora UI and source contracts, 16 October 2026. Screenshots labelled as the verified run use ten real computational candidates. Demo values are simulated. Sources: https://enzora-agent.com/ ; https://github.com/YuzhangLi2281/Enzora ; https://github.com/YuzhangLi2281/Phenom .</a:t>
+              <a:t>Current Enzora UI and source contracts, 16 October 2026. Screenshots labelled as the verified run use ten real computational candidates. Demo values are simulated. Sources: https://enzora-agent.com/ ; https://github.com/YuzhangLi2281/Enzora ; https://github.com/YuzhangLi2281/PHENOM .</a:t>
             </a:r>
           </a:p>
         </p:txBody>
@@ -1579,7 +1579,7 @@
           <a:lstStyle xmlns:a="http://schemas.openxmlformats.org/drawingml/2006/main"/>
           <a:p xmlns:a="http://schemas.openxmlformats.org/drawingml/2006/main">
             <a:r>
-              <a:t>Current Enzora UI and source contracts, 16 October 2026. Screenshots labelled as the verified run use ten real computational candidates. Demo values are simulated. Sources: https://enzora-agent.com/ ; https://github.com/YuzhangLi2281/Enzora ; https://github.com/YuzhangLi2281/Phenom .</a:t>
+              <a:t>Current Enzora UI and source contracts, 16 October 2026. Screenshots labelled as the verified run use ten real computational candidates. Demo values are simulated. Sources: https://enzora-agent.com/ ; https://github.com/YuzhangLi2281/Enzora ; https://github.com/YuzhangLi2281/PHENOM .</a:t>
             </a:r>
           </a:p>
         </p:txBody>
@@ -1649,7 +1649,7 @@
           <a:lstStyle xmlns:a="http://schemas.openxmlformats.org/drawingml/2006/main"/>
           <a:p xmlns:a="http://schemas.openxmlformats.org/drawingml/2006/main">
             <a:r>
-              <a:t>Current Enzora UI and source contracts, 16 October 2026. Screenshots labelled as the verified run use ten real computational candidates. Demo values are simulated. Sources: https://enzora-agent.com/ ; https://github.com/YuzhangLi2281/Enzora ; https://github.com/YuzhangLi2281/Phenom .</a:t>
+              <a:t>Current Enzora UI and source contracts, 16 October 2026. Screenshots labelled as the verified run use ten real computational candidates. Demo values are simulated. Sources: https://enzora-agent.com/ ; https://github.com/YuzhangLi2281/Enzora ; https://github.com/YuzhangLi2281/PHENOM .</a:t>
             </a:r>
           </a:p>
         </p:txBody>
@@ -1696,7 +1696,7 @@
           <p:cNvPr id="3" name="Title">
             <a:extLst xmlns:a="http://schemas.openxmlformats.org/drawingml/2006/main">
               <a:ext uri="{FF2B5EF4-FFF2-40B4-BE49-F238E27FC236}">
-                <a16:creationId xmlns:a16="http://schemas.microsoft.com/office/drawing/2014/main" id="{6631894A-8014-4F10-98A6-72045BB780AE}"/>
+                <a16:creationId xmlns:a16="http://schemas.microsoft.com/office/drawing/2014/main" id="{A1315BB0-7FE3-4242-BD94-C02A90A44DF6}"/>
               </a:ext>
             </a:extLst>
           </p:cNvPr>
@@ -1853,7 +1853,7 @@
           <p:cNvPr id="2" name="Subtitle">
             <a:extLst xmlns:a="http://schemas.openxmlformats.org/drawingml/2006/main">
               <a:ext uri="{FF2B5EF4-FFF2-40B4-BE49-F238E27FC236}">
-                <a16:creationId xmlns:a16="http://schemas.microsoft.com/office/drawing/2014/main" id="{40F9FEA2-9F1F-4CDF-9658-E4E4C6B9DF25}"/>
+                <a16:creationId xmlns:a16="http://schemas.microsoft.com/office/drawing/2014/main" id="{9C6888FE-32D9-4AB2-9464-6164BF5CD423}"/>
               </a:ext>
             </a:extLst>
           </p:cNvPr>
@@ -2027,7 +2027,7 @@
           <p:cNvPr id="2" name="Section title">
             <a:extLst xmlns:a="http://schemas.openxmlformats.org/drawingml/2006/main">
               <a:ext uri="{FF2B5EF4-FFF2-40B4-BE49-F238E27FC236}">
-                <a16:creationId xmlns:a16="http://schemas.microsoft.com/office/drawing/2014/main" id="{AF60C271-69E0-4520-B457-688F4A61E749}"/>
+                <a16:creationId xmlns:a16="http://schemas.microsoft.com/office/drawing/2014/main" id="{1378EA28-2850-49D8-B8F0-B0908B9BCE8B}"/>
               </a:ext>
             </a:extLst>
           </p:cNvPr>
@@ -2201,7 +2201,7 @@
           <p:cNvPr id="3" name="Title">
             <a:extLst xmlns:a="http://schemas.openxmlformats.org/drawingml/2006/main">
               <a:ext uri="{FF2B5EF4-FFF2-40B4-BE49-F238E27FC236}">
-                <a16:creationId xmlns:a16="http://schemas.microsoft.com/office/drawing/2014/main" id="{8419FFF9-F8D7-4440-AA19-DE32DD024B9F}"/>
+                <a16:creationId xmlns:a16="http://schemas.microsoft.com/office/drawing/2014/main" id="{093B3A61-9901-40DE-A76D-85C9582FBD0E}"/>
               </a:ext>
             </a:extLst>
           </p:cNvPr>
@@ -2358,7 +2358,7 @@
           <p:cNvPr id="2" name="Body">
             <a:extLst xmlns:a="http://schemas.openxmlformats.org/drawingml/2006/main">
               <a:ext uri="{FF2B5EF4-FFF2-40B4-BE49-F238E27FC236}">
-                <a16:creationId xmlns:a16="http://schemas.microsoft.com/office/drawing/2014/main" id="{901BDFEA-2A4F-4240-ADDA-4E6EAD78B125}"/>
+                <a16:creationId xmlns:a16="http://schemas.microsoft.com/office/drawing/2014/main" id="{E5467B06-953E-4506-A054-59767CB2DEBF}"/>
               </a:ext>
             </a:extLst>
           </p:cNvPr>
@@ -2532,7 +2532,7 @@
           <p:cNvPr id="4" name="Title">
             <a:extLst xmlns:a="http://schemas.openxmlformats.org/drawingml/2006/main">
               <a:ext uri="{FF2B5EF4-FFF2-40B4-BE49-F238E27FC236}">
-                <a16:creationId xmlns:a16="http://schemas.microsoft.com/office/drawing/2014/main" id="{33CF2F2F-BB77-401E-BBF3-2A4B2D1B8C3C}"/>
+                <a16:creationId xmlns:a16="http://schemas.microsoft.com/office/drawing/2014/main" id="{469AACDE-3A15-4F6C-994D-F78BE2E0FDED}"/>
               </a:ext>
             </a:extLst>
           </p:cNvPr>
@@ -2689,7 +2689,7 @@
           <p:cNvPr id="2" name="Left column">
             <a:extLst xmlns:a="http://schemas.openxmlformats.org/drawingml/2006/main">
               <a:ext uri="{FF2B5EF4-FFF2-40B4-BE49-F238E27FC236}">
-                <a16:creationId xmlns:a16="http://schemas.microsoft.com/office/drawing/2014/main" id="{2E5DE119-F375-48B3-8970-26CB79167A36}"/>
+                <a16:creationId xmlns:a16="http://schemas.microsoft.com/office/drawing/2014/main" id="{D57F867F-28D9-43C7-A529-6922A965E942}"/>
               </a:ext>
             </a:extLst>
           </p:cNvPr>
@@ -2846,7 +2846,7 @@
           <p:cNvPr id="3" name="Right column">
             <a:extLst xmlns:a="http://schemas.openxmlformats.org/drawingml/2006/main">
               <a:ext uri="{FF2B5EF4-FFF2-40B4-BE49-F238E27FC236}">
-                <a16:creationId xmlns:a16="http://schemas.microsoft.com/office/drawing/2014/main" id="{9B55CA9A-A7F5-4A22-A573-F413F04EE49E}"/>
+                <a16:creationId xmlns:a16="http://schemas.microsoft.com/office/drawing/2014/main" id="{EF803E03-420B-432D-B9D4-2670AC55D209}"/>
               </a:ext>
             </a:extLst>
           </p:cNvPr>
@@ -3020,7 +3020,7 @@
           <p:cNvPr id="3" name="Title">
             <a:extLst xmlns:a="http://schemas.openxmlformats.org/drawingml/2006/main">
               <a:ext uri="{FF2B5EF4-FFF2-40B4-BE49-F238E27FC236}">
-                <a16:creationId xmlns:a16="http://schemas.microsoft.com/office/drawing/2014/main" id="{AC8CAA51-F625-4B1F-8650-8270D2368CCB}"/>
+                <a16:creationId xmlns:a16="http://schemas.microsoft.com/office/drawing/2014/main" id="{659FAAA2-C0B4-4740-B696-DD9924918EEE}"/>
               </a:ext>
             </a:extLst>
           </p:cNvPr>
@@ -3177,7 +3177,7 @@
           <p:cNvPr id="2" name="Left column">
             <a:extLst xmlns:a="http://schemas.openxmlformats.org/drawingml/2006/main">
               <a:ext uri="{FF2B5EF4-FFF2-40B4-BE49-F238E27FC236}">
-                <a16:creationId xmlns:a16="http://schemas.microsoft.com/office/drawing/2014/main" id="{E47D412D-111F-48B3-A01E-FD938EFA4200}"/>
+                <a16:creationId xmlns:a16="http://schemas.microsoft.com/office/drawing/2014/main" id="{4CD9FBE1-69A3-47BB-9280-863608936D70}"/>
               </a:ext>
             </a:extLst>
           </p:cNvPr>
@@ -3372,12 +3372,12 @@
   </p:cSld>
   <p:clrMap bg1="lt1" tx1="dk1" bg2="lt2" tx2="dk2" accent1="accent1" accent2="accent2" accent3="accent3" accent4="accent4" accent5="accent5" accent6="accent6" hlink="hlink" folHlink="folHlink"/>
   <p:sldLayoutIdLst>
-    <p:sldLayoutId xmlns:r="http://schemas.openxmlformats.org/officeDocument/2006/relationships" id="2147483649" r:id="R699cb517b6134163"/>
-    <p:sldLayoutId xmlns:r="http://schemas.openxmlformats.org/officeDocument/2006/relationships" id="2147483650" r:id="R80cbf824a17e4284"/>
-    <p:sldLayoutId xmlns:r="http://schemas.openxmlformats.org/officeDocument/2006/relationships" id="2147483651" r:id="R0ca2af56aa94408f"/>
-    <p:sldLayoutId xmlns:r="http://schemas.openxmlformats.org/officeDocument/2006/relationships" id="2147483652" r:id="R8225015ae14e4748"/>
-    <p:sldLayoutId xmlns:r="http://schemas.openxmlformats.org/officeDocument/2006/relationships" id="2147483653" r:id="R7826c4ee60854684"/>
-    <p:sldLayoutId xmlns:r="http://schemas.openxmlformats.org/officeDocument/2006/relationships" id="2147483654" r:id="R85d505513a954f74"/>
+    <p:sldLayoutId xmlns:r="http://schemas.openxmlformats.org/officeDocument/2006/relationships" id="2147483649" r:id="Rd6cbef2a419d47ee"/>
+    <p:sldLayoutId xmlns:r="http://schemas.openxmlformats.org/officeDocument/2006/relationships" id="2147483650" r:id="Rc3abc8b88c154ff7"/>
+    <p:sldLayoutId xmlns:r="http://schemas.openxmlformats.org/officeDocument/2006/relationships" id="2147483651" r:id="R3ac23dc962054fee"/>
+    <p:sldLayoutId xmlns:r="http://schemas.openxmlformats.org/officeDocument/2006/relationships" id="2147483652" r:id="R57a3787c853f474b"/>
+    <p:sldLayoutId xmlns:r="http://schemas.openxmlformats.org/officeDocument/2006/relationships" id="2147483653" r:id="Rc7b2faaf3b0c4272"/>
+    <p:sldLayoutId xmlns:r="http://schemas.openxmlformats.org/officeDocument/2006/relationships" id="2147483654" r:id="Rfe70ff30301347f1"/>
   </p:sldLayoutIdLst>
   <p:txStyles>
     <p:titleStyle>
@@ -3928,7 +3928,7 @@
           <p:cNvPr id="12" name="">
             <a:extLst xmlns:a="http://schemas.openxmlformats.org/drawingml/2006/main">
               <a:ext uri="{FF2B5EF4-FFF2-40B4-BE49-F238E27FC236}">
-                <a16:creationId xmlns:a16="http://schemas.microsoft.com/office/drawing/2014/main" id="{E7E45A14-A496-46FA-A487-10293BC31219}"/>
+                <a16:creationId xmlns:a16="http://schemas.microsoft.com/office/drawing/2014/main" id="{21EA25DB-F702-4F97-959C-EBD54703AE05}"/>
               </a:ext>
             </a:extLst>
           </p:cNvPr>
@@ -3994,7 +3994,7 @@
           <p:cNvPr id="2" name="">
             <a:extLst xmlns:a="http://schemas.openxmlformats.org/drawingml/2006/main">
               <a:ext uri="{FF2B5EF4-FFF2-40B4-BE49-F238E27FC236}">
-                <a16:creationId xmlns:a16="http://schemas.microsoft.com/office/drawing/2014/main" id="{DF2B120E-606A-4536-8076-55CB0C31F2A9}"/>
+                <a16:creationId xmlns:a16="http://schemas.microsoft.com/office/drawing/2014/main" id="{19CA5EFC-50EC-4986-8EA3-40E7C6092F18}"/>
               </a:ext>
             </a:extLst>
           </p:cNvPr>
@@ -4083,7 +4083,7 @@
           <p:cNvPr id="3" name="">
             <a:extLst xmlns:a="http://schemas.openxmlformats.org/drawingml/2006/main">
               <a:ext uri="{FF2B5EF4-FFF2-40B4-BE49-F238E27FC236}">
-                <a16:creationId xmlns:a16="http://schemas.microsoft.com/office/drawing/2014/main" id="{22DAD470-4ABC-47C7-9D6A-CB4BCEC732D2}"/>
+                <a16:creationId xmlns:a16="http://schemas.microsoft.com/office/drawing/2014/main" id="{B96D17C8-2D13-4338-B479-F5A6094D216E}"/>
               </a:ext>
             </a:extLst>
           </p:cNvPr>
@@ -4149,7 +4149,7 @@
           <p:cNvPr id="4" name="">
             <a:extLst xmlns:a="http://schemas.openxmlformats.org/drawingml/2006/main">
               <a:ext uri="{FF2B5EF4-FFF2-40B4-BE49-F238E27FC236}">
-                <a16:creationId xmlns:a16="http://schemas.microsoft.com/office/drawing/2014/main" id="{CB41A1EF-EC93-4476-AFFC-899790EADCFC}"/>
+                <a16:creationId xmlns:a16="http://schemas.microsoft.com/office/drawing/2014/main" id="{02605627-910E-45CC-9135-86689317AA52}"/>
               </a:ext>
             </a:extLst>
           </p:cNvPr>
@@ -4215,7 +4215,7 @@
           <p:cNvPr id="5" name="">
             <a:extLst xmlns:a="http://schemas.openxmlformats.org/drawingml/2006/main">
               <a:ext uri="{FF2B5EF4-FFF2-40B4-BE49-F238E27FC236}">
-                <a16:creationId xmlns:a16="http://schemas.microsoft.com/office/drawing/2014/main" id="{2BA15282-04F1-43C2-99E0-6E6E7B0C19E5}"/>
+                <a16:creationId xmlns:a16="http://schemas.microsoft.com/office/drawing/2014/main" id="{16A21A99-DB7A-4495-87A5-974EFD33A5F3}"/>
               </a:ext>
             </a:extLst>
           </p:cNvPr>
@@ -4281,7 +4281,7 @@
           <p:cNvPr id="6" name="">
             <a:extLst xmlns:a="http://schemas.openxmlformats.org/drawingml/2006/main">
               <a:ext uri="{FF2B5EF4-FFF2-40B4-BE49-F238E27FC236}">
-                <a16:creationId xmlns:a16="http://schemas.microsoft.com/office/drawing/2014/main" id="{46562EDC-B2CB-4657-9744-F804EDF43198}"/>
+                <a16:creationId xmlns:a16="http://schemas.microsoft.com/office/drawing/2014/main" id="{2233D2BF-C006-4BE3-B328-6305625E15E2}"/>
               </a:ext>
             </a:extLst>
           </p:cNvPr>
@@ -4291,10 +4291,10 @@
           <p:nvPr/>
         </p:nvPicPr>
         <p:blipFill>
-          <a:blip xmlns:r="http://schemas.openxmlformats.org/officeDocument/2006/relationships" xmlns:a="http://schemas.openxmlformats.org/drawingml/2006/main" r:embed="R93d04532ef5f4442">
+          <a:blip xmlns:r="http://schemas.openxmlformats.org/officeDocument/2006/relationships" xmlns:a="http://schemas.openxmlformats.org/drawingml/2006/main" r:embed="Rb33c01b09d48465c">
             <a:extLst>
               <a:ext uri="{96DAC541-7B7A-43D3-8B79-37D633B846F1}">
-                <asvg:svgBlip xmlns:asvg="http://schemas.microsoft.com/office/drawing/2016/SVG/main" r:embed="Re8f6506187904ebd"/>
+                <asvg:svgBlip xmlns:asvg="http://schemas.microsoft.com/office/drawing/2016/SVG/main" r:embed="R105c5a95f6bf4128"/>
               </a:ext>
             </a:extLst>
           </a:blip>
@@ -4315,7 +4315,7 @@
           <p:cNvPr id="7" name="">
             <a:extLst xmlns:a="http://schemas.openxmlformats.org/drawingml/2006/main">
               <a:ext uri="{FF2B5EF4-FFF2-40B4-BE49-F238E27FC236}">
-                <a16:creationId xmlns:a16="http://schemas.microsoft.com/office/drawing/2014/main" id="{58708736-A847-4EA1-8A37-BBFF4C581AFD}"/>
+                <a16:creationId xmlns:a16="http://schemas.microsoft.com/office/drawing/2014/main" id="{5539E8EF-11BD-46E9-98AE-F998A353F77A}"/>
               </a:ext>
             </a:extLst>
           </p:cNvPr>
@@ -4381,7 +4381,7 @@
           <p:cNvPr id="8" name="">
             <a:extLst xmlns:a="http://schemas.openxmlformats.org/drawingml/2006/main">
               <a:ext uri="{FF2B5EF4-FFF2-40B4-BE49-F238E27FC236}">
-                <a16:creationId xmlns:a16="http://schemas.microsoft.com/office/drawing/2014/main" id="{3F92E959-7E5D-4500-8628-EAC7893A13DD}"/>
+                <a16:creationId xmlns:a16="http://schemas.microsoft.com/office/drawing/2014/main" id="{F0FFC296-35F3-4500-ABCF-2C562409D8E6}"/>
               </a:ext>
             </a:extLst>
           </p:cNvPr>
@@ -4447,7 +4447,7 @@
           <p:cNvPr id="9" name="">
             <a:extLst xmlns:a="http://schemas.openxmlformats.org/drawingml/2006/main">
               <a:ext uri="{FF2B5EF4-FFF2-40B4-BE49-F238E27FC236}">
-                <a16:creationId xmlns:a16="http://schemas.microsoft.com/office/drawing/2014/main" id="{086C2995-B132-4E26-BC06-A915A0E4764B}"/>
+                <a16:creationId xmlns:a16="http://schemas.microsoft.com/office/drawing/2014/main" id="{7C2F1510-184F-4D16-8271-59206BBD9A52}"/>
               </a:ext>
             </a:extLst>
           </p:cNvPr>
@@ -4513,7 +4513,7 @@
           <p:cNvPr id="10" name="">
             <a:extLst xmlns:a="http://schemas.openxmlformats.org/drawingml/2006/main">
               <a:ext uri="{FF2B5EF4-FFF2-40B4-BE49-F238E27FC236}">
-                <a16:creationId xmlns:a16="http://schemas.microsoft.com/office/drawing/2014/main" id="{9DC686E1-3B58-422A-8948-0EDF6B13AF02}"/>
+                <a16:creationId xmlns:a16="http://schemas.microsoft.com/office/drawing/2014/main" id="{47D57134-140B-42EE-A3E8-FBA41FB75B34}"/>
               </a:ext>
             </a:extLst>
           </p:cNvPr>
@@ -4562,7 +4562,7 @@
             </a:pPr>
             <a:r>
               <a:rPr>
-                <a:hlinkClick xmlns:r="http://schemas.openxmlformats.org/officeDocument/2006/relationships" r:id="Rac50cca7297045da"/>
+                <a:hlinkClick xmlns:r="http://schemas.openxmlformats.org/officeDocument/2006/relationships" r:id="Rc255fa6ffc28478d"/>
               </a:rPr>
               <a:t>https://enzora-agent.com</a:t>
             </a:r>
@@ -4574,7 +4574,7 @@
           <p:cNvPr id="11" name="">
             <a:extLst xmlns:a="http://schemas.openxmlformats.org/drawingml/2006/main">
               <a:ext uri="{FF2B5EF4-FFF2-40B4-BE49-F238E27FC236}">
-                <a16:creationId xmlns:a16="http://schemas.microsoft.com/office/drawing/2014/main" id="{C78424CA-5816-497D-A86B-B150D46D787E}"/>
+                <a16:creationId xmlns:a16="http://schemas.microsoft.com/office/drawing/2014/main" id="{C1A8FB51-EC6D-46EC-A351-FB8CB755D9C0}"/>
               </a:ext>
             </a:extLst>
           </p:cNvPr>
@@ -4684,7 +4684,7 @@
     </p:spTree>
     <p:extLst>
       <p:ext uri="{BB962C8B-B14F-4D97-AF65-F5344CB8AC3E}">
-        <p14:creationId xmlns:p14="http://schemas.microsoft.com/office/powerpoint/2010/main" val="489617111"/>
+        <p14:creationId xmlns:p14="http://schemas.microsoft.com/office/powerpoint/2010/main" val="1347788459"/>
       </p:ext>
     </p:extLst>
   </p:cSld>
@@ -4715,7 +4715,7 @@
           <p:cNvPr id="11" name="">
             <a:extLst xmlns:a="http://schemas.openxmlformats.org/drawingml/2006/main">
               <a:ext uri="{FF2B5EF4-FFF2-40B4-BE49-F238E27FC236}">
-                <a16:creationId xmlns:a16="http://schemas.microsoft.com/office/drawing/2014/main" id="{2E03E993-B720-4BDB-BB6D-F77D119AADE6}"/>
+                <a16:creationId xmlns:a16="http://schemas.microsoft.com/office/drawing/2014/main" id="{1DCDF757-D2E5-4DA9-8650-FB7F73CF75B3}"/>
               </a:ext>
             </a:extLst>
           </p:cNvPr>
@@ -4781,7 +4781,7 @@
           <p:cNvPr id="2" name="">
             <a:extLst xmlns:a="http://schemas.openxmlformats.org/drawingml/2006/main">
               <a:ext uri="{FF2B5EF4-FFF2-40B4-BE49-F238E27FC236}">
-                <a16:creationId xmlns:a16="http://schemas.microsoft.com/office/drawing/2014/main" id="{99B5DDC9-FA25-47A7-8B79-ED67A66EF368}"/>
+                <a16:creationId xmlns:a16="http://schemas.microsoft.com/office/drawing/2014/main" id="{7BC655CB-D68F-4AC9-ADC0-50D215456B15}"/>
               </a:ext>
             </a:extLst>
           </p:cNvPr>
@@ -4847,7 +4847,7 @@
           <p:cNvPr id="3" name="">
             <a:extLst xmlns:a="http://schemas.openxmlformats.org/drawingml/2006/main">
               <a:ext uri="{FF2B5EF4-FFF2-40B4-BE49-F238E27FC236}">
-                <a16:creationId xmlns:a16="http://schemas.microsoft.com/office/drawing/2014/main" id="{C56A4239-AB74-41A9-B837-F373812DDA01}"/>
+                <a16:creationId xmlns:a16="http://schemas.microsoft.com/office/drawing/2014/main" id="{0E7A5436-245B-46BB-9D32-5B5DE30C6615}"/>
               </a:ext>
             </a:extLst>
           </p:cNvPr>
@@ -4913,7 +4913,7 @@
           <p:cNvPr id="4" name="">
             <a:extLst xmlns:a="http://schemas.openxmlformats.org/drawingml/2006/main">
               <a:ext uri="{FF2B5EF4-FFF2-40B4-BE49-F238E27FC236}">
-                <a16:creationId xmlns:a16="http://schemas.microsoft.com/office/drawing/2014/main" id="{E2B897A1-3B19-4083-9195-7B4F35BEA04C}"/>
+                <a16:creationId xmlns:a16="http://schemas.microsoft.com/office/drawing/2014/main" id="{7875ACF0-8F1F-43E1-8928-AC41402DED71}"/>
               </a:ext>
             </a:extLst>
           </p:cNvPr>
@@ -4979,7 +4979,7 @@
           <p:cNvPr id="5" name="">
             <a:extLst xmlns:a="http://schemas.openxmlformats.org/drawingml/2006/main">
               <a:ext uri="{FF2B5EF4-FFF2-40B4-BE49-F238E27FC236}">
-                <a16:creationId xmlns:a16="http://schemas.microsoft.com/office/drawing/2014/main" id="{D31EE7C8-792E-4E32-8A47-F996EEB1DF16}"/>
+                <a16:creationId xmlns:a16="http://schemas.microsoft.com/office/drawing/2014/main" id="{D09D0163-AABF-443D-920D-EAA147B0CA6E}"/>
               </a:ext>
             </a:extLst>
           </p:cNvPr>
@@ -5045,7 +5045,7 @@
           <p:cNvPr id="6" name="">
             <a:extLst xmlns:a="http://schemas.openxmlformats.org/drawingml/2006/main">
               <a:ext uri="{FF2B5EF4-FFF2-40B4-BE49-F238E27FC236}">
-                <a16:creationId xmlns:a16="http://schemas.microsoft.com/office/drawing/2014/main" id="{67B385AC-D90D-4BF1-A711-8602A634BEF6}"/>
+                <a16:creationId xmlns:a16="http://schemas.microsoft.com/office/drawing/2014/main" id="{67BD5B98-0E61-414E-8804-BCAB27446EEF}"/>
               </a:ext>
             </a:extLst>
           </p:cNvPr>
@@ -5111,7 +5111,7 @@
           <p:cNvPr id="7" name="">
             <a:extLst xmlns:a="http://schemas.openxmlformats.org/drawingml/2006/main">
               <a:ext uri="{FF2B5EF4-FFF2-40B4-BE49-F238E27FC236}">
-                <a16:creationId xmlns:a16="http://schemas.microsoft.com/office/drawing/2014/main" id="{A17265D7-982C-4677-BB31-524A29A207FF}"/>
+                <a16:creationId xmlns:a16="http://schemas.microsoft.com/office/drawing/2014/main" id="{16C05CEE-B5D0-457C-A4F8-36E368135F5C}"/>
               </a:ext>
             </a:extLst>
           </p:cNvPr>
@@ -5177,7 +5177,7 @@
           <p:cNvPr id="8" name="">
             <a:extLst xmlns:a="http://schemas.openxmlformats.org/drawingml/2006/main">
               <a:ext uri="{FF2B5EF4-FFF2-40B4-BE49-F238E27FC236}">
-                <a16:creationId xmlns:a16="http://schemas.microsoft.com/office/drawing/2014/main" id="{159FE68F-FDDA-4407-AF13-F1BB90E31D79}"/>
+                <a16:creationId xmlns:a16="http://schemas.microsoft.com/office/drawing/2014/main" id="{DA5981A7-AD37-432F-AD28-B29941DA3184}"/>
               </a:ext>
             </a:extLst>
           </p:cNvPr>
@@ -5289,7 +5289,7 @@
           <p:cNvPr id="9" name="">
             <a:extLst xmlns:a="http://schemas.openxmlformats.org/drawingml/2006/main">
               <a:ext uri="{FF2B5EF4-FFF2-40B4-BE49-F238E27FC236}">
-                <a16:creationId xmlns:a16="http://schemas.microsoft.com/office/drawing/2014/main" id="{4DC9F217-5172-441E-8365-1FEC9A26E4D3}"/>
+                <a16:creationId xmlns:a16="http://schemas.microsoft.com/office/drawing/2014/main" id="{5FAEF748-C0A4-4559-B3D5-405AABD97787}"/>
               </a:ext>
             </a:extLst>
           </p:cNvPr>
@@ -5299,7 +5299,7 @@
           <p:nvPr/>
         </p:nvPicPr>
         <p:blipFill>
-          <a:blip xmlns:r="http://schemas.openxmlformats.org/officeDocument/2006/relationships" xmlns:a="http://schemas.openxmlformats.org/drawingml/2006/main" r:embed="R04eae4421c83480d"/>
+          <a:blip xmlns:r="http://schemas.openxmlformats.org/officeDocument/2006/relationships" xmlns:a="http://schemas.openxmlformats.org/drawingml/2006/main" r:embed="Ra059ab73967f42a7"/>
           <a:stretch xmlns:a="http://schemas.openxmlformats.org/drawingml/2006/main"/>
         </p:blipFill>
         <p:spPr>
@@ -5317,7 +5317,7 @@
           <p:cNvPr id="10" name="">
             <a:extLst xmlns:a="http://schemas.openxmlformats.org/drawingml/2006/main">
               <a:ext uri="{FF2B5EF4-FFF2-40B4-BE49-F238E27FC236}">
-                <a16:creationId xmlns:a16="http://schemas.microsoft.com/office/drawing/2014/main" id="{5EE411BD-98D8-411E-BE90-D4CCF92FE3B1}"/>
+                <a16:creationId xmlns:a16="http://schemas.microsoft.com/office/drawing/2014/main" id="{D7D9CADF-58EB-4E19-AA90-F4A472ECC60C}"/>
               </a:ext>
             </a:extLst>
           </p:cNvPr>
@@ -5381,7 +5381,7 @@
     </p:spTree>
     <p:extLst>
       <p:ext uri="{BB962C8B-B14F-4D97-AF65-F5344CB8AC3E}">
-        <p14:creationId xmlns:p14="http://schemas.microsoft.com/office/powerpoint/2010/main" val="1852758573"/>
+        <p14:creationId xmlns:p14="http://schemas.microsoft.com/office/powerpoint/2010/main" val="240632170"/>
       </p:ext>
     </p:extLst>
   </p:cSld>
@@ -5412,7 +5412,7 @@
           <p:cNvPr id="11" name="">
             <a:extLst xmlns:a="http://schemas.openxmlformats.org/drawingml/2006/main">
               <a:ext uri="{FF2B5EF4-FFF2-40B4-BE49-F238E27FC236}">
-                <a16:creationId xmlns:a16="http://schemas.microsoft.com/office/drawing/2014/main" id="{6D043B79-F02D-40EC-A0B2-952BDCC42F6B}"/>
+                <a16:creationId xmlns:a16="http://schemas.microsoft.com/office/drawing/2014/main" id="{80AC8A54-460D-4B9C-8F7F-7D0A24312642}"/>
               </a:ext>
             </a:extLst>
           </p:cNvPr>
@@ -5478,7 +5478,7 @@
           <p:cNvPr id="2" name="">
             <a:extLst xmlns:a="http://schemas.openxmlformats.org/drawingml/2006/main">
               <a:ext uri="{FF2B5EF4-FFF2-40B4-BE49-F238E27FC236}">
-                <a16:creationId xmlns:a16="http://schemas.microsoft.com/office/drawing/2014/main" id="{B8EC4871-39CE-4E54-ABD8-8454F7F1E6FD}"/>
+                <a16:creationId xmlns:a16="http://schemas.microsoft.com/office/drawing/2014/main" id="{DD92CFDE-513B-4E27-91DD-F22AC7EB1382}"/>
               </a:ext>
             </a:extLst>
           </p:cNvPr>
@@ -5544,7 +5544,7 @@
           <p:cNvPr id="3" name="">
             <a:extLst xmlns:a="http://schemas.openxmlformats.org/drawingml/2006/main">
               <a:ext uri="{FF2B5EF4-FFF2-40B4-BE49-F238E27FC236}">
-                <a16:creationId xmlns:a16="http://schemas.microsoft.com/office/drawing/2014/main" id="{151F3C8F-105F-42D6-BFF7-9EC5EC90447C}"/>
+                <a16:creationId xmlns:a16="http://schemas.microsoft.com/office/drawing/2014/main" id="{FEFE8469-49AF-46E2-97DB-C344F84E0316}"/>
               </a:ext>
             </a:extLst>
           </p:cNvPr>
@@ -5610,7 +5610,7 @@
           <p:cNvPr id="4" name="">
             <a:extLst xmlns:a="http://schemas.openxmlformats.org/drawingml/2006/main">
               <a:ext uri="{FF2B5EF4-FFF2-40B4-BE49-F238E27FC236}">
-                <a16:creationId xmlns:a16="http://schemas.microsoft.com/office/drawing/2014/main" id="{74E25367-8263-4D7C-BFA6-30F75060AE8E}"/>
+                <a16:creationId xmlns:a16="http://schemas.microsoft.com/office/drawing/2014/main" id="{BA2316BF-5779-4C1C-994D-D4E36DA81657}"/>
               </a:ext>
             </a:extLst>
           </p:cNvPr>
@@ -5676,7 +5676,7 @@
           <p:cNvPr id="5" name="">
             <a:extLst xmlns:a="http://schemas.openxmlformats.org/drawingml/2006/main">
               <a:ext uri="{FF2B5EF4-FFF2-40B4-BE49-F238E27FC236}">
-                <a16:creationId xmlns:a16="http://schemas.microsoft.com/office/drawing/2014/main" id="{691935F1-5FBB-41B5-970D-F3D53B0C07AB}"/>
+                <a16:creationId xmlns:a16="http://schemas.microsoft.com/office/drawing/2014/main" id="{D1CBC48A-BA82-4C12-AF7E-461B47933B38}"/>
               </a:ext>
             </a:extLst>
           </p:cNvPr>
@@ -5742,7 +5742,7 @@
           <p:cNvPr id="6" name="">
             <a:extLst xmlns:a="http://schemas.openxmlformats.org/drawingml/2006/main">
               <a:ext uri="{FF2B5EF4-FFF2-40B4-BE49-F238E27FC236}">
-                <a16:creationId xmlns:a16="http://schemas.microsoft.com/office/drawing/2014/main" id="{5D76F164-2732-49F2-B3B6-D0C4B1264664}"/>
+                <a16:creationId xmlns:a16="http://schemas.microsoft.com/office/drawing/2014/main" id="{430F5CA6-6C7F-4107-9E3D-38E16F10FC81}"/>
               </a:ext>
             </a:extLst>
           </p:cNvPr>
@@ -5808,7 +5808,7 @@
           <p:cNvPr id="7" name="">
             <a:extLst xmlns:a="http://schemas.openxmlformats.org/drawingml/2006/main">
               <a:ext uri="{FF2B5EF4-FFF2-40B4-BE49-F238E27FC236}">
-                <a16:creationId xmlns:a16="http://schemas.microsoft.com/office/drawing/2014/main" id="{BA3848C4-5405-4524-8019-5241D56DB261}"/>
+                <a16:creationId xmlns:a16="http://schemas.microsoft.com/office/drawing/2014/main" id="{E5B8D8C0-C031-4B8F-9004-8F94EAD2A1E9}"/>
               </a:ext>
             </a:extLst>
           </p:cNvPr>
@@ -5874,7 +5874,7 @@
           <p:cNvPr id="8" name="">
             <a:extLst xmlns:a="http://schemas.openxmlformats.org/drawingml/2006/main">
               <a:ext uri="{FF2B5EF4-FFF2-40B4-BE49-F238E27FC236}">
-                <a16:creationId xmlns:a16="http://schemas.microsoft.com/office/drawing/2014/main" id="{EB463583-72BE-4B8E-B5B6-78BCF38D8A2D}"/>
+                <a16:creationId xmlns:a16="http://schemas.microsoft.com/office/drawing/2014/main" id="{874ADCCB-49CE-46BC-AF3A-E7B10FB2C329}"/>
               </a:ext>
             </a:extLst>
           </p:cNvPr>
@@ -5884,7 +5884,7 @@
           <p:nvPr/>
         </p:nvPicPr>
         <p:blipFill>
-          <a:blip xmlns:r="http://schemas.openxmlformats.org/officeDocument/2006/relationships" xmlns:a="http://schemas.openxmlformats.org/drawingml/2006/main" r:embed="Ree70096a6ec646b2"/>
+          <a:blip xmlns:r="http://schemas.openxmlformats.org/officeDocument/2006/relationships" xmlns:a="http://schemas.openxmlformats.org/drawingml/2006/main" r:embed="R45eeb282a0a44844"/>
           <a:stretch xmlns:a="http://schemas.openxmlformats.org/drawingml/2006/main"/>
         </p:blipFill>
         <p:spPr>
@@ -5902,7 +5902,7 @@
           <p:cNvPr id="9" name="">
             <a:extLst xmlns:a="http://schemas.openxmlformats.org/drawingml/2006/main">
               <a:ext uri="{FF2B5EF4-FFF2-40B4-BE49-F238E27FC236}">
-                <a16:creationId xmlns:a16="http://schemas.microsoft.com/office/drawing/2014/main" id="{241DC8EF-ED2F-4162-A9ED-731BC799865B}"/>
+                <a16:creationId xmlns:a16="http://schemas.microsoft.com/office/drawing/2014/main" id="{E1DA4ABB-F001-4E13-A24F-4D58D38755A4}"/>
               </a:ext>
             </a:extLst>
           </p:cNvPr>
@@ -5968,7 +5968,7 @@
           <p:cNvPr id="10" name="">
             <a:extLst xmlns:a="http://schemas.openxmlformats.org/drawingml/2006/main">
               <a:ext uri="{FF2B5EF4-FFF2-40B4-BE49-F238E27FC236}">
-                <a16:creationId xmlns:a16="http://schemas.microsoft.com/office/drawing/2014/main" id="{4F00BCD1-D4BC-4519-8A5E-F4B02DE83E85}"/>
+                <a16:creationId xmlns:a16="http://schemas.microsoft.com/office/drawing/2014/main" id="{CF9D8A64-7F30-4BB7-86EC-1F4F6D7BDF60}"/>
               </a:ext>
             </a:extLst>
           </p:cNvPr>
@@ -6032,7 +6032,7 @@
     </p:spTree>
     <p:extLst>
       <p:ext uri="{BB962C8B-B14F-4D97-AF65-F5344CB8AC3E}">
-        <p14:creationId xmlns:p14="http://schemas.microsoft.com/office/powerpoint/2010/main" val="2082033896"/>
+        <p14:creationId xmlns:p14="http://schemas.microsoft.com/office/powerpoint/2010/main" val="1191264114"/>
       </p:ext>
     </p:extLst>
   </p:cSld>
@@ -6063,7 +6063,7 @@
           <p:cNvPr id="11" name="">
             <a:extLst xmlns:a="http://schemas.openxmlformats.org/drawingml/2006/main">
               <a:ext uri="{FF2B5EF4-FFF2-40B4-BE49-F238E27FC236}">
-                <a16:creationId xmlns:a16="http://schemas.microsoft.com/office/drawing/2014/main" id="{3BBE9B2E-96E7-49A6-B521-1C95518B223D}"/>
+                <a16:creationId xmlns:a16="http://schemas.microsoft.com/office/drawing/2014/main" id="{98A2A228-1630-4049-B151-621E153A2C9F}"/>
               </a:ext>
             </a:extLst>
           </p:cNvPr>
@@ -6129,7 +6129,7 @@
           <p:cNvPr id="2" name="">
             <a:extLst xmlns:a="http://schemas.openxmlformats.org/drawingml/2006/main">
               <a:ext uri="{FF2B5EF4-FFF2-40B4-BE49-F238E27FC236}">
-                <a16:creationId xmlns:a16="http://schemas.microsoft.com/office/drawing/2014/main" id="{2D910211-3AC6-4B31-BE0F-9433E23A8121}"/>
+                <a16:creationId xmlns:a16="http://schemas.microsoft.com/office/drawing/2014/main" id="{A7FC9531-9383-44B3-9CFF-713AB192AF41}"/>
               </a:ext>
             </a:extLst>
           </p:cNvPr>
@@ -6195,7 +6195,7 @@
           <p:cNvPr id="3" name="">
             <a:extLst xmlns:a="http://schemas.openxmlformats.org/drawingml/2006/main">
               <a:ext uri="{FF2B5EF4-FFF2-40B4-BE49-F238E27FC236}">
-                <a16:creationId xmlns:a16="http://schemas.microsoft.com/office/drawing/2014/main" id="{9706D8B2-8DA7-4ABB-8207-93FACF67A7F7}"/>
+                <a16:creationId xmlns:a16="http://schemas.microsoft.com/office/drawing/2014/main" id="{B7C73164-BCF4-483F-B87E-1C9CF8230AE0}"/>
               </a:ext>
             </a:extLst>
           </p:cNvPr>
@@ -6261,7 +6261,7 @@
           <p:cNvPr id="4" name="">
             <a:extLst xmlns:a="http://schemas.openxmlformats.org/drawingml/2006/main">
               <a:ext uri="{FF2B5EF4-FFF2-40B4-BE49-F238E27FC236}">
-                <a16:creationId xmlns:a16="http://schemas.microsoft.com/office/drawing/2014/main" id="{C41CFC3B-B933-43DE-99F0-700375CF0D6E}"/>
+                <a16:creationId xmlns:a16="http://schemas.microsoft.com/office/drawing/2014/main" id="{B0716AAF-5773-48CB-AF2B-570FB78CC492}"/>
               </a:ext>
             </a:extLst>
           </p:cNvPr>
@@ -6327,7 +6327,7 @@
           <p:cNvPr id="5" name="">
             <a:extLst xmlns:a="http://schemas.openxmlformats.org/drawingml/2006/main">
               <a:ext uri="{FF2B5EF4-FFF2-40B4-BE49-F238E27FC236}">
-                <a16:creationId xmlns:a16="http://schemas.microsoft.com/office/drawing/2014/main" id="{0E7A4D05-EF7E-4B71-A066-C8F906DD96F7}"/>
+                <a16:creationId xmlns:a16="http://schemas.microsoft.com/office/drawing/2014/main" id="{BA0895D7-CE15-41D6-B073-1BA4914F264D}"/>
               </a:ext>
             </a:extLst>
           </p:cNvPr>
@@ -6393,7 +6393,7 @@
           <p:cNvPr id="6" name="">
             <a:extLst xmlns:a="http://schemas.openxmlformats.org/drawingml/2006/main">
               <a:ext uri="{FF2B5EF4-FFF2-40B4-BE49-F238E27FC236}">
-                <a16:creationId xmlns:a16="http://schemas.microsoft.com/office/drawing/2014/main" id="{5C2D05E0-0B89-4414-8954-D3D4A636A0DB}"/>
+                <a16:creationId xmlns:a16="http://schemas.microsoft.com/office/drawing/2014/main" id="{7302E995-6426-480D-89E1-702A8B3777A1}"/>
               </a:ext>
             </a:extLst>
           </p:cNvPr>
@@ -6403,7 +6403,7 @@
           <p:nvPr/>
         </p:nvPicPr>
         <p:blipFill>
-          <a:blip xmlns:r="http://schemas.openxmlformats.org/officeDocument/2006/relationships" xmlns:a="http://schemas.openxmlformats.org/drawingml/2006/main" r:embed="R5daef70d10d44d7a"/>
+          <a:blip xmlns:r="http://schemas.openxmlformats.org/officeDocument/2006/relationships" xmlns:a="http://schemas.openxmlformats.org/drawingml/2006/main" r:embed="R3706afdff328493f"/>
           <a:stretch xmlns:a="http://schemas.openxmlformats.org/drawingml/2006/main"/>
         </p:blipFill>
         <p:spPr>
@@ -6421,7 +6421,7 @@
           <p:cNvPr id="7" name="">
             <a:extLst xmlns:a="http://schemas.openxmlformats.org/drawingml/2006/main">
               <a:ext uri="{FF2B5EF4-FFF2-40B4-BE49-F238E27FC236}">
-                <a16:creationId xmlns:a16="http://schemas.microsoft.com/office/drawing/2014/main" id="{837BCCA0-373A-41A6-AE55-C2939DCD19BD}"/>
+                <a16:creationId xmlns:a16="http://schemas.microsoft.com/office/drawing/2014/main" id="{74268F1A-9343-40E3-AA38-0EFA676B7EA1}"/>
               </a:ext>
             </a:extLst>
           </p:cNvPr>
@@ -6487,7 +6487,7 @@
           <p:cNvPr id="8" name="">
             <a:extLst xmlns:a="http://schemas.openxmlformats.org/drawingml/2006/main">
               <a:ext uri="{FF2B5EF4-FFF2-40B4-BE49-F238E27FC236}">
-                <a16:creationId xmlns:a16="http://schemas.microsoft.com/office/drawing/2014/main" id="{DAEC3967-3B0E-4F63-9DC0-DDCBF9D4A7B4}"/>
+                <a16:creationId xmlns:a16="http://schemas.microsoft.com/office/drawing/2014/main" id="{18E29BCD-CDC2-4FF3-97D7-9005B3A95EBF}"/>
               </a:ext>
             </a:extLst>
           </p:cNvPr>
@@ -6553,7 +6553,7 @@
           <p:cNvPr id="9" name="">
             <a:extLst xmlns:a="http://schemas.openxmlformats.org/drawingml/2006/main">
               <a:ext uri="{FF2B5EF4-FFF2-40B4-BE49-F238E27FC236}">
-                <a16:creationId xmlns:a16="http://schemas.microsoft.com/office/drawing/2014/main" id="{7A1E505A-0579-4951-B9C5-FD2C30769260}"/>
+                <a16:creationId xmlns:a16="http://schemas.microsoft.com/office/drawing/2014/main" id="{16B1B5B7-FB24-4208-87D7-10048936F59C}"/>
               </a:ext>
             </a:extLst>
           </p:cNvPr>
@@ -6619,7 +6619,7 @@
           <p:cNvPr id="10" name="">
             <a:extLst xmlns:a="http://schemas.openxmlformats.org/drawingml/2006/main">
               <a:ext uri="{FF2B5EF4-FFF2-40B4-BE49-F238E27FC236}">
-                <a16:creationId xmlns:a16="http://schemas.microsoft.com/office/drawing/2014/main" id="{76616B19-8FA9-434E-A9DF-8065F6DCA424}"/>
+                <a16:creationId xmlns:a16="http://schemas.microsoft.com/office/drawing/2014/main" id="{C1D0297E-BCEF-4E2E-A986-520329CB4948}"/>
               </a:ext>
             </a:extLst>
           </p:cNvPr>
@@ -6683,7 +6683,7 @@
     </p:spTree>
     <p:extLst>
       <p:ext uri="{BB962C8B-B14F-4D97-AF65-F5344CB8AC3E}">
-        <p14:creationId xmlns:p14="http://schemas.microsoft.com/office/powerpoint/2010/main" val="1906150854"/>
+        <p14:creationId xmlns:p14="http://schemas.microsoft.com/office/powerpoint/2010/main" val="132547485"/>
       </p:ext>
     </p:extLst>
   </p:cSld>
@@ -6714,7 +6714,7 @@
           <p:cNvPr id="14" name="">
             <a:extLst xmlns:a="http://schemas.openxmlformats.org/drawingml/2006/main">
               <a:ext uri="{FF2B5EF4-FFF2-40B4-BE49-F238E27FC236}">
-                <a16:creationId xmlns:a16="http://schemas.microsoft.com/office/drawing/2014/main" id="{34BAB9DF-D172-47A7-8609-E2B59BEA4429}"/>
+                <a16:creationId xmlns:a16="http://schemas.microsoft.com/office/drawing/2014/main" id="{4619B1E8-EF91-44EA-8CFB-A260629C8AB7}"/>
               </a:ext>
             </a:extLst>
           </p:cNvPr>
@@ -6780,7 +6780,7 @@
           <p:cNvPr id="2" name="">
             <a:extLst xmlns:a="http://schemas.openxmlformats.org/drawingml/2006/main">
               <a:ext uri="{FF2B5EF4-FFF2-40B4-BE49-F238E27FC236}">
-                <a16:creationId xmlns:a16="http://schemas.microsoft.com/office/drawing/2014/main" id="{670C1AD2-7A7F-4BC6-8003-DF3046B8B7A8}"/>
+                <a16:creationId xmlns:a16="http://schemas.microsoft.com/office/drawing/2014/main" id="{CBB1BB01-F2AF-4CE9-86FD-29F960A54F54}"/>
               </a:ext>
             </a:extLst>
           </p:cNvPr>
@@ -6846,7 +6846,7 @@
           <p:cNvPr id="3" name="">
             <a:extLst xmlns:a="http://schemas.openxmlformats.org/drawingml/2006/main">
               <a:ext uri="{FF2B5EF4-FFF2-40B4-BE49-F238E27FC236}">
-                <a16:creationId xmlns:a16="http://schemas.microsoft.com/office/drawing/2014/main" id="{8E7DC1CB-1F14-45D5-9DE9-1E733785CA2E}"/>
+                <a16:creationId xmlns:a16="http://schemas.microsoft.com/office/drawing/2014/main" id="{9720F2CA-054E-4482-8726-C1C2337E7A64}"/>
               </a:ext>
             </a:extLst>
           </p:cNvPr>
@@ -6912,7 +6912,7 @@
           <p:cNvPr id="4" name="">
             <a:extLst xmlns:a="http://schemas.openxmlformats.org/drawingml/2006/main">
               <a:ext uri="{FF2B5EF4-FFF2-40B4-BE49-F238E27FC236}">
-                <a16:creationId xmlns:a16="http://schemas.microsoft.com/office/drawing/2014/main" id="{6E5B8A8D-ABB2-4962-BA25-FBD3C5EB1F01}"/>
+                <a16:creationId xmlns:a16="http://schemas.microsoft.com/office/drawing/2014/main" id="{BAFE58BB-B37B-495D-8E5F-3D90AC524DF3}"/>
               </a:ext>
             </a:extLst>
           </p:cNvPr>
@@ -6978,7 +6978,7 @@
           <p:cNvPr id="5" name="">
             <a:extLst xmlns:a="http://schemas.openxmlformats.org/drawingml/2006/main">
               <a:ext uri="{FF2B5EF4-FFF2-40B4-BE49-F238E27FC236}">
-                <a16:creationId xmlns:a16="http://schemas.microsoft.com/office/drawing/2014/main" id="{ABB43F49-C299-4AF9-8C81-4F1B16EE0D5F}"/>
+                <a16:creationId xmlns:a16="http://schemas.microsoft.com/office/drawing/2014/main" id="{FA655CB5-CF6E-4A5E-9586-62B485529CEF}"/>
               </a:ext>
             </a:extLst>
           </p:cNvPr>
@@ -7044,7 +7044,7 @@
           <p:cNvPr id="6" name="">
             <a:extLst xmlns:a="http://schemas.openxmlformats.org/drawingml/2006/main">
               <a:ext uri="{FF2B5EF4-FFF2-40B4-BE49-F238E27FC236}">
-                <a16:creationId xmlns:a16="http://schemas.microsoft.com/office/drawing/2014/main" id="{882A3C25-3BC6-4DF7-9604-569973E924EA}"/>
+                <a16:creationId xmlns:a16="http://schemas.microsoft.com/office/drawing/2014/main" id="{9E98A643-5B3D-481B-A8D9-C10A4E40682D}"/>
               </a:ext>
             </a:extLst>
           </p:cNvPr>
@@ -7110,7 +7110,7 @@
           <p:cNvPr id="7" name="">
             <a:extLst xmlns:a="http://schemas.openxmlformats.org/drawingml/2006/main">
               <a:ext uri="{FF2B5EF4-FFF2-40B4-BE49-F238E27FC236}">
-                <a16:creationId xmlns:a16="http://schemas.microsoft.com/office/drawing/2014/main" id="{BB811553-39CE-4138-B397-3C9ECC36794C}"/>
+                <a16:creationId xmlns:a16="http://schemas.microsoft.com/office/drawing/2014/main" id="{3140562A-8844-4971-908A-CAEE2FBD5A08}"/>
               </a:ext>
             </a:extLst>
           </p:cNvPr>
@@ -7176,7 +7176,7 @@
           <p:cNvPr id="8" name="">
             <a:extLst xmlns:a="http://schemas.openxmlformats.org/drawingml/2006/main">
               <a:ext uri="{FF2B5EF4-FFF2-40B4-BE49-F238E27FC236}">
-                <a16:creationId xmlns:a16="http://schemas.microsoft.com/office/drawing/2014/main" id="{35BC9CDA-8682-4AC3-A867-CEC9B3109074}"/>
+                <a16:creationId xmlns:a16="http://schemas.microsoft.com/office/drawing/2014/main" id="{855D9E66-E0DC-43CE-91F4-75FEBC7EE0D9}"/>
               </a:ext>
             </a:extLst>
           </p:cNvPr>
@@ -7242,7 +7242,7 @@
           <p:cNvPr id="9" name="">
             <a:extLst xmlns:a="http://schemas.openxmlformats.org/drawingml/2006/main">
               <a:ext uri="{FF2B5EF4-FFF2-40B4-BE49-F238E27FC236}">
-                <a16:creationId xmlns:a16="http://schemas.microsoft.com/office/drawing/2014/main" id="{0376EEB0-9035-4A2A-86E0-DCED333FF3D2}"/>
+                <a16:creationId xmlns:a16="http://schemas.microsoft.com/office/drawing/2014/main" id="{0DA2F8FD-840A-453E-B9C4-0CDCA21F07E0}"/>
               </a:ext>
             </a:extLst>
           </p:cNvPr>
@@ -7308,7 +7308,7 @@
           <p:cNvPr id="10" name="">
             <a:extLst xmlns:a="http://schemas.openxmlformats.org/drawingml/2006/main">
               <a:ext uri="{FF2B5EF4-FFF2-40B4-BE49-F238E27FC236}">
-                <a16:creationId xmlns:a16="http://schemas.microsoft.com/office/drawing/2014/main" id="{DD9007CD-12D8-416F-8815-1CC5D83D0175}"/>
+                <a16:creationId xmlns:a16="http://schemas.microsoft.com/office/drawing/2014/main" id="{C763B8C2-FE20-4D0E-B226-5A11E456B3BB}"/>
               </a:ext>
             </a:extLst>
           </p:cNvPr>
@@ -7374,7 +7374,7 @@
           <p:cNvPr id="11" name="">
             <a:extLst xmlns:a="http://schemas.openxmlformats.org/drawingml/2006/main">
               <a:ext uri="{FF2B5EF4-FFF2-40B4-BE49-F238E27FC236}">
-                <a16:creationId xmlns:a16="http://schemas.microsoft.com/office/drawing/2014/main" id="{6600F7A9-B291-4DA4-A3D1-AB259153AE64}"/>
+                <a16:creationId xmlns:a16="http://schemas.microsoft.com/office/drawing/2014/main" id="{9FAD829A-DBA2-442F-991B-C45DD02BA613}"/>
               </a:ext>
             </a:extLst>
           </p:cNvPr>
@@ -7440,7 +7440,7 @@
           <p:cNvPr id="12" name="">
             <a:extLst xmlns:a="http://schemas.openxmlformats.org/drawingml/2006/main">
               <a:ext uri="{FF2B5EF4-FFF2-40B4-BE49-F238E27FC236}">
-                <a16:creationId xmlns:a16="http://schemas.microsoft.com/office/drawing/2014/main" id="{02DA13C1-DB05-4A4C-B9AC-13D084ACDC87}"/>
+                <a16:creationId xmlns:a16="http://schemas.microsoft.com/office/drawing/2014/main" id="{81773871-9E9B-4B4D-989E-8BC51C05A10F}"/>
               </a:ext>
             </a:extLst>
           </p:cNvPr>
@@ -7506,7 +7506,7 @@
           <p:cNvPr id="13" name="">
             <a:extLst xmlns:a="http://schemas.openxmlformats.org/drawingml/2006/main">
               <a:ext uri="{FF2B5EF4-FFF2-40B4-BE49-F238E27FC236}">
-                <a16:creationId xmlns:a16="http://schemas.microsoft.com/office/drawing/2014/main" id="{AF2C784E-BB4E-47D0-A7F1-297B16ED2A57}"/>
+                <a16:creationId xmlns:a16="http://schemas.microsoft.com/office/drawing/2014/main" id="{25C99A48-6CA9-42EF-815E-32F40DA8B9FF}"/>
               </a:ext>
             </a:extLst>
           </p:cNvPr>
@@ -7570,7 +7570,7 @@
     </p:spTree>
     <p:extLst>
       <p:ext uri="{BB962C8B-B14F-4D97-AF65-F5344CB8AC3E}">
-        <p14:creationId xmlns:p14="http://schemas.microsoft.com/office/powerpoint/2010/main" val="941255786"/>
+        <p14:creationId xmlns:p14="http://schemas.microsoft.com/office/powerpoint/2010/main" val="1325832223"/>
       </p:ext>
     </p:extLst>
   </p:cSld>
@@ -7601,7 +7601,7 @@
           <p:cNvPr id="11" name="">
             <a:extLst xmlns:a="http://schemas.openxmlformats.org/drawingml/2006/main">
               <a:ext uri="{FF2B5EF4-FFF2-40B4-BE49-F238E27FC236}">
-                <a16:creationId xmlns:a16="http://schemas.microsoft.com/office/drawing/2014/main" id="{26B56F1C-50B0-43A1-AEEC-73268B7DF486}"/>
+                <a16:creationId xmlns:a16="http://schemas.microsoft.com/office/drawing/2014/main" id="{AE3695B0-0B38-4665-9786-FA4AE6C437D7}"/>
               </a:ext>
             </a:extLst>
           </p:cNvPr>
@@ -7667,7 +7667,7 @@
           <p:cNvPr id="2" name="">
             <a:extLst xmlns:a="http://schemas.openxmlformats.org/drawingml/2006/main">
               <a:ext uri="{FF2B5EF4-FFF2-40B4-BE49-F238E27FC236}">
-                <a16:creationId xmlns:a16="http://schemas.microsoft.com/office/drawing/2014/main" id="{9A7D91B5-9BAC-40B9-9F3D-2DBDED5D1CE7}"/>
+                <a16:creationId xmlns:a16="http://schemas.microsoft.com/office/drawing/2014/main" id="{FA603DA0-4426-48E9-AEB7-5B68DA98C044}"/>
               </a:ext>
             </a:extLst>
           </p:cNvPr>
@@ -7733,7 +7733,7 @@
           <p:cNvPr id="3" name="">
             <a:extLst xmlns:a="http://schemas.openxmlformats.org/drawingml/2006/main">
               <a:ext uri="{FF2B5EF4-FFF2-40B4-BE49-F238E27FC236}">
-                <a16:creationId xmlns:a16="http://schemas.microsoft.com/office/drawing/2014/main" id="{8A3175A6-B819-4100-B93C-B32DE57A92DF}"/>
+                <a16:creationId xmlns:a16="http://schemas.microsoft.com/office/drawing/2014/main" id="{1E6E5B01-6E13-4985-8DF9-28088C6B09F4}"/>
               </a:ext>
             </a:extLst>
           </p:cNvPr>
@@ -7799,7 +7799,7 @@
           <p:cNvPr id="4" name="">
             <a:extLst xmlns:a="http://schemas.openxmlformats.org/drawingml/2006/main">
               <a:ext uri="{FF2B5EF4-FFF2-40B4-BE49-F238E27FC236}">
-                <a16:creationId xmlns:a16="http://schemas.microsoft.com/office/drawing/2014/main" id="{916D9E96-639F-4A6F-874A-1BD0FBE07244}"/>
+                <a16:creationId xmlns:a16="http://schemas.microsoft.com/office/drawing/2014/main" id="{F5D8BDED-3563-4B4C-BC88-2C5E701DCE0F}"/>
               </a:ext>
             </a:extLst>
           </p:cNvPr>
@@ -7865,7 +7865,7 @@
           <p:cNvPr id="5" name="">
             <a:extLst xmlns:a="http://schemas.openxmlformats.org/drawingml/2006/main">
               <a:ext uri="{FF2B5EF4-FFF2-40B4-BE49-F238E27FC236}">
-                <a16:creationId xmlns:a16="http://schemas.microsoft.com/office/drawing/2014/main" id="{A3900B30-11F3-4694-9C8A-7D6A2DE03C2E}"/>
+                <a16:creationId xmlns:a16="http://schemas.microsoft.com/office/drawing/2014/main" id="{9836EF3B-2483-4B06-B215-692DDE96D9CA}"/>
               </a:ext>
             </a:extLst>
           </p:cNvPr>
@@ -7931,7 +7931,7 @@
           <p:cNvPr id="6" name="">
             <a:extLst xmlns:a="http://schemas.openxmlformats.org/drawingml/2006/main">
               <a:ext uri="{FF2B5EF4-FFF2-40B4-BE49-F238E27FC236}">
-                <a16:creationId xmlns:a16="http://schemas.microsoft.com/office/drawing/2014/main" id="{5619DE5D-ABDE-41E3-B08A-3ADE7358EC6E}"/>
+                <a16:creationId xmlns:a16="http://schemas.microsoft.com/office/drawing/2014/main" id="{8E35EBB7-E44D-4C88-87B7-F6F211A60F4E}"/>
               </a:ext>
             </a:extLst>
           </p:cNvPr>
@@ -7997,7 +7997,7 @@
           <p:cNvPr id="7" name="">
             <a:extLst xmlns:a="http://schemas.openxmlformats.org/drawingml/2006/main">
               <a:ext uri="{FF2B5EF4-FFF2-40B4-BE49-F238E27FC236}">
-                <a16:creationId xmlns:a16="http://schemas.microsoft.com/office/drawing/2014/main" id="{59EC34A6-A5E1-4868-806C-7996CB1446F8}"/>
+                <a16:creationId xmlns:a16="http://schemas.microsoft.com/office/drawing/2014/main" id="{9F119B9B-4D29-4869-9A32-1F60BD8290F8}"/>
               </a:ext>
             </a:extLst>
           </p:cNvPr>
@@ -8063,7 +8063,7 @@
           <p:cNvPr id="8" name="">
             <a:extLst xmlns:a="http://schemas.openxmlformats.org/drawingml/2006/main">
               <a:ext uri="{FF2B5EF4-FFF2-40B4-BE49-F238E27FC236}">
-                <a16:creationId xmlns:a16="http://schemas.microsoft.com/office/drawing/2014/main" id="{079585A3-8374-4E27-AB98-2F86B78F1E47}"/>
+                <a16:creationId xmlns:a16="http://schemas.microsoft.com/office/drawing/2014/main" id="{D7B70515-CD52-4E0E-9FA9-ED5B98C002D5}"/>
               </a:ext>
             </a:extLst>
           </p:cNvPr>
@@ -8073,7 +8073,7 @@
           <p:nvPr/>
         </p:nvPicPr>
         <p:blipFill>
-          <a:blip xmlns:r="http://schemas.openxmlformats.org/officeDocument/2006/relationships" xmlns:a="http://schemas.openxmlformats.org/drawingml/2006/main" r:embed="R46e8cd3468a3420d"/>
+          <a:blip xmlns:r="http://schemas.openxmlformats.org/officeDocument/2006/relationships" xmlns:a="http://schemas.openxmlformats.org/drawingml/2006/main" r:embed="Rdec16a3c682b4c6e"/>
           <a:stretch xmlns:a="http://schemas.openxmlformats.org/drawingml/2006/main"/>
         </p:blipFill>
         <p:spPr>
@@ -8091,7 +8091,7 @@
           <p:cNvPr id="9" name="">
             <a:extLst xmlns:a="http://schemas.openxmlformats.org/drawingml/2006/main">
               <a:ext uri="{FF2B5EF4-FFF2-40B4-BE49-F238E27FC236}">
-                <a16:creationId xmlns:a16="http://schemas.microsoft.com/office/drawing/2014/main" id="{7B12F4A7-AC9B-4941-A8DA-BAC80C41A753}"/>
+                <a16:creationId xmlns:a16="http://schemas.microsoft.com/office/drawing/2014/main" id="{B6740431-A415-47A6-8F56-B68404A6196D}"/>
               </a:ext>
             </a:extLst>
           </p:cNvPr>
@@ -8157,7 +8157,7 @@
           <p:cNvPr id="10" name="">
             <a:extLst xmlns:a="http://schemas.openxmlformats.org/drawingml/2006/main">
               <a:ext uri="{FF2B5EF4-FFF2-40B4-BE49-F238E27FC236}">
-                <a16:creationId xmlns:a16="http://schemas.microsoft.com/office/drawing/2014/main" id="{4FE8D09D-72E4-4E8E-94E6-0D5BDDC1F587}"/>
+                <a16:creationId xmlns:a16="http://schemas.microsoft.com/office/drawing/2014/main" id="{143AFC6D-BCDF-4C2F-BCE5-2F0C11E135B6}"/>
               </a:ext>
             </a:extLst>
           </p:cNvPr>
@@ -8221,7 +8221,7 @@
     </p:spTree>
     <p:extLst>
       <p:ext uri="{BB962C8B-B14F-4D97-AF65-F5344CB8AC3E}">
-        <p14:creationId xmlns:p14="http://schemas.microsoft.com/office/powerpoint/2010/main" val="1099204879"/>
+        <p14:creationId xmlns:p14="http://schemas.microsoft.com/office/powerpoint/2010/main" val="1223518463"/>
       </p:ext>
     </p:extLst>
   </p:cSld>
@@ -8252,7 +8252,7 @@
           <p:cNvPr id="13" name="">
             <a:extLst xmlns:a="http://schemas.openxmlformats.org/drawingml/2006/main">
               <a:ext uri="{FF2B5EF4-FFF2-40B4-BE49-F238E27FC236}">
-                <a16:creationId xmlns:a16="http://schemas.microsoft.com/office/drawing/2014/main" id="{348504DD-4AB8-4449-9C84-A4A369C8642C}"/>
+                <a16:creationId xmlns:a16="http://schemas.microsoft.com/office/drawing/2014/main" id="{0AC7F407-E23B-4390-9702-22853B8D5537}"/>
               </a:ext>
             </a:extLst>
           </p:cNvPr>
@@ -8318,7 +8318,7 @@
           <p:cNvPr id="2" name="">
             <a:extLst xmlns:a="http://schemas.openxmlformats.org/drawingml/2006/main">
               <a:ext uri="{FF2B5EF4-FFF2-40B4-BE49-F238E27FC236}">
-                <a16:creationId xmlns:a16="http://schemas.microsoft.com/office/drawing/2014/main" id="{B464EE6D-3689-4166-B4C5-652BE5F41EEA}"/>
+                <a16:creationId xmlns:a16="http://schemas.microsoft.com/office/drawing/2014/main" id="{10595255-70E4-47E3-978F-D78B1047BD16}"/>
               </a:ext>
             </a:extLst>
           </p:cNvPr>
@@ -8384,7 +8384,7 @@
           <p:cNvPr id="3" name="">
             <a:extLst xmlns:a="http://schemas.openxmlformats.org/drawingml/2006/main">
               <a:ext uri="{FF2B5EF4-FFF2-40B4-BE49-F238E27FC236}">
-                <a16:creationId xmlns:a16="http://schemas.microsoft.com/office/drawing/2014/main" id="{4F1070B2-02E8-4012-8F94-D45A01AB61CD}"/>
+                <a16:creationId xmlns:a16="http://schemas.microsoft.com/office/drawing/2014/main" id="{2C30EF64-58B2-48AA-B872-ABF8E2ADD88E}"/>
               </a:ext>
             </a:extLst>
           </p:cNvPr>
@@ -8450,7 +8450,7 @@
           <p:cNvPr id="4" name="">
             <a:extLst xmlns:a="http://schemas.openxmlformats.org/drawingml/2006/main">
               <a:ext uri="{FF2B5EF4-FFF2-40B4-BE49-F238E27FC236}">
-                <a16:creationId xmlns:a16="http://schemas.microsoft.com/office/drawing/2014/main" id="{D93C2BB7-681B-4717-B5B4-FFE286886B77}"/>
+                <a16:creationId xmlns:a16="http://schemas.microsoft.com/office/drawing/2014/main" id="{590446C1-62EA-4BFE-8EA6-9FDDC7922CAC}"/>
               </a:ext>
             </a:extLst>
           </p:cNvPr>
@@ -8516,7 +8516,7 @@
           <p:cNvPr id="5" name="">
             <a:extLst xmlns:a="http://schemas.openxmlformats.org/drawingml/2006/main">
               <a:ext uri="{FF2B5EF4-FFF2-40B4-BE49-F238E27FC236}">
-                <a16:creationId xmlns:a16="http://schemas.microsoft.com/office/drawing/2014/main" id="{3CFFC085-3426-4D9D-9966-2858DE581209}"/>
+                <a16:creationId xmlns:a16="http://schemas.microsoft.com/office/drawing/2014/main" id="{99F3016D-A306-4A32-BCEB-13BF3DBDD78D}"/>
               </a:ext>
             </a:extLst>
           </p:cNvPr>
@@ -8582,7 +8582,7 @@
           <p:cNvPr id="6" name="">
             <a:extLst xmlns:a="http://schemas.openxmlformats.org/drawingml/2006/main">
               <a:ext uri="{FF2B5EF4-FFF2-40B4-BE49-F238E27FC236}">
-                <a16:creationId xmlns:a16="http://schemas.microsoft.com/office/drawing/2014/main" id="{428210BB-E129-4B3A-BC3A-30EA0BB38DE0}"/>
+                <a16:creationId xmlns:a16="http://schemas.microsoft.com/office/drawing/2014/main" id="{28BA76EA-3EE6-40B3-AC28-821743F25E8A}"/>
               </a:ext>
             </a:extLst>
           </p:cNvPr>
@@ -8763,7 +8763,7 @@
           <p:cNvPr id="7" name="">
             <a:extLst xmlns:a="http://schemas.openxmlformats.org/drawingml/2006/main">
               <a:ext uri="{FF2B5EF4-FFF2-40B4-BE49-F238E27FC236}">
-                <a16:creationId xmlns:a16="http://schemas.microsoft.com/office/drawing/2014/main" id="{312B2AE4-287C-4370-8E80-D7F5632B7636}"/>
+                <a16:creationId xmlns:a16="http://schemas.microsoft.com/office/drawing/2014/main" id="{B10AF9ED-3627-4EA3-803A-B2913BF20851}"/>
               </a:ext>
             </a:extLst>
           </p:cNvPr>
@@ -8829,7 +8829,7 @@
           <p:cNvPr id="8" name="">
             <a:extLst xmlns:a="http://schemas.openxmlformats.org/drawingml/2006/main">
               <a:ext uri="{FF2B5EF4-FFF2-40B4-BE49-F238E27FC236}">
-                <a16:creationId xmlns:a16="http://schemas.microsoft.com/office/drawing/2014/main" id="{FBEB4DF5-7DE0-436B-828D-C333921C650F}"/>
+                <a16:creationId xmlns:a16="http://schemas.microsoft.com/office/drawing/2014/main" id="{231B2079-9424-4D70-A4B2-B733B36F49EE}"/>
               </a:ext>
             </a:extLst>
           </p:cNvPr>
@@ -8895,7 +8895,7 @@
           <p:cNvPr id="9" name="">
             <a:extLst xmlns:a="http://schemas.openxmlformats.org/drawingml/2006/main">
               <a:ext uri="{FF2B5EF4-FFF2-40B4-BE49-F238E27FC236}">
-                <a16:creationId xmlns:a16="http://schemas.microsoft.com/office/drawing/2014/main" id="{03ABA151-4441-4C6F-8B6D-EF45662A498F}"/>
+                <a16:creationId xmlns:a16="http://schemas.microsoft.com/office/drawing/2014/main" id="{AC64C9AA-2434-4F0B-998E-81DD3B3CC77B}"/>
               </a:ext>
             </a:extLst>
           </p:cNvPr>
@@ -8961,7 +8961,7 @@
           <p:cNvPr id="10" name="">
             <a:extLst xmlns:a="http://schemas.openxmlformats.org/drawingml/2006/main">
               <a:ext uri="{FF2B5EF4-FFF2-40B4-BE49-F238E27FC236}">
-                <a16:creationId xmlns:a16="http://schemas.microsoft.com/office/drawing/2014/main" id="{312E55D4-7563-4ABE-8200-6685478EB5E9}"/>
+                <a16:creationId xmlns:a16="http://schemas.microsoft.com/office/drawing/2014/main" id="{E4E1D78D-586E-4BD2-B4F9-064E35BD6C01}"/>
               </a:ext>
             </a:extLst>
           </p:cNvPr>
@@ -9050,7 +9050,7 @@
           <p:cNvPr id="11" name="">
             <a:extLst xmlns:a="http://schemas.openxmlformats.org/drawingml/2006/main">
               <a:ext uri="{FF2B5EF4-FFF2-40B4-BE49-F238E27FC236}">
-                <a16:creationId xmlns:a16="http://schemas.microsoft.com/office/drawing/2014/main" id="{88145F2C-C822-43ED-8BF0-67E0BE8EACA3}"/>
+                <a16:creationId xmlns:a16="http://schemas.microsoft.com/office/drawing/2014/main" id="{F388E700-3764-4988-9E96-E8E2868B5FD7}"/>
               </a:ext>
             </a:extLst>
           </p:cNvPr>
@@ -9116,7 +9116,7 @@
           <p:cNvPr id="12" name="">
             <a:extLst xmlns:a="http://schemas.openxmlformats.org/drawingml/2006/main">
               <a:ext uri="{FF2B5EF4-FFF2-40B4-BE49-F238E27FC236}">
-                <a16:creationId xmlns:a16="http://schemas.microsoft.com/office/drawing/2014/main" id="{E2D368C9-7E41-43E8-8BD6-F710740C02A9}"/>
+                <a16:creationId xmlns:a16="http://schemas.microsoft.com/office/drawing/2014/main" id="{FB8EB71B-790C-4F17-9333-E937FBEEC4D2}"/>
               </a:ext>
             </a:extLst>
           </p:cNvPr>
@@ -9203,7 +9203,7 @@
     </p:spTree>
     <p:extLst>
       <p:ext uri="{BB962C8B-B14F-4D97-AF65-F5344CB8AC3E}">
-        <p14:creationId xmlns:p14="http://schemas.microsoft.com/office/powerpoint/2010/main" val="1229511265"/>
+        <p14:creationId xmlns:p14="http://schemas.microsoft.com/office/powerpoint/2010/main" val="1507677115"/>
       </p:ext>
     </p:extLst>
   </p:cSld>
@@ -9234,7 +9234,7 @@
           <p:cNvPr id="13" name="">
             <a:extLst xmlns:a="http://schemas.openxmlformats.org/drawingml/2006/main">
               <a:ext uri="{FF2B5EF4-FFF2-40B4-BE49-F238E27FC236}">
-                <a16:creationId xmlns:a16="http://schemas.microsoft.com/office/drawing/2014/main" id="{6E3DA8B0-A308-43D1-837A-C839BC174AC1}"/>
+                <a16:creationId xmlns:a16="http://schemas.microsoft.com/office/drawing/2014/main" id="{1F31132B-C404-426A-B441-5A8B835385AB}"/>
               </a:ext>
             </a:extLst>
           </p:cNvPr>
@@ -9300,7 +9300,7 @@
           <p:cNvPr id="2" name="">
             <a:extLst xmlns:a="http://schemas.openxmlformats.org/drawingml/2006/main">
               <a:ext uri="{FF2B5EF4-FFF2-40B4-BE49-F238E27FC236}">
-                <a16:creationId xmlns:a16="http://schemas.microsoft.com/office/drawing/2014/main" id="{0DB732EA-6AB6-4BFA-954F-1368F81F89CE}"/>
+                <a16:creationId xmlns:a16="http://schemas.microsoft.com/office/drawing/2014/main" id="{D05BD5E3-5BDA-48F8-A9EC-E046C6B2450C}"/>
               </a:ext>
             </a:extLst>
           </p:cNvPr>
@@ -9366,7 +9366,7 @@
           <p:cNvPr id="3" name="">
             <a:extLst xmlns:a="http://schemas.openxmlformats.org/drawingml/2006/main">
               <a:ext uri="{FF2B5EF4-FFF2-40B4-BE49-F238E27FC236}">
-                <a16:creationId xmlns:a16="http://schemas.microsoft.com/office/drawing/2014/main" id="{8666CC0B-A786-4C0F-8174-7747855D6BED}"/>
+                <a16:creationId xmlns:a16="http://schemas.microsoft.com/office/drawing/2014/main" id="{45D93BD6-3161-47B5-A2C1-9AB67C4509D1}"/>
               </a:ext>
             </a:extLst>
           </p:cNvPr>
@@ -9432,7 +9432,7 @@
           <p:cNvPr id="4" name="">
             <a:extLst xmlns:a="http://schemas.openxmlformats.org/drawingml/2006/main">
               <a:ext uri="{FF2B5EF4-FFF2-40B4-BE49-F238E27FC236}">
-                <a16:creationId xmlns:a16="http://schemas.microsoft.com/office/drawing/2014/main" id="{2FC3B4F1-0E3D-4C7A-BE1D-DF221B6A47A6}"/>
+                <a16:creationId xmlns:a16="http://schemas.microsoft.com/office/drawing/2014/main" id="{6DDFE3B0-776F-4F4C-8A59-246125352B5E}"/>
               </a:ext>
             </a:extLst>
           </p:cNvPr>
@@ -9498,7 +9498,7 @@
           <p:cNvPr id="5" name="">
             <a:extLst xmlns:a="http://schemas.openxmlformats.org/drawingml/2006/main">
               <a:ext uri="{FF2B5EF4-FFF2-40B4-BE49-F238E27FC236}">
-                <a16:creationId xmlns:a16="http://schemas.microsoft.com/office/drawing/2014/main" id="{4B61E852-6477-495A-B20F-CE6174F2A6C7}"/>
+                <a16:creationId xmlns:a16="http://schemas.microsoft.com/office/drawing/2014/main" id="{6A57C311-0F8F-477D-899A-D9EFA6858FE9}"/>
               </a:ext>
             </a:extLst>
           </p:cNvPr>
@@ -9564,7 +9564,7 @@
           <p:cNvPr id="6" name="">
             <a:extLst xmlns:a="http://schemas.openxmlformats.org/drawingml/2006/main">
               <a:ext uri="{FF2B5EF4-FFF2-40B4-BE49-F238E27FC236}">
-                <a16:creationId xmlns:a16="http://schemas.microsoft.com/office/drawing/2014/main" id="{1C95667C-6273-4FF0-AC6F-958065042C59}"/>
+                <a16:creationId xmlns:a16="http://schemas.microsoft.com/office/drawing/2014/main" id="{245F47AB-D9CF-423F-80BC-6F9D2A60385B}"/>
               </a:ext>
             </a:extLst>
           </p:cNvPr>
@@ -9630,7 +9630,7 @@
           <p:cNvPr id="7" name="">
             <a:extLst xmlns:a="http://schemas.openxmlformats.org/drawingml/2006/main">
               <a:ext uri="{FF2B5EF4-FFF2-40B4-BE49-F238E27FC236}">
-                <a16:creationId xmlns:a16="http://schemas.microsoft.com/office/drawing/2014/main" id="{8E5AA1CC-B213-47FA-B913-F0C7D6E2C176}"/>
+                <a16:creationId xmlns:a16="http://schemas.microsoft.com/office/drawing/2014/main" id="{E82CF6CD-ECCC-473E-A71A-6BED40B5CF0A}"/>
               </a:ext>
             </a:extLst>
           </p:cNvPr>
@@ -9686,7 +9686,7 @@
                 <a:ea typeface="Arial"/>
                 <a:cs typeface="Arial"/>
               </a:rPr>
-              <a:t>Clone the Enzora repository and install its API/web dependencies. Follow each model’s environment requirements. Phenom inference also requires its checkpoint, ESMC and MolT5 resources. Enzora does not distribute all model weights.</a:t>
+              <a:t>Clone the Enzora repository and install its API/web dependencies. Follow each model’s environment requirements. PHENOM inference also requires its checkpoint, ESMC and MolT5 resources. Enzora does not distribute all model weights.</a:t>
             </a:r>
           </a:p>
         </p:txBody>
@@ -9696,7 +9696,7 @@
           <p:cNvPr id="8" name="">
             <a:extLst xmlns:a="http://schemas.openxmlformats.org/drawingml/2006/main">
               <a:ext uri="{FF2B5EF4-FFF2-40B4-BE49-F238E27FC236}">
-                <a16:creationId xmlns:a16="http://schemas.microsoft.com/office/drawing/2014/main" id="{C77BC0B6-9652-4270-B204-C120639C07EA}"/>
+                <a16:creationId xmlns:a16="http://schemas.microsoft.com/office/drawing/2014/main" id="{9B1E1AFB-EB7F-4F6B-8AFF-B7FDA2F667A1}"/>
               </a:ext>
             </a:extLst>
           </p:cNvPr>
@@ -9882,7 +9882,7 @@
           <p:cNvPr id="9" name="">
             <a:extLst xmlns:a="http://schemas.openxmlformats.org/drawingml/2006/main">
               <a:ext uri="{FF2B5EF4-FFF2-40B4-BE49-F238E27FC236}">
-                <a16:creationId xmlns:a16="http://schemas.microsoft.com/office/drawing/2014/main" id="{B05B9E1F-E7A0-4004-82D3-3CCE5C36F4B3}"/>
+                <a16:creationId xmlns:a16="http://schemas.microsoft.com/office/drawing/2014/main" id="{D908574B-31F1-412E-A064-275C70A90FA6}"/>
               </a:ext>
             </a:extLst>
           </p:cNvPr>
@@ -9948,7 +9948,7 @@
           <p:cNvPr id="10" name="">
             <a:extLst xmlns:a="http://schemas.openxmlformats.org/drawingml/2006/main">
               <a:ext uri="{FF2B5EF4-FFF2-40B4-BE49-F238E27FC236}">
-                <a16:creationId xmlns:a16="http://schemas.microsoft.com/office/drawing/2014/main" id="{BBFB3862-BED5-4332-880E-44C0B32B4397}"/>
+                <a16:creationId xmlns:a16="http://schemas.microsoft.com/office/drawing/2014/main" id="{125C91FD-B082-4807-B1E7-C1395E46BB82}"/>
               </a:ext>
             </a:extLst>
           </p:cNvPr>
@@ -10014,7 +10014,7 @@
           <p:cNvPr id="11" name="">
             <a:extLst xmlns:a="http://schemas.openxmlformats.org/drawingml/2006/main">
               <a:ext uri="{FF2B5EF4-FFF2-40B4-BE49-F238E27FC236}">
-                <a16:creationId xmlns:a16="http://schemas.microsoft.com/office/drawing/2014/main" id="{A1D640AD-9EFE-47BC-9CF1-1348B483644E}"/>
+                <a16:creationId xmlns:a16="http://schemas.microsoft.com/office/drawing/2014/main" id="{4D8462D6-8BF7-44FC-8653-6737D31E9DA1}"/>
               </a:ext>
             </a:extLst>
           </p:cNvPr>
@@ -10080,7 +10080,7 @@
           <p:cNvPr id="12" name="">
             <a:extLst xmlns:a="http://schemas.openxmlformats.org/drawingml/2006/main">
               <a:ext uri="{FF2B5EF4-FFF2-40B4-BE49-F238E27FC236}">
-                <a16:creationId xmlns:a16="http://schemas.microsoft.com/office/drawing/2014/main" id="{C93E51FB-7269-4BD7-B7E5-1963DAE26122}"/>
+                <a16:creationId xmlns:a16="http://schemas.microsoft.com/office/drawing/2014/main" id="{B773D354-DA11-4584-A5B7-038E108437E9}"/>
               </a:ext>
             </a:extLst>
           </p:cNvPr>
@@ -10144,7 +10144,7 @@
     </p:spTree>
     <p:extLst>
       <p:ext uri="{BB962C8B-B14F-4D97-AF65-F5344CB8AC3E}">
-        <p14:creationId xmlns:p14="http://schemas.microsoft.com/office/powerpoint/2010/main" val="1756105048"/>
+        <p14:creationId xmlns:p14="http://schemas.microsoft.com/office/powerpoint/2010/main" val="1370598014"/>
       </p:ext>
     </p:extLst>
   </p:cSld>
@@ -10175,7 +10175,7 @@
           <p:cNvPr id="20" name="">
             <a:extLst xmlns:a="http://schemas.openxmlformats.org/drawingml/2006/main">
               <a:ext uri="{FF2B5EF4-FFF2-40B4-BE49-F238E27FC236}">
-                <a16:creationId xmlns:a16="http://schemas.microsoft.com/office/drawing/2014/main" id="{04229F78-0BAD-4F8F-B6C2-407D3B7A0255}"/>
+                <a16:creationId xmlns:a16="http://schemas.microsoft.com/office/drawing/2014/main" id="{B540A53F-5D62-420C-A37E-58A62EE3FE9F}"/>
               </a:ext>
             </a:extLst>
           </p:cNvPr>
@@ -10241,7 +10241,7 @@
           <p:cNvPr id="2" name="">
             <a:extLst xmlns:a="http://schemas.openxmlformats.org/drawingml/2006/main">
               <a:ext uri="{FF2B5EF4-FFF2-40B4-BE49-F238E27FC236}">
-                <a16:creationId xmlns:a16="http://schemas.microsoft.com/office/drawing/2014/main" id="{6ABD0D1A-B9EB-4C42-A52C-5BDF6B10B736}"/>
+                <a16:creationId xmlns:a16="http://schemas.microsoft.com/office/drawing/2014/main" id="{831ABBA9-2274-42D2-BD98-339D2C371EA2}"/>
               </a:ext>
             </a:extLst>
           </p:cNvPr>
@@ -10307,7 +10307,7 @@
           <p:cNvPr id="3" name="">
             <a:extLst xmlns:a="http://schemas.openxmlformats.org/drawingml/2006/main">
               <a:ext uri="{FF2B5EF4-FFF2-40B4-BE49-F238E27FC236}">
-                <a16:creationId xmlns:a16="http://schemas.microsoft.com/office/drawing/2014/main" id="{6464EE5D-A047-47EB-9C3E-184FDD0673A9}"/>
+                <a16:creationId xmlns:a16="http://schemas.microsoft.com/office/drawing/2014/main" id="{435836F5-B275-4B41-B285-26E4D705CB66}"/>
               </a:ext>
             </a:extLst>
           </p:cNvPr>
@@ -10373,7 +10373,7 @@
           <p:cNvPr id="4" name="">
             <a:extLst xmlns:a="http://schemas.openxmlformats.org/drawingml/2006/main">
               <a:ext uri="{FF2B5EF4-FFF2-40B4-BE49-F238E27FC236}">
-                <a16:creationId xmlns:a16="http://schemas.microsoft.com/office/drawing/2014/main" id="{766979D0-F68F-4C7D-8261-CB1487BBAE4C}"/>
+                <a16:creationId xmlns:a16="http://schemas.microsoft.com/office/drawing/2014/main" id="{53D2EC46-9CC1-435F-82C7-7F9BEB05DBC8}"/>
               </a:ext>
             </a:extLst>
           </p:cNvPr>
@@ -10439,7 +10439,7 @@
           <p:cNvPr id="5" name="">
             <a:extLst xmlns:a="http://schemas.openxmlformats.org/drawingml/2006/main">
               <a:ext uri="{FF2B5EF4-FFF2-40B4-BE49-F238E27FC236}">
-                <a16:creationId xmlns:a16="http://schemas.microsoft.com/office/drawing/2014/main" id="{E5230D41-9C75-4142-A15B-BB006BBC924E}"/>
+                <a16:creationId xmlns:a16="http://schemas.microsoft.com/office/drawing/2014/main" id="{0A722599-D137-4EF8-A02C-0AB9D6C472C0}"/>
               </a:ext>
             </a:extLst>
           </p:cNvPr>
@@ -10505,7 +10505,7 @@
           <p:cNvPr id="6" name="">
             <a:extLst xmlns:a="http://schemas.openxmlformats.org/drawingml/2006/main">
               <a:ext uri="{FF2B5EF4-FFF2-40B4-BE49-F238E27FC236}">
-                <a16:creationId xmlns:a16="http://schemas.microsoft.com/office/drawing/2014/main" id="{13C786F4-A616-4A38-9BB3-48691CDE7E13}"/>
+                <a16:creationId xmlns:a16="http://schemas.microsoft.com/office/drawing/2014/main" id="{E8F5457D-D879-442F-A754-2D1E2DCEAF80}"/>
               </a:ext>
             </a:extLst>
           </p:cNvPr>
@@ -10571,7 +10571,7 @@
           <p:cNvPr id="7" name="">
             <a:extLst xmlns:a="http://schemas.openxmlformats.org/drawingml/2006/main">
               <a:ext uri="{FF2B5EF4-FFF2-40B4-BE49-F238E27FC236}">
-                <a16:creationId xmlns:a16="http://schemas.microsoft.com/office/drawing/2014/main" id="{066B2C86-ECA3-421E-9A4F-E4D57B4FF73F}"/>
+                <a16:creationId xmlns:a16="http://schemas.microsoft.com/office/drawing/2014/main" id="{38221C96-3963-4361-89E2-CAC7118EAE26}"/>
               </a:ext>
             </a:extLst>
           </p:cNvPr>
@@ -10637,7 +10637,7 @@
           <p:cNvPr id="8" name="">
             <a:extLst xmlns:a="http://schemas.openxmlformats.org/drawingml/2006/main">
               <a:ext uri="{FF2B5EF4-FFF2-40B4-BE49-F238E27FC236}">
-                <a16:creationId xmlns:a16="http://schemas.microsoft.com/office/drawing/2014/main" id="{C337EC9B-AB75-4D4F-81A5-79C9D9476F13}"/>
+                <a16:creationId xmlns:a16="http://schemas.microsoft.com/office/drawing/2014/main" id="{5624A616-B819-4C11-A1ED-136C9BAC95CC}"/>
               </a:ext>
             </a:extLst>
           </p:cNvPr>
@@ -10703,7 +10703,7 @@
           <p:cNvPr id="9" name="">
             <a:extLst xmlns:a="http://schemas.openxmlformats.org/drawingml/2006/main">
               <a:ext uri="{FF2B5EF4-FFF2-40B4-BE49-F238E27FC236}">
-                <a16:creationId xmlns:a16="http://schemas.microsoft.com/office/drawing/2014/main" id="{DB78CF37-1865-45C6-BAEC-07998C8BC6CE}"/>
+                <a16:creationId xmlns:a16="http://schemas.microsoft.com/office/drawing/2014/main" id="{6304D7DF-EFD2-4A1B-9326-F345659FD0BF}"/>
               </a:ext>
             </a:extLst>
           </p:cNvPr>
@@ -10769,7 +10769,7 @@
           <p:cNvPr id="10" name="">
             <a:extLst xmlns:a="http://schemas.openxmlformats.org/drawingml/2006/main">
               <a:ext uri="{FF2B5EF4-FFF2-40B4-BE49-F238E27FC236}">
-                <a16:creationId xmlns:a16="http://schemas.microsoft.com/office/drawing/2014/main" id="{5FA904FA-61A3-49D7-A565-56C98B52DCD6}"/>
+                <a16:creationId xmlns:a16="http://schemas.microsoft.com/office/drawing/2014/main" id="{4494F44A-C75F-4E6F-AF8B-A110A91AAFF9}"/>
               </a:ext>
             </a:extLst>
           </p:cNvPr>
@@ -10835,7 +10835,7 @@
           <p:cNvPr id="11" name="">
             <a:extLst xmlns:a="http://schemas.openxmlformats.org/drawingml/2006/main">
               <a:ext uri="{FF2B5EF4-FFF2-40B4-BE49-F238E27FC236}">
-                <a16:creationId xmlns:a16="http://schemas.microsoft.com/office/drawing/2014/main" id="{75358021-E1A1-4D4A-BE23-57AEBC6B6F75}"/>
+                <a16:creationId xmlns:a16="http://schemas.microsoft.com/office/drawing/2014/main" id="{3EF04CCB-117E-4123-B4A4-5D93A06DDD93}"/>
               </a:ext>
             </a:extLst>
           </p:cNvPr>
@@ -10901,7 +10901,7 @@
           <p:cNvPr id="12" name="">
             <a:extLst xmlns:a="http://schemas.openxmlformats.org/drawingml/2006/main">
               <a:ext uri="{FF2B5EF4-FFF2-40B4-BE49-F238E27FC236}">
-                <a16:creationId xmlns:a16="http://schemas.microsoft.com/office/drawing/2014/main" id="{A87E44A5-E974-4D98-B876-3DCB94522A99}"/>
+                <a16:creationId xmlns:a16="http://schemas.microsoft.com/office/drawing/2014/main" id="{82BE1D2E-09C3-499A-86EF-31A267FFC99D}"/>
               </a:ext>
             </a:extLst>
           </p:cNvPr>
@@ -10967,7 +10967,7 @@
           <p:cNvPr id="13" name="">
             <a:extLst xmlns:a="http://schemas.openxmlformats.org/drawingml/2006/main">
               <a:ext uri="{FF2B5EF4-FFF2-40B4-BE49-F238E27FC236}">
-                <a16:creationId xmlns:a16="http://schemas.microsoft.com/office/drawing/2014/main" id="{DC161519-255D-4D31-BB26-CC14A5E83F46}"/>
+                <a16:creationId xmlns:a16="http://schemas.microsoft.com/office/drawing/2014/main" id="{D6C08764-6E52-42A0-BC11-DE7B7D294564}"/>
               </a:ext>
             </a:extLst>
           </p:cNvPr>
@@ -11033,7 +11033,7 @@
           <p:cNvPr id="14" name="">
             <a:extLst xmlns:a="http://schemas.openxmlformats.org/drawingml/2006/main">
               <a:ext uri="{FF2B5EF4-FFF2-40B4-BE49-F238E27FC236}">
-                <a16:creationId xmlns:a16="http://schemas.microsoft.com/office/drawing/2014/main" id="{715AF2CD-E0A1-4045-B2E3-D02534336B04}"/>
+                <a16:creationId xmlns:a16="http://schemas.microsoft.com/office/drawing/2014/main" id="{9DED8033-BEFA-4251-98E6-86B3813CABF0}"/>
               </a:ext>
             </a:extLst>
           </p:cNvPr>
@@ -11099,7 +11099,7 @@
           <p:cNvPr id="15" name="">
             <a:extLst xmlns:a="http://schemas.openxmlformats.org/drawingml/2006/main">
               <a:ext uri="{FF2B5EF4-FFF2-40B4-BE49-F238E27FC236}">
-                <a16:creationId xmlns:a16="http://schemas.microsoft.com/office/drawing/2014/main" id="{FE4AA275-B467-4A95-8210-EC57A8539BD0}"/>
+                <a16:creationId xmlns:a16="http://schemas.microsoft.com/office/drawing/2014/main" id="{CB7F664E-ECB2-46B7-AA5F-C8CAE1291875}"/>
               </a:ext>
             </a:extLst>
           </p:cNvPr>
@@ -11165,7 +11165,7 @@
           <p:cNvPr id="16" name="">
             <a:extLst xmlns:a="http://schemas.openxmlformats.org/drawingml/2006/main">
               <a:ext uri="{FF2B5EF4-FFF2-40B4-BE49-F238E27FC236}">
-                <a16:creationId xmlns:a16="http://schemas.microsoft.com/office/drawing/2014/main" id="{0531E875-D90C-4526-83B0-87AFC34C1600}"/>
+                <a16:creationId xmlns:a16="http://schemas.microsoft.com/office/drawing/2014/main" id="{D767DA03-8D61-47A0-A644-05ADFBD4AEDA}"/>
               </a:ext>
             </a:extLst>
           </p:cNvPr>
@@ -11231,7 +11231,7 @@
           <p:cNvPr id="17" name="">
             <a:extLst xmlns:a="http://schemas.openxmlformats.org/drawingml/2006/main">
               <a:ext uri="{FF2B5EF4-FFF2-40B4-BE49-F238E27FC236}">
-                <a16:creationId xmlns:a16="http://schemas.microsoft.com/office/drawing/2014/main" id="{5324AEA5-E8D2-4594-9A64-DE44FE4120D9}"/>
+                <a16:creationId xmlns:a16="http://schemas.microsoft.com/office/drawing/2014/main" id="{F511E015-2D9C-4A74-BB78-88DACB17A366}"/>
               </a:ext>
             </a:extLst>
           </p:cNvPr>
@@ -11297,7 +11297,7 @@
           <p:cNvPr id="18" name="">
             <a:extLst xmlns:a="http://schemas.openxmlformats.org/drawingml/2006/main">
               <a:ext uri="{FF2B5EF4-FFF2-40B4-BE49-F238E27FC236}">
-                <a16:creationId xmlns:a16="http://schemas.microsoft.com/office/drawing/2014/main" id="{10629A2C-E438-4140-94CF-5AE96FA2CDB4}"/>
+                <a16:creationId xmlns:a16="http://schemas.microsoft.com/office/drawing/2014/main" id="{21D62D41-8692-4944-8040-5BDFF2956121}"/>
               </a:ext>
             </a:extLst>
           </p:cNvPr>
@@ -11363,7 +11363,7 @@
           <p:cNvPr id="19" name="">
             <a:extLst xmlns:a="http://schemas.openxmlformats.org/drawingml/2006/main">
               <a:ext uri="{FF2B5EF4-FFF2-40B4-BE49-F238E27FC236}">
-                <a16:creationId xmlns:a16="http://schemas.microsoft.com/office/drawing/2014/main" id="{4FFEE69E-9BB4-4457-B4FD-72BADE9877BC}"/>
+                <a16:creationId xmlns:a16="http://schemas.microsoft.com/office/drawing/2014/main" id="{A7DC63F3-47C9-419C-B29C-E1FCE6E64D8D}"/>
               </a:ext>
             </a:extLst>
           </p:cNvPr>
@@ -11427,7 +11427,7 @@
     </p:spTree>
     <p:extLst>
       <p:ext uri="{BB962C8B-B14F-4D97-AF65-F5344CB8AC3E}">
-        <p14:creationId xmlns:p14="http://schemas.microsoft.com/office/powerpoint/2010/main" val="1919338852"/>
+        <p14:creationId xmlns:p14="http://schemas.microsoft.com/office/powerpoint/2010/main" val="1494989296"/>
       </p:ext>
     </p:extLst>
   </p:cSld>
@@ -11458,7 +11458,7 @@
           <p:cNvPr id="12" name="">
             <a:extLst xmlns:a="http://schemas.openxmlformats.org/drawingml/2006/main">
               <a:ext uri="{FF2B5EF4-FFF2-40B4-BE49-F238E27FC236}">
-                <a16:creationId xmlns:a16="http://schemas.microsoft.com/office/drawing/2014/main" id="{6EF21234-D3E7-4BD2-AB37-0F843C3FEFAD}"/>
+                <a16:creationId xmlns:a16="http://schemas.microsoft.com/office/drawing/2014/main" id="{A8B5A167-0332-42B4-A050-C430C0657408}"/>
               </a:ext>
             </a:extLst>
           </p:cNvPr>
@@ -11524,7 +11524,7 @@
           <p:cNvPr id="2" name="">
             <a:extLst xmlns:a="http://schemas.openxmlformats.org/drawingml/2006/main">
               <a:ext uri="{FF2B5EF4-FFF2-40B4-BE49-F238E27FC236}">
-                <a16:creationId xmlns:a16="http://schemas.microsoft.com/office/drawing/2014/main" id="{B9D4B458-D681-47AF-B89E-88184ABF8325}"/>
+                <a16:creationId xmlns:a16="http://schemas.microsoft.com/office/drawing/2014/main" id="{14E47502-1549-4CA1-BC00-85E294ABA03C}"/>
               </a:ext>
             </a:extLst>
           </p:cNvPr>
@@ -11590,7 +11590,7 @@
           <p:cNvPr id="3" name="">
             <a:extLst xmlns:a="http://schemas.openxmlformats.org/drawingml/2006/main">
               <a:ext uri="{FF2B5EF4-FFF2-40B4-BE49-F238E27FC236}">
-                <a16:creationId xmlns:a16="http://schemas.microsoft.com/office/drawing/2014/main" id="{9BA79006-4D17-46AC-8721-F63A7F3539DA}"/>
+                <a16:creationId xmlns:a16="http://schemas.microsoft.com/office/drawing/2014/main" id="{0BA104A7-632E-4474-957C-13EC57C67052}"/>
               </a:ext>
             </a:extLst>
           </p:cNvPr>
@@ -11656,7 +11656,7 @@
           <p:cNvPr id="4" name="">
             <a:extLst xmlns:a="http://schemas.openxmlformats.org/drawingml/2006/main">
               <a:ext uri="{FF2B5EF4-FFF2-40B4-BE49-F238E27FC236}">
-                <a16:creationId xmlns:a16="http://schemas.microsoft.com/office/drawing/2014/main" id="{5B699CA7-E855-4503-A85A-7E73764CC30D}"/>
+                <a16:creationId xmlns:a16="http://schemas.microsoft.com/office/drawing/2014/main" id="{F3DC9601-E4C1-43CB-BF10-D43D1CFA6F3D}"/>
               </a:ext>
             </a:extLst>
           </p:cNvPr>
@@ -11722,7 +11722,7 @@
           <p:cNvPr id="5" name="">
             <a:extLst xmlns:a="http://schemas.openxmlformats.org/drawingml/2006/main">
               <a:ext uri="{FF2B5EF4-FFF2-40B4-BE49-F238E27FC236}">
-                <a16:creationId xmlns:a16="http://schemas.microsoft.com/office/drawing/2014/main" id="{4BC6BA00-1DC3-440B-8172-57E012F0B136}"/>
+                <a16:creationId xmlns:a16="http://schemas.microsoft.com/office/drawing/2014/main" id="{28D9CD60-6FB8-4271-AD67-558253F59BD2}"/>
               </a:ext>
             </a:extLst>
           </p:cNvPr>
@@ -11788,7 +11788,7 @@
           <p:cNvPr id="6" name="">
             <a:extLst xmlns:a="http://schemas.openxmlformats.org/drawingml/2006/main">
               <a:ext uri="{FF2B5EF4-FFF2-40B4-BE49-F238E27FC236}">
-                <a16:creationId xmlns:a16="http://schemas.microsoft.com/office/drawing/2014/main" id="{DEB633C1-A224-4B1F-A444-4D37F945BF86}"/>
+                <a16:creationId xmlns:a16="http://schemas.microsoft.com/office/drawing/2014/main" id="{3A622CB7-2A2A-42E2-A75A-186D43AC2960}"/>
               </a:ext>
             </a:extLst>
           </p:cNvPr>
@@ -11854,7 +11854,7 @@
           <p:cNvPr id="7" name="">
             <a:extLst xmlns:a="http://schemas.openxmlformats.org/drawingml/2006/main">
               <a:ext uri="{FF2B5EF4-FFF2-40B4-BE49-F238E27FC236}">
-                <a16:creationId xmlns:a16="http://schemas.microsoft.com/office/drawing/2014/main" id="{6C6BCA2E-4E8A-4FC2-83C3-BEECE65BCDF2}"/>
+                <a16:creationId xmlns:a16="http://schemas.microsoft.com/office/drawing/2014/main" id="{5B064516-099F-4C4F-AC86-CF9FBFA7C6F7}"/>
               </a:ext>
             </a:extLst>
           </p:cNvPr>
@@ -11920,7 +11920,7 @@
           <p:cNvPr id="8" name="">
             <a:extLst xmlns:a="http://schemas.openxmlformats.org/drawingml/2006/main">
               <a:ext uri="{FF2B5EF4-FFF2-40B4-BE49-F238E27FC236}">
-                <a16:creationId xmlns:a16="http://schemas.microsoft.com/office/drawing/2014/main" id="{8EAC8FDE-CB97-4962-A1B5-F8AE1CC99919}"/>
+                <a16:creationId xmlns:a16="http://schemas.microsoft.com/office/drawing/2014/main" id="{AE3C6354-E6FB-41CF-AFDB-967FD797E8BE}"/>
               </a:ext>
             </a:extLst>
           </p:cNvPr>
@@ -11986,7 +11986,7 @@
           <p:cNvPr id="9" name="">
             <a:extLst xmlns:a="http://schemas.openxmlformats.org/drawingml/2006/main">
               <a:ext uri="{FF2B5EF4-FFF2-40B4-BE49-F238E27FC236}">
-                <a16:creationId xmlns:a16="http://schemas.microsoft.com/office/drawing/2014/main" id="{31BA3447-5434-4783-93FD-3C93820D3754}"/>
+                <a16:creationId xmlns:a16="http://schemas.microsoft.com/office/drawing/2014/main" id="{5CB1D4D0-2C67-4E95-A189-9E90359CD8A8}"/>
               </a:ext>
             </a:extLst>
           </p:cNvPr>
@@ -12052,7 +12052,7 @@
           <p:cNvPr id="10" name="">
             <a:extLst xmlns:a="http://schemas.openxmlformats.org/drawingml/2006/main">
               <a:ext uri="{FF2B5EF4-FFF2-40B4-BE49-F238E27FC236}">
-                <a16:creationId xmlns:a16="http://schemas.microsoft.com/office/drawing/2014/main" id="{167A78CD-2649-4014-960B-81D0C1B98435}"/>
+                <a16:creationId xmlns:a16="http://schemas.microsoft.com/office/drawing/2014/main" id="{A0ABF546-ED90-4093-AF82-963E5AD6A4AF}"/>
               </a:ext>
             </a:extLst>
           </p:cNvPr>
@@ -12177,7 +12177,7 @@
                 <a:ea typeface="Arial"/>
                 <a:cs typeface="Arial"/>
               </a:rPr>
-              <a:t>https://github.com/YuzhangLi2281/Phenom</a:t>
+              <a:t>https://github.com/YuzhangLi2281/PHENOM</a:t>
             </a:r>
           </a:p>
           <a:p xmlns:a="http://schemas.openxmlformats.org/drawingml/2006/main">
@@ -12233,7 +12233,7 @@
           <p:cNvPr id="11" name="">
             <a:extLst xmlns:a="http://schemas.openxmlformats.org/drawingml/2006/main">
               <a:ext uri="{FF2B5EF4-FFF2-40B4-BE49-F238E27FC236}">
-                <a16:creationId xmlns:a16="http://schemas.microsoft.com/office/drawing/2014/main" id="{9E4E6248-F588-496B-A04E-CA8675EB8425}"/>
+                <a16:creationId xmlns:a16="http://schemas.microsoft.com/office/drawing/2014/main" id="{1ECDA292-41AB-4731-B8BE-F5FD4F5FED9B}"/>
               </a:ext>
             </a:extLst>
           </p:cNvPr>
@@ -12289,7 +12289,7 @@
                 <a:ea typeface="Arial"/>
                 <a:cs typeface="Arial"/>
               </a:rPr>
-              <a:t>Figure direction follows AnewOmni’s molecular detail and visual hierarchy. Project diagrams retain editable labels and separate formula source slides.</a:t>
+              <a:t>Project diagrams retain editable labels and vector components. Native formula sources remain available for editing.</a:t>
             </a:r>
           </a:p>
         </p:txBody>
@@ -12297,7 +12297,7 @@
     </p:spTree>
     <p:extLst>
       <p:ext uri="{BB962C8B-B14F-4D97-AF65-F5344CB8AC3E}">
-        <p14:creationId xmlns:p14="http://schemas.microsoft.com/office/powerpoint/2010/main" val="535991818"/>
+        <p14:creationId xmlns:p14="http://schemas.microsoft.com/office/powerpoint/2010/main" val="1346777009"/>
       </p:ext>
     </p:extLst>
   </p:cSld>
@@ -12328,7 +12328,7 @@
           <p:cNvPr id="12" name="">
             <a:extLst xmlns:a="http://schemas.openxmlformats.org/drawingml/2006/main">
               <a:ext uri="{FF2B5EF4-FFF2-40B4-BE49-F238E27FC236}">
-                <a16:creationId xmlns:a16="http://schemas.microsoft.com/office/drawing/2014/main" id="{2A212F03-8AAB-4EAE-BCEC-43CE392A6369}"/>
+                <a16:creationId xmlns:a16="http://schemas.microsoft.com/office/drawing/2014/main" id="{FEEB13D0-DD5F-4E4F-B97F-62315FBCF410}"/>
               </a:ext>
             </a:extLst>
           </p:cNvPr>
@@ -12394,7 +12394,7 @@
           <p:cNvPr id="2" name="">
             <a:extLst xmlns:a="http://schemas.openxmlformats.org/drawingml/2006/main">
               <a:ext uri="{FF2B5EF4-FFF2-40B4-BE49-F238E27FC236}">
-                <a16:creationId xmlns:a16="http://schemas.microsoft.com/office/drawing/2014/main" id="{9BDCEB6A-4D94-4D85-BC65-320088210D73}"/>
+                <a16:creationId xmlns:a16="http://schemas.microsoft.com/office/drawing/2014/main" id="{516662F9-2EDB-4972-A5B2-7F22B49C98A0}"/>
               </a:ext>
             </a:extLst>
           </p:cNvPr>
@@ -12460,7 +12460,7 @@
           <p:cNvPr id="3" name="">
             <a:extLst xmlns:a="http://schemas.openxmlformats.org/drawingml/2006/main">
               <a:ext uri="{FF2B5EF4-FFF2-40B4-BE49-F238E27FC236}">
-                <a16:creationId xmlns:a16="http://schemas.microsoft.com/office/drawing/2014/main" id="{706D9D26-0E1A-443C-B2DE-A0DA6C14DE54}"/>
+                <a16:creationId xmlns:a16="http://schemas.microsoft.com/office/drawing/2014/main" id="{04539794-643F-447A-AC05-38B9CB4A3825}"/>
               </a:ext>
             </a:extLst>
           </p:cNvPr>
@@ -12526,7 +12526,7 @@
           <p:cNvPr id="4" name="">
             <a:extLst xmlns:a="http://schemas.openxmlformats.org/drawingml/2006/main">
               <a:ext uri="{FF2B5EF4-FFF2-40B4-BE49-F238E27FC236}">
-                <a16:creationId xmlns:a16="http://schemas.microsoft.com/office/drawing/2014/main" id="{ECBF4132-140C-4CCC-A3A3-7E1ED04495D9}"/>
+                <a16:creationId xmlns:a16="http://schemas.microsoft.com/office/drawing/2014/main" id="{AF07A89F-7969-4D5E-ADDF-E378BF4CA798}"/>
               </a:ext>
             </a:extLst>
           </p:cNvPr>
@@ -12592,7 +12592,7 @@
           <p:cNvPr id="5" name="">
             <a:extLst xmlns:a="http://schemas.openxmlformats.org/drawingml/2006/main">
               <a:ext uri="{FF2B5EF4-FFF2-40B4-BE49-F238E27FC236}">
-                <a16:creationId xmlns:a16="http://schemas.microsoft.com/office/drawing/2014/main" id="{538AE0E8-4069-4BD4-A7B3-B54980535FA5}"/>
+                <a16:creationId xmlns:a16="http://schemas.microsoft.com/office/drawing/2014/main" id="{296A08D2-6F10-4853-A3B8-EEA749EDB168}"/>
               </a:ext>
             </a:extLst>
           </p:cNvPr>
@@ -12658,7 +12658,7 @@
           <p:cNvPr id="6" name="">
             <a:extLst xmlns:a="http://schemas.openxmlformats.org/drawingml/2006/main">
               <a:ext uri="{FF2B5EF4-FFF2-40B4-BE49-F238E27FC236}">
-                <a16:creationId xmlns:a16="http://schemas.microsoft.com/office/drawing/2014/main" id="{8E01D24D-4B94-4FB1-8361-1FB8BEDD6245}"/>
+                <a16:creationId xmlns:a16="http://schemas.microsoft.com/office/drawing/2014/main" id="{BE89DFBD-4294-4DB3-A0DF-36999F8F3C35}"/>
               </a:ext>
             </a:extLst>
           </p:cNvPr>
@@ -12668,7 +12668,7 @@
           <p:nvPr/>
         </p:nvPicPr>
         <p:blipFill>
-          <a:blip xmlns:r="http://schemas.openxmlformats.org/officeDocument/2006/relationships" xmlns:a="http://schemas.openxmlformats.org/drawingml/2006/main" r:embed="R00692200aa8447e4"/>
+          <a:blip xmlns:r="http://schemas.openxmlformats.org/officeDocument/2006/relationships" xmlns:a="http://schemas.openxmlformats.org/drawingml/2006/main" r:embed="R3ede32d0178b4ba5"/>
           <a:stretch xmlns:a="http://schemas.openxmlformats.org/drawingml/2006/main"/>
         </p:blipFill>
         <p:spPr>
@@ -12686,7 +12686,7 @@
           <p:cNvPr id="7" name="">
             <a:extLst xmlns:a="http://schemas.openxmlformats.org/drawingml/2006/main">
               <a:ext uri="{FF2B5EF4-FFF2-40B4-BE49-F238E27FC236}">
-                <a16:creationId xmlns:a16="http://schemas.microsoft.com/office/drawing/2014/main" id="{CB6D51AD-B9A6-4AFD-9564-480528D16BDE}"/>
+                <a16:creationId xmlns:a16="http://schemas.microsoft.com/office/drawing/2014/main" id="{2F46BEA0-E005-4DD8-8600-5DDE7D03E920}"/>
               </a:ext>
             </a:extLst>
           </p:cNvPr>
@@ -12752,7 +12752,7 @@
           <p:cNvPr id="8" name="">
             <a:extLst xmlns:a="http://schemas.openxmlformats.org/drawingml/2006/main">
               <a:ext uri="{FF2B5EF4-FFF2-40B4-BE49-F238E27FC236}">
-                <a16:creationId xmlns:a16="http://schemas.microsoft.com/office/drawing/2014/main" id="{3380483B-D0AB-40FF-9AE9-4DDDBD35082B}"/>
+                <a16:creationId xmlns:a16="http://schemas.microsoft.com/office/drawing/2014/main" id="{7B3EA715-1339-4A67-B635-6A1A1C8D21C3}"/>
               </a:ext>
             </a:extLst>
           </p:cNvPr>
@@ -12818,7 +12818,7 @@
           <p:cNvPr id="9" name="">
             <a:extLst xmlns:a="http://schemas.openxmlformats.org/drawingml/2006/main">
               <a:ext uri="{FF2B5EF4-FFF2-40B4-BE49-F238E27FC236}">
-                <a16:creationId xmlns:a16="http://schemas.microsoft.com/office/drawing/2014/main" id="{BA69B278-99D0-4CA5-B4D5-638DB81C2905}"/>
+                <a16:creationId xmlns:a16="http://schemas.microsoft.com/office/drawing/2014/main" id="{8D348010-D29E-44EB-9331-111DA9022FE4}"/>
               </a:ext>
             </a:extLst>
           </p:cNvPr>
@@ -12884,7 +12884,7 @@
           <p:cNvPr id="10" name="">
             <a:extLst xmlns:a="http://schemas.openxmlformats.org/drawingml/2006/main">
               <a:ext uri="{FF2B5EF4-FFF2-40B4-BE49-F238E27FC236}">
-                <a16:creationId xmlns:a16="http://schemas.microsoft.com/office/drawing/2014/main" id="{F2982709-A50F-4CF7-932E-87894FF73901}"/>
+                <a16:creationId xmlns:a16="http://schemas.microsoft.com/office/drawing/2014/main" id="{97A987C9-59D6-4CB6-B06E-881F39B4F0A8}"/>
               </a:ext>
             </a:extLst>
           </p:cNvPr>
@@ -12950,7 +12950,7 @@
           <p:cNvPr id="11" name="">
             <a:extLst xmlns:a="http://schemas.openxmlformats.org/drawingml/2006/main">
               <a:ext uri="{FF2B5EF4-FFF2-40B4-BE49-F238E27FC236}">
-                <a16:creationId xmlns:a16="http://schemas.microsoft.com/office/drawing/2014/main" id="{CBFBE361-0903-4DD0-A642-5AF8C9B6F0F0}"/>
+                <a16:creationId xmlns:a16="http://schemas.microsoft.com/office/drawing/2014/main" id="{2C47BFA5-5676-4885-9F15-1CBC3C36A2A3}"/>
               </a:ext>
             </a:extLst>
           </p:cNvPr>
@@ -13014,7 +13014,7 @@
     </p:spTree>
     <p:extLst>
       <p:ext uri="{BB962C8B-B14F-4D97-AF65-F5344CB8AC3E}">
-        <p14:creationId xmlns:p14="http://schemas.microsoft.com/office/powerpoint/2010/main" val="669460199"/>
+        <p14:creationId xmlns:p14="http://schemas.microsoft.com/office/powerpoint/2010/main" val="908013504"/>
       </p:ext>
     </p:extLst>
   </p:cSld>
@@ -13045,7 +13045,7 @@
           <p:cNvPr id="12" name="">
             <a:extLst xmlns:a="http://schemas.openxmlformats.org/drawingml/2006/main">
               <a:ext uri="{FF2B5EF4-FFF2-40B4-BE49-F238E27FC236}">
-                <a16:creationId xmlns:a16="http://schemas.microsoft.com/office/drawing/2014/main" id="{E8CF5C8A-2416-443C-A613-1AEBFF74B82E}"/>
+                <a16:creationId xmlns:a16="http://schemas.microsoft.com/office/drawing/2014/main" id="{5482C3CC-B366-4953-A075-6644051EC517}"/>
               </a:ext>
             </a:extLst>
           </p:cNvPr>
@@ -13111,7 +13111,7 @@
           <p:cNvPr id="2" name="">
             <a:extLst xmlns:a="http://schemas.openxmlformats.org/drawingml/2006/main">
               <a:ext uri="{FF2B5EF4-FFF2-40B4-BE49-F238E27FC236}">
-                <a16:creationId xmlns:a16="http://schemas.microsoft.com/office/drawing/2014/main" id="{154A36BD-3FB8-4CE9-B0CA-594A79D7BEC1}"/>
+                <a16:creationId xmlns:a16="http://schemas.microsoft.com/office/drawing/2014/main" id="{3FB5249F-5424-4E6D-B11C-A0EF7125B082}"/>
               </a:ext>
             </a:extLst>
           </p:cNvPr>
@@ -13177,7 +13177,7 @@
           <p:cNvPr id="3" name="">
             <a:extLst xmlns:a="http://schemas.openxmlformats.org/drawingml/2006/main">
               <a:ext uri="{FF2B5EF4-FFF2-40B4-BE49-F238E27FC236}">
-                <a16:creationId xmlns:a16="http://schemas.microsoft.com/office/drawing/2014/main" id="{185034C3-7767-4F82-825B-B0C2B3858C00}"/>
+                <a16:creationId xmlns:a16="http://schemas.microsoft.com/office/drawing/2014/main" id="{D34B30E5-30D6-4990-AC61-43509707F2A5}"/>
               </a:ext>
             </a:extLst>
           </p:cNvPr>
@@ -13243,7 +13243,7 @@
           <p:cNvPr id="4" name="">
             <a:extLst xmlns:a="http://schemas.openxmlformats.org/drawingml/2006/main">
               <a:ext uri="{FF2B5EF4-FFF2-40B4-BE49-F238E27FC236}">
-                <a16:creationId xmlns:a16="http://schemas.microsoft.com/office/drawing/2014/main" id="{4DE34BD5-B02D-4972-9A3F-CE670A36E54D}"/>
+                <a16:creationId xmlns:a16="http://schemas.microsoft.com/office/drawing/2014/main" id="{AB1A633B-CD78-40B0-932E-7EF76A1BAC86}"/>
               </a:ext>
             </a:extLst>
           </p:cNvPr>
@@ -13309,7 +13309,7 @@
           <p:cNvPr id="5" name="">
             <a:extLst xmlns:a="http://schemas.openxmlformats.org/drawingml/2006/main">
               <a:ext uri="{FF2B5EF4-FFF2-40B4-BE49-F238E27FC236}">
-                <a16:creationId xmlns:a16="http://schemas.microsoft.com/office/drawing/2014/main" id="{8DBA121B-32BD-4B31-9E5B-E45F8928464E}"/>
+                <a16:creationId xmlns:a16="http://schemas.microsoft.com/office/drawing/2014/main" id="{9E0B95EC-AF82-4A59-BE4E-018338BB3F53}"/>
               </a:ext>
             </a:extLst>
           </p:cNvPr>
@@ -13375,7 +13375,7 @@
           <p:cNvPr id="6" name="">
             <a:extLst xmlns:a="http://schemas.openxmlformats.org/drawingml/2006/main">
               <a:ext uri="{FF2B5EF4-FFF2-40B4-BE49-F238E27FC236}">
-                <a16:creationId xmlns:a16="http://schemas.microsoft.com/office/drawing/2014/main" id="{9A667C29-B2A5-4EA7-9391-5E9B1B3453E7}"/>
+                <a16:creationId xmlns:a16="http://schemas.microsoft.com/office/drawing/2014/main" id="{1937B998-46C4-433E-AA05-D31536F5E35D}"/>
               </a:ext>
             </a:extLst>
           </p:cNvPr>
@@ -13441,7 +13441,7 @@
           <p:cNvPr id="7" name="">
             <a:extLst xmlns:a="http://schemas.openxmlformats.org/drawingml/2006/main">
               <a:ext uri="{FF2B5EF4-FFF2-40B4-BE49-F238E27FC236}">
-                <a16:creationId xmlns:a16="http://schemas.microsoft.com/office/drawing/2014/main" id="{02C9DE4C-3036-4D77-8ABF-146491FC6863}"/>
+                <a16:creationId xmlns:a16="http://schemas.microsoft.com/office/drawing/2014/main" id="{A2AACA9C-88E6-4262-B22B-B2C6053F6B94}"/>
               </a:ext>
             </a:extLst>
           </p:cNvPr>
@@ -13507,7 +13507,7 @@
           <p:cNvPr id="8" name="">
             <a:extLst xmlns:a="http://schemas.openxmlformats.org/drawingml/2006/main">
               <a:ext uri="{FF2B5EF4-FFF2-40B4-BE49-F238E27FC236}">
-                <a16:creationId xmlns:a16="http://schemas.microsoft.com/office/drawing/2014/main" id="{8475BC6A-4803-4B4D-AA20-C0EBAB95F68A}"/>
+                <a16:creationId xmlns:a16="http://schemas.microsoft.com/office/drawing/2014/main" id="{CBF2AAB1-1293-41E9-842E-96578614FA5C}"/>
               </a:ext>
             </a:extLst>
           </p:cNvPr>
@@ -13573,7 +13573,7 @@
           <p:cNvPr id="9" name="">
             <a:extLst xmlns:a="http://schemas.openxmlformats.org/drawingml/2006/main">
               <a:ext uri="{FF2B5EF4-FFF2-40B4-BE49-F238E27FC236}">
-                <a16:creationId xmlns:a16="http://schemas.microsoft.com/office/drawing/2014/main" id="{8C2152E8-0058-4E1A-A76F-DEFA8CAE37A6}"/>
+                <a16:creationId xmlns:a16="http://schemas.microsoft.com/office/drawing/2014/main" id="{928A3407-3012-4FB7-9A8C-1CE744F2AEA9}"/>
               </a:ext>
             </a:extLst>
           </p:cNvPr>
@@ -13639,7 +13639,7 @@
           <p:cNvPr id="10" name="">
             <a:extLst xmlns:a="http://schemas.openxmlformats.org/drawingml/2006/main">
               <a:ext uri="{FF2B5EF4-FFF2-40B4-BE49-F238E27FC236}">
-                <a16:creationId xmlns:a16="http://schemas.microsoft.com/office/drawing/2014/main" id="{79B44DC0-1B8D-45DD-8340-F08D9707F4AA}"/>
+                <a16:creationId xmlns:a16="http://schemas.microsoft.com/office/drawing/2014/main" id="{B632A9CD-C547-4A0E-90AD-3A160AA15220}"/>
               </a:ext>
             </a:extLst>
           </p:cNvPr>
@@ -13649,7 +13649,7 @@
           <p:nvPr/>
         </p:nvPicPr>
         <p:blipFill>
-          <a:blip xmlns:r="http://schemas.openxmlformats.org/officeDocument/2006/relationships" xmlns:a="http://schemas.openxmlformats.org/drawingml/2006/main" r:embed="Rf01ce9a951604dba"/>
+          <a:blip xmlns:r="http://schemas.openxmlformats.org/officeDocument/2006/relationships" xmlns:a="http://schemas.openxmlformats.org/drawingml/2006/main" r:embed="R2d8ee5355d4f4735"/>
           <a:stretch xmlns:a="http://schemas.openxmlformats.org/drawingml/2006/main"/>
         </p:blipFill>
         <p:spPr>
@@ -13667,7 +13667,7 @@
           <p:cNvPr id="11" name="">
             <a:extLst xmlns:a="http://schemas.openxmlformats.org/drawingml/2006/main">
               <a:ext uri="{FF2B5EF4-FFF2-40B4-BE49-F238E27FC236}">
-                <a16:creationId xmlns:a16="http://schemas.microsoft.com/office/drawing/2014/main" id="{22B2CE5B-F540-4DF3-85CB-8C884CA49F17}"/>
+                <a16:creationId xmlns:a16="http://schemas.microsoft.com/office/drawing/2014/main" id="{1CC4CA50-2469-49EA-81F7-D429378DEEDE}"/>
               </a:ext>
             </a:extLst>
           </p:cNvPr>
@@ -13731,7 +13731,7 @@
     </p:spTree>
     <p:extLst>
       <p:ext uri="{BB962C8B-B14F-4D97-AF65-F5344CB8AC3E}">
-        <p14:creationId xmlns:p14="http://schemas.microsoft.com/office/powerpoint/2010/main" val="555830071"/>
+        <p14:creationId xmlns:p14="http://schemas.microsoft.com/office/powerpoint/2010/main" val="487083766"/>
       </p:ext>
     </p:extLst>
   </p:cSld>
@@ -13762,7 +13762,7 @@
           <p:cNvPr id="15" name="">
             <a:extLst xmlns:a="http://schemas.openxmlformats.org/drawingml/2006/main">
               <a:ext uri="{FF2B5EF4-FFF2-40B4-BE49-F238E27FC236}">
-                <a16:creationId xmlns:a16="http://schemas.microsoft.com/office/drawing/2014/main" id="{E92029F4-92A0-4D73-90A9-12E05993D709}"/>
+                <a16:creationId xmlns:a16="http://schemas.microsoft.com/office/drawing/2014/main" id="{352A5B5B-E1A9-4EB8-BE1E-2E77CD762C4D}"/>
               </a:ext>
             </a:extLst>
           </p:cNvPr>
@@ -13828,7 +13828,7 @@
           <p:cNvPr id="2" name="">
             <a:extLst xmlns:a="http://schemas.openxmlformats.org/drawingml/2006/main">
               <a:ext uri="{FF2B5EF4-FFF2-40B4-BE49-F238E27FC236}">
-                <a16:creationId xmlns:a16="http://schemas.microsoft.com/office/drawing/2014/main" id="{4EC459C4-EC81-41C3-8106-D4E5163B7ECF}"/>
+                <a16:creationId xmlns:a16="http://schemas.microsoft.com/office/drawing/2014/main" id="{59967713-7203-4F7B-BE19-A26112387666}"/>
               </a:ext>
             </a:extLst>
           </p:cNvPr>
@@ -13894,7 +13894,7 @@
           <p:cNvPr id="3" name="">
             <a:extLst xmlns:a="http://schemas.openxmlformats.org/drawingml/2006/main">
               <a:ext uri="{FF2B5EF4-FFF2-40B4-BE49-F238E27FC236}">
-                <a16:creationId xmlns:a16="http://schemas.microsoft.com/office/drawing/2014/main" id="{8B4041FE-C9B2-412C-932C-17EC5D525AD5}"/>
+                <a16:creationId xmlns:a16="http://schemas.microsoft.com/office/drawing/2014/main" id="{81D42A51-3C77-4C78-89DF-A8DBF2B5137B}"/>
               </a:ext>
             </a:extLst>
           </p:cNvPr>
@@ -13960,7 +13960,7 @@
           <p:cNvPr id="4" name="">
             <a:extLst xmlns:a="http://schemas.openxmlformats.org/drawingml/2006/main">
               <a:ext uri="{FF2B5EF4-FFF2-40B4-BE49-F238E27FC236}">
-                <a16:creationId xmlns:a16="http://schemas.microsoft.com/office/drawing/2014/main" id="{2F73B47E-55DD-4199-A53D-6E428F9423CE}"/>
+                <a16:creationId xmlns:a16="http://schemas.microsoft.com/office/drawing/2014/main" id="{2BE4BA06-9960-4187-A64C-B48FA9745CCF}"/>
               </a:ext>
             </a:extLst>
           </p:cNvPr>
@@ -14026,7 +14026,7 @@
           <p:cNvPr id="5" name="">
             <a:extLst xmlns:a="http://schemas.openxmlformats.org/drawingml/2006/main">
               <a:ext uri="{FF2B5EF4-FFF2-40B4-BE49-F238E27FC236}">
-                <a16:creationId xmlns:a16="http://schemas.microsoft.com/office/drawing/2014/main" id="{448E0366-5749-48D1-A77C-B205C8467FB4}"/>
+                <a16:creationId xmlns:a16="http://schemas.microsoft.com/office/drawing/2014/main" id="{30101679-F816-462B-9276-721DFBF1C127}"/>
               </a:ext>
             </a:extLst>
           </p:cNvPr>
@@ -14092,7 +14092,7 @@
           <p:cNvPr id="6" name="">
             <a:extLst xmlns:a="http://schemas.openxmlformats.org/drawingml/2006/main">
               <a:ext uri="{FF2B5EF4-FFF2-40B4-BE49-F238E27FC236}">
-                <a16:creationId xmlns:a16="http://schemas.microsoft.com/office/drawing/2014/main" id="{CAA241AB-BCA1-4B1B-B28B-2628281207A6}"/>
+                <a16:creationId xmlns:a16="http://schemas.microsoft.com/office/drawing/2014/main" id="{3E41E61A-B015-4D1C-A736-2987077C65DB}"/>
               </a:ext>
             </a:extLst>
           </p:cNvPr>
@@ -14158,7 +14158,7 @@
           <p:cNvPr id="7" name="">
             <a:extLst xmlns:a="http://schemas.openxmlformats.org/drawingml/2006/main">
               <a:ext uri="{FF2B5EF4-FFF2-40B4-BE49-F238E27FC236}">
-                <a16:creationId xmlns:a16="http://schemas.microsoft.com/office/drawing/2014/main" id="{8AD0D16E-C1AE-4D60-ABE2-E4A57B01ADAC}"/>
+                <a16:creationId xmlns:a16="http://schemas.microsoft.com/office/drawing/2014/main" id="{E2D75758-E44B-4620-8BB7-BAEA34DDE7E9}"/>
               </a:ext>
             </a:extLst>
           </p:cNvPr>
@@ -14224,7 +14224,7 @@
           <p:cNvPr id="8" name="">
             <a:extLst xmlns:a="http://schemas.openxmlformats.org/drawingml/2006/main">
               <a:ext uri="{FF2B5EF4-FFF2-40B4-BE49-F238E27FC236}">
-                <a16:creationId xmlns:a16="http://schemas.microsoft.com/office/drawing/2014/main" id="{F08B4677-DA8F-4B0D-AE55-C411995B8737}"/>
+                <a16:creationId xmlns:a16="http://schemas.microsoft.com/office/drawing/2014/main" id="{384715A1-3B02-474B-828C-8E787DA9E6B0}"/>
               </a:ext>
             </a:extLst>
           </p:cNvPr>
@@ -14290,7 +14290,7 @@
           <p:cNvPr id="9" name="">
             <a:extLst xmlns:a="http://schemas.openxmlformats.org/drawingml/2006/main">
               <a:ext uri="{FF2B5EF4-FFF2-40B4-BE49-F238E27FC236}">
-                <a16:creationId xmlns:a16="http://schemas.microsoft.com/office/drawing/2014/main" id="{B8C6473C-795C-4C21-8A40-8AC46F3C847C}"/>
+                <a16:creationId xmlns:a16="http://schemas.microsoft.com/office/drawing/2014/main" id="{DADEB93C-B5D2-427F-97AF-9F163A8590E5}"/>
               </a:ext>
             </a:extLst>
           </p:cNvPr>
@@ -14346,7 +14346,7 @@
                 <a:ea typeface="Arial"/>
                 <a:cs typeface="Arial"/>
               </a:rPr>
-              <a:t>Phenom needs an enzyme–substrate pair. For the carbonic anhydrase example, carbon dioxide is O=C=O. A pH target alone does not replace the substrate.</a:t>
+              <a:t>PHENOM needs an enzyme–substrate pair. For the carbonic anhydrase example, carbon dioxide is O=C=O. A pH target alone does not replace the substrate.</a:t>
             </a:r>
           </a:p>
         </p:txBody>
@@ -14356,7 +14356,7 @@
           <p:cNvPr id="10" name="">
             <a:extLst xmlns:a="http://schemas.openxmlformats.org/drawingml/2006/main">
               <a:ext uri="{FF2B5EF4-FFF2-40B4-BE49-F238E27FC236}">
-                <a16:creationId xmlns:a16="http://schemas.microsoft.com/office/drawing/2014/main" id="{FDEF5FB9-4138-4CDA-BAA0-FEAD9AE2534C}"/>
+                <a16:creationId xmlns:a16="http://schemas.microsoft.com/office/drawing/2014/main" id="{B244CBC8-4262-48DE-9793-1351EC0DF62D}"/>
               </a:ext>
             </a:extLst>
           </p:cNvPr>
@@ -14422,7 +14422,7 @@
           <p:cNvPr id="11" name="">
             <a:extLst xmlns:a="http://schemas.openxmlformats.org/drawingml/2006/main">
               <a:ext uri="{FF2B5EF4-FFF2-40B4-BE49-F238E27FC236}">
-                <a16:creationId xmlns:a16="http://schemas.microsoft.com/office/drawing/2014/main" id="{A91B09BB-B3D8-4F99-AEBA-8FD181CC78F6}"/>
+                <a16:creationId xmlns:a16="http://schemas.microsoft.com/office/drawing/2014/main" id="{50B5D98F-C3B4-4C2A-AEB4-C13335662DD6}"/>
               </a:ext>
             </a:extLst>
           </p:cNvPr>
@@ -14488,7 +14488,7 @@
           <p:cNvPr id="12" name="">
             <a:extLst xmlns:a="http://schemas.openxmlformats.org/drawingml/2006/main">
               <a:ext uri="{FF2B5EF4-FFF2-40B4-BE49-F238E27FC236}">
-                <a16:creationId xmlns:a16="http://schemas.microsoft.com/office/drawing/2014/main" id="{14933887-B2D4-4A0A-A001-9686EC1FE006}"/>
+                <a16:creationId xmlns:a16="http://schemas.microsoft.com/office/drawing/2014/main" id="{B8D7992C-DFE8-40EC-81DE-D37D3E78C4BE}"/>
               </a:ext>
             </a:extLst>
           </p:cNvPr>
@@ -14554,7 +14554,7 @@
           <p:cNvPr id="13" name="">
             <a:extLst xmlns:a="http://schemas.openxmlformats.org/drawingml/2006/main">
               <a:ext uri="{FF2B5EF4-FFF2-40B4-BE49-F238E27FC236}">
-                <a16:creationId xmlns:a16="http://schemas.microsoft.com/office/drawing/2014/main" id="{7A6EE96C-5F7E-4906-8FD7-20A032A32211}"/>
+                <a16:creationId xmlns:a16="http://schemas.microsoft.com/office/drawing/2014/main" id="{E3F4798F-A015-42FB-AF91-5232A6E28AAA}"/>
               </a:ext>
             </a:extLst>
           </p:cNvPr>
@@ -14620,7 +14620,7 @@
           <p:cNvPr id="14" name="">
             <a:extLst xmlns:a="http://schemas.openxmlformats.org/drawingml/2006/main">
               <a:ext uri="{FF2B5EF4-FFF2-40B4-BE49-F238E27FC236}">
-                <a16:creationId xmlns:a16="http://schemas.microsoft.com/office/drawing/2014/main" id="{31EF4DED-D1A2-4143-9DF2-FFCE1303C0C0}"/>
+                <a16:creationId xmlns:a16="http://schemas.microsoft.com/office/drawing/2014/main" id="{9A57EC60-F2C0-40B7-BFA2-62D9A724B31F}"/>
               </a:ext>
             </a:extLst>
           </p:cNvPr>
@@ -14684,7 +14684,7 @@
     </p:spTree>
     <p:extLst>
       <p:ext uri="{BB962C8B-B14F-4D97-AF65-F5344CB8AC3E}">
-        <p14:creationId xmlns:p14="http://schemas.microsoft.com/office/powerpoint/2010/main" val="8815116"/>
+        <p14:creationId xmlns:p14="http://schemas.microsoft.com/office/powerpoint/2010/main" val="129873753"/>
       </p:ext>
     </p:extLst>
   </p:cSld>
@@ -14715,7 +14715,7 @@
           <p:cNvPr id="11" name="">
             <a:extLst xmlns:a="http://schemas.openxmlformats.org/drawingml/2006/main">
               <a:ext uri="{FF2B5EF4-FFF2-40B4-BE49-F238E27FC236}">
-                <a16:creationId xmlns:a16="http://schemas.microsoft.com/office/drawing/2014/main" id="{A1A9A75D-2F84-465F-8D86-8169CA984946}"/>
+                <a16:creationId xmlns:a16="http://schemas.microsoft.com/office/drawing/2014/main" id="{36AFFA3F-26D4-4A79-8A20-C62F6DDED3D3}"/>
               </a:ext>
             </a:extLst>
           </p:cNvPr>
@@ -14781,7 +14781,7 @@
           <p:cNvPr id="2" name="">
             <a:extLst xmlns:a="http://schemas.openxmlformats.org/drawingml/2006/main">
               <a:ext uri="{FF2B5EF4-FFF2-40B4-BE49-F238E27FC236}">
-                <a16:creationId xmlns:a16="http://schemas.microsoft.com/office/drawing/2014/main" id="{389B93E7-2A5D-4044-9EF7-2F228E317019}"/>
+                <a16:creationId xmlns:a16="http://schemas.microsoft.com/office/drawing/2014/main" id="{23949649-97BA-41C2-9C50-1B87D33FB6B4}"/>
               </a:ext>
             </a:extLst>
           </p:cNvPr>
@@ -14847,7 +14847,7 @@
           <p:cNvPr id="3" name="">
             <a:extLst xmlns:a="http://schemas.openxmlformats.org/drawingml/2006/main">
               <a:ext uri="{FF2B5EF4-FFF2-40B4-BE49-F238E27FC236}">
-                <a16:creationId xmlns:a16="http://schemas.microsoft.com/office/drawing/2014/main" id="{AF47FA36-88FD-48F1-963B-3D9664BB08D8}"/>
+                <a16:creationId xmlns:a16="http://schemas.microsoft.com/office/drawing/2014/main" id="{A6DD2E6E-533E-46B5-B61E-E1F710BD463A}"/>
               </a:ext>
             </a:extLst>
           </p:cNvPr>
@@ -14913,7 +14913,7 @@
           <p:cNvPr id="4" name="">
             <a:extLst xmlns:a="http://schemas.openxmlformats.org/drawingml/2006/main">
               <a:ext uri="{FF2B5EF4-FFF2-40B4-BE49-F238E27FC236}">
-                <a16:creationId xmlns:a16="http://schemas.microsoft.com/office/drawing/2014/main" id="{E7FEA3C2-2C4F-4E52-A195-25F861D90967}"/>
+                <a16:creationId xmlns:a16="http://schemas.microsoft.com/office/drawing/2014/main" id="{7354BBBA-B5AC-4847-8530-D75479846304}"/>
               </a:ext>
             </a:extLst>
           </p:cNvPr>
@@ -14979,7 +14979,7 @@
           <p:cNvPr id="5" name="">
             <a:extLst xmlns:a="http://schemas.openxmlformats.org/drawingml/2006/main">
               <a:ext uri="{FF2B5EF4-FFF2-40B4-BE49-F238E27FC236}">
-                <a16:creationId xmlns:a16="http://schemas.microsoft.com/office/drawing/2014/main" id="{2D3E95DC-CC57-4100-9F2A-52C478F3FA6F}"/>
+                <a16:creationId xmlns:a16="http://schemas.microsoft.com/office/drawing/2014/main" id="{762F1D74-D755-4220-944F-62375CD4D1B6}"/>
               </a:ext>
             </a:extLst>
           </p:cNvPr>
@@ -15045,7 +15045,7 @@
           <p:cNvPr id="6" name="">
             <a:extLst xmlns:a="http://schemas.openxmlformats.org/drawingml/2006/main">
               <a:ext uri="{FF2B5EF4-FFF2-40B4-BE49-F238E27FC236}">
-                <a16:creationId xmlns:a16="http://schemas.microsoft.com/office/drawing/2014/main" id="{DFF492EB-AB70-442D-BF18-57AAEC833B51}"/>
+                <a16:creationId xmlns:a16="http://schemas.microsoft.com/office/drawing/2014/main" id="{D0644BF6-7F4B-46C6-935C-9D41D723FED9}"/>
               </a:ext>
             </a:extLst>
           </p:cNvPr>
@@ -15111,7 +15111,7 @@
           <p:cNvPr id="7" name="">
             <a:extLst xmlns:a="http://schemas.openxmlformats.org/drawingml/2006/main">
               <a:ext uri="{FF2B5EF4-FFF2-40B4-BE49-F238E27FC236}">
-                <a16:creationId xmlns:a16="http://schemas.microsoft.com/office/drawing/2014/main" id="{1828D40F-F7F1-4ADC-9DF8-0CA72DC5E738}"/>
+                <a16:creationId xmlns:a16="http://schemas.microsoft.com/office/drawing/2014/main" id="{244DE85D-FC69-434D-93E2-062E40012AD3}"/>
               </a:ext>
             </a:extLst>
           </p:cNvPr>
@@ -15177,7 +15177,7 @@
           <p:cNvPr id="8" name="">
             <a:extLst xmlns:a="http://schemas.openxmlformats.org/drawingml/2006/main">
               <a:ext uri="{FF2B5EF4-FFF2-40B4-BE49-F238E27FC236}">
-                <a16:creationId xmlns:a16="http://schemas.microsoft.com/office/drawing/2014/main" id="{5E1CB843-4A41-41C9-BB27-8532AB08DABF}"/>
+                <a16:creationId xmlns:a16="http://schemas.microsoft.com/office/drawing/2014/main" id="{D871AEAE-ADE9-4E35-BD1A-9F4F08ED4303}"/>
               </a:ext>
             </a:extLst>
           </p:cNvPr>
@@ -15187,7 +15187,7 @@
           <p:nvPr/>
         </p:nvPicPr>
         <p:blipFill>
-          <a:blip xmlns:r="http://schemas.openxmlformats.org/officeDocument/2006/relationships" xmlns:a="http://schemas.openxmlformats.org/drawingml/2006/main" r:embed="Re77bc906ecfc45fc"/>
+          <a:blip xmlns:r="http://schemas.openxmlformats.org/officeDocument/2006/relationships" xmlns:a="http://schemas.openxmlformats.org/drawingml/2006/main" r:embed="R9e949af572214be1"/>
           <a:stretch xmlns:a="http://schemas.openxmlformats.org/drawingml/2006/main"/>
         </p:blipFill>
         <p:spPr>
@@ -15205,7 +15205,7 @@
           <p:cNvPr id="9" name="">
             <a:extLst xmlns:a="http://schemas.openxmlformats.org/drawingml/2006/main">
               <a:ext uri="{FF2B5EF4-FFF2-40B4-BE49-F238E27FC236}">
-                <a16:creationId xmlns:a16="http://schemas.microsoft.com/office/drawing/2014/main" id="{A977B7B5-B762-492D-B26E-626F01EB7929}"/>
+                <a16:creationId xmlns:a16="http://schemas.microsoft.com/office/drawing/2014/main" id="{97926B7A-C435-4AA3-8CF7-3EAFA5A92C61}"/>
               </a:ext>
             </a:extLst>
           </p:cNvPr>
@@ -15271,7 +15271,7 @@
           <p:cNvPr id="10" name="">
             <a:extLst xmlns:a="http://schemas.openxmlformats.org/drawingml/2006/main">
               <a:ext uri="{FF2B5EF4-FFF2-40B4-BE49-F238E27FC236}">
-                <a16:creationId xmlns:a16="http://schemas.microsoft.com/office/drawing/2014/main" id="{DEF2C6F2-1B2D-4BA0-8190-1F2C04317C27}"/>
+                <a16:creationId xmlns:a16="http://schemas.microsoft.com/office/drawing/2014/main" id="{BA02BC1E-F4F4-4B30-9F05-70AB8EB8C76B}"/>
               </a:ext>
             </a:extLst>
           </p:cNvPr>
@@ -15335,7 +15335,7 @@
     </p:spTree>
     <p:extLst>
       <p:ext uri="{BB962C8B-B14F-4D97-AF65-F5344CB8AC3E}">
-        <p14:creationId xmlns:p14="http://schemas.microsoft.com/office/powerpoint/2010/main" val="134871379"/>
+        <p14:creationId xmlns:p14="http://schemas.microsoft.com/office/powerpoint/2010/main" val="628559999"/>
       </p:ext>
     </p:extLst>
   </p:cSld>
@@ -15366,7 +15366,7 @@
           <p:cNvPr id="11" name="">
             <a:extLst xmlns:a="http://schemas.openxmlformats.org/drawingml/2006/main">
               <a:ext uri="{FF2B5EF4-FFF2-40B4-BE49-F238E27FC236}">
-                <a16:creationId xmlns:a16="http://schemas.microsoft.com/office/drawing/2014/main" id="{DE1A7FC7-8D63-492B-AFA5-14D7C05641AB}"/>
+                <a16:creationId xmlns:a16="http://schemas.microsoft.com/office/drawing/2014/main" id="{8B3F8DF2-7DEA-4183-956B-6F1B914BA505}"/>
               </a:ext>
             </a:extLst>
           </p:cNvPr>
@@ -15432,7 +15432,7 @@
           <p:cNvPr id="2" name="">
             <a:extLst xmlns:a="http://schemas.openxmlformats.org/drawingml/2006/main">
               <a:ext uri="{FF2B5EF4-FFF2-40B4-BE49-F238E27FC236}">
-                <a16:creationId xmlns:a16="http://schemas.microsoft.com/office/drawing/2014/main" id="{B5E37647-F8CF-4355-B616-94BDF704B941}"/>
+                <a16:creationId xmlns:a16="http://schemas.microsoft.com/office/drawing/2014/main" id="{8EB980C3-E11C-42CF-9B89-C223EC0EB8B6}"/>
               </a:ext>
             </a:extLst>
           </p:cNvPr>
@@ -15498,7 +15498,7 @@
           <p:cNvPr id="3" name="">
             <a:extLst xmlns:a="http://schemas.openxmlformats.org/drawingml/2006/main">
               <a:ext uri="{FF2B5EF4-FFF2-40B4-BE49-F238E27FC236}">
-                <a16:creationId xmlns:a16="http://schemas.microsoft.com/office/drawing/2014/main" id="{ECD8980A-FD56-4337-AD05-E1F8FFCCE601}"/>
+                <a16:creationId xmlns:a16="http://schemas.microsoft.com/office/drawing/2014/main" id="{03005FCE-56E2-4D7C-8568-FC1FA14AB4D1}"/>
               </a:ext>
             </a:extLst>
           </p:cNvPr>
@@ -15564,7 +15564,7 @@
           <p:cNvPr id="4" name="">
             <a:extLst xmlns:a="http://schemas.openxmlformats.org/drawingml/2006/main">
               <a:ext uri="{FF2B5EF4-FFF2-40B4-BE49-F238E27FC236}">
-                <a16:creationId xmlns:a16="http://schemas.microsoft.com/office/drawing/2014/main" id="{C15D1EA5-FF8D-4593-AE72-46A00B9E4C6F}"/>
+                <a16:creationId xmlns:a16="http://schemas.microsoft.com/office/drawing/2014/main" id="{E01761BD-BB39-49AE-9F5A-38FDB309FE64}"/>
               </a:ext>
             </a:extLst>
           </p:cNvPr>
@@ -15630,7 +15630,7 @@
           <p:cNvPr id="5" name="">
             <a:extLst xmlns:a="http://schemas.openxmlformats.org/drawingml/2006/main">
               <a:ext uri="{FF2B5EF4-FFF2-40B4-BE49-F238E27FC236}">
-                <a16:creationId xmlns:a16="http://schemas.microsoft.com/office/drawing/2014/main" id="{CA705E52-5094-46C2-B0BE-A919E12BA42A}"/>
+                <a16:creationId xmlns:a16="http://schemas.microsoft.com/office/drawing/2014/main" id="{E730327A-6817-4E66-82D7-01EF1A2F8E02}"/>
               </a:ext>
             </a:extLst>
           </p:cNvPr>
@@ -15696,7 +15696,7 @@
           <p:cNvPr id="6" name="">
             <a:extLst xmlns:a="http://schemas.openxmlformats.org/drawingml/2006/main">
               <a:ext uri="{FF2B5EF4-FFF2-40B4-BE49-F238E27FC236}">
-                <a16:creationId xmlns:a16="http://schemas.microsoft.com/office/drawing/2014/main" id="{06BAF490-38B6-4859-A603-78059C9793EC}"/>
+                <a16:creationId xmlns:a16="http://schemas.microsoft.com/office/drawing/2014/main" id="{298AA8E1-E6A2-4D19-9A3D-44E84F6FA7D4}"/>
               </a:ext>
             </a:extLst>
           </p:cNvPr>
@@ -15762,7 +15762,7 @@
           <p:cNvPr id="7" name="">
             <a:extLst xmlns:a="http://schemas.openxmlformats.org/drawingml/2006/main">
               <a:ext uri="{FF2B5EF4-FFF2-40B4-BE49-F238E27FC236}">
-                <a16:creationId xmlns:a16="http://schemas.microsoft.com/office/drawing/2014/main" id="{DC9FE2B8-AFF1-47C9-92E1-72FB6E5250CC}"/>
+                <a16:creationId xmlns:a16="http://schemas.microsoft.com/office/drawing/2014/main" id="{4E05CEAA-E058-43F8-83BA-71CE587DCC69}"/>
               </a:ext>
             </a:extLst>
           </p:cNvPr>
@@ -15828,7 +15828,7 @@
           <p:cNvPr id="8" name="">
             <a:extLst xmlns:a="http://schemas.openxmlformats.org/drawingml/2006/main">
               <a:ext uri="{FF2B5EF4-FFF2-40B4-BE49-F238E27FC236}">
-                <a16:creationId xmlns:a16="http://schemas.microsoft.com/office/drawing/2014/main" id="{5896B992-75FA-498D-BFAA-B83D344B498E}"/>
+                <a16:creationId xmlns:a16="http://schemas.microsoft.com/office/drawing/2014/main" id="{FEE3200E-D3B4-48F8-804B-26C1A8832648}"/>
               </a:ext>
             </a:extLst>
           </p:cNvPr>
@@ -15838,7 +15838,7 @@
           <p:nvPr/>
         </p:nvPicPr>
         <p:blipFill>
-          <a:blip xmlns:r="http://schemas.openxmlformats.org/officeDocument/2006/relationships" xmlns:a="http://schemas.openxmlformats.org/drawingml/2006/main" r:embed="R6e6dca0d2fa74b7a"/>
+          <a:blip xmlns:r="http://schemas.openxmlformats.org/officeDocument/2006/relationships" xmlns:a="http://schemas.openxmlformats.org/drawingml/2006/main" r:embed="R11de17f8fd744fac"/>
           <a:stretch xmlns:a="http://schemas.openxmlformats.org/drawingml/2006/main"/>
         </p:blipFill>
         <p:spPr>
@@ -15856,7 +15856,7 @@
           <p:cNvPr id="9" name="">
             <a:extLst xmlns:a="http://schemas.openxmlformats.org/drawingml/2006/main">
               <a:ext uri="{FF2B5EF4-FFF2-40B4-BE49-F238E27FC236}">
-                <a16:creationId xmlns:a16="http://schemas.microsoft.com/office/drawing/2014/main" id="{FC86DF65-44D3-4FAD-ADBD-C004A448C459}"/>
+                <a16:creationId xmlns:a16="http://schemas.microsoft.com/office/drawing/2014/main" id="{2D79EA68-3386-4FA8-BECC-6902F180A49E}"/>
               </a:ext>
             </a:extLst>
           </p:cNvPr>
@@ -15922,7 +15922,7 @@
           <p:cNvPr id="10" name="">
             <a:extLst xmlns:a="http://schemas.openxmlformats.org/drawingml/2006/main">
               <a:ext uri="{FF2B5EF4-FFF2-40B4-BE49-F238E27FC236}">
-                <a16:creationId xmlns:a16="http://schemas.microsoft.com/office/drawing/2014/main" id="{EDF62B56-3C88-4D2C-9902-B663994C62A3}"/>
+                <a16:creationId xmlns:a16="http://schemas.microsoft.com/office/drawing/2014/main" id="{B379D331-23ED-45AB-80A4-168408FA3F2C}"/>
               </a:ext>
             </a:extLst>
           </p:cNvPr>
@@ -15986,7 +15986,7 @@
     </p:spTree>
     <p:extLst>
       <p:ext uri="{BB962C8B-B14F-4D97-AF65-F5344CB8AC3E}">
-        <p14:creationId xmlns:p14="http://schemas.microsoft.com/office/powerpoint/2010/main" val="1522674339"/>
+        <p14:creationId xmlns:p14="http://schemas.microsoft.com/office/powerpoint/2010/main" val="1848009112"/>
       </p:ext>
     </p:extLst>
   </p:cSld>
@@ -16017,7 +16017,7 @@
           <p:cNvPr id="11" name="">
             <a:extLst xmlns:a="http://schemas.openxmlformats.org/drawingml/2006/main">
               <a:ext uri="{FF2B5EF4-FFF2-40B4-BE49-F238E27FC236}">
-                <a16:creationId xmlns:a16="http://schemas.microsoft.com/office/drawing/2014/main" id="{CB860C3D-278C-4A74-9C83-3D10CD318536}"/>
+                <a16:creationId xmlns:a16="http://schemas.microsoft.com/office/drawing/2014/main" id="{2005D130-5BDE-49BB-92B3-366655673C23}"/>
               </a:ext>
             </a:extLst>
           </p:cNvPr>
@@ -16083,7 +16083,7 @@
           <p:cNvPr id="2" name="">
             <a:extLst xmlns:a="http://schemas.openxmlformats.org/drawingml/2006/main">
               <a:ext uri="{FF2B5EF4-FFF2-40B4-BE49-F238E27FC236}">
-                <a16:creationId xmlns:a16="http://schemas.microsoft.com/office/drawing/2014/main" id="{586BAD25-8DFB-44AE-A7AE-0C72A38AE753}"/>
+                <a16:creationId xmlns:a16="http://schemas.microsoft.com/office/drawing/2014/main" id="{401A806F-4B08-45BF-8FFF-4DF507E603EC}"/>
               </a:ext>
             </a:extLst>
           </p:cNvPr>
@@ -16149,7 +16149,7 @@
           <p:cNvPr id="3" name="">
             <a:extLst xmlns:a="http://schemas.openxmlformats.org/drawingml/2006/main">
               <a:ext uri="{FF2B5EF4-FFF2-40B4-BE49-F238E27FC236}">
-                <a16:creationId xmlns:a16="http://schemas.microsoft.com/office/drawing/2014/main" id="{1929DD94-3823-4036-A87F-4C0F93959D47}"/>
+                <a16:creationId xmlns:a16="http://schemas.microsoft.com/office/drawing/2014/main" id="{B2FA67F2-7297-46BB-A165-74E0766577F1}"/>
               </a:ext>
             </a:extLst>
           </p:cNvPr>
@@ -16215,7 +16215,7 @@
           <p:cNvPr id="4" name="">
             <a:extLst xmlns:a="http://schemas.openxmlformats.org/drawingml/2006/main">
               <a:ext uri="{FF2B5EF4-FFF2-40B4-BE49-F238E27FC236}">
-                <a16:creationId xmlns:a16="http://schemas.microsoft.com/office/drawing/2014/main" id="{A627D20E-424E-4CC0-9B11-4FFA7255C1C2}"/>
+                <a16:creationId xmlns:a16="http://schemas.microsoft.com/office/drawing/2014/main" id="{89848FD4-6D25-450F-847C-EF87C9D9E826}"/>
               </a:ext>
             </a:extLst>
           </p:cNvPr>
@@ -16281,7 +16281,7 @@
           <p:cNvPr id="5" name="">
             <a:extLst xmlns:a="http://schemas.openxmlformats.org/drawingml/2006/main">
               <a:ext uri="{FF2B5EF4-FFF2-40B4-BE49-F238E27FC236}">
-                <a16:creationId xmlns:a16="http://schemas.microsoft.com/office/drawing/2014/main" id="{BC22EFF1-7E7F-4122-A745-0182DB6B697F}"/>
+                <a16:creationId xmlns:a16="http://schemas.microsoft.com/office/drawing/2014/main" id="{B641F572-14C1-489A-B2EC-440EF0E9891C}"/>
               </a:ext>
             </a:extLst>
           </p:cNvPr>
@@ -16347,7 +16347,7 @@
           <p:cNvPr id="6" name="">
             <a:extLst xmlns:a="http://schemas.openxmlformats.org/drawingml/2006/main">
               <a:ext uri="{FF2B5EF4-FFF2-40B4-BE49-F238E27FC236}">
-                <a16:creationId xmlns:a16="http://schemas.microsoft.com/office/drawing/2014/main" id="{05C1FDAD-9BFB-4E3F-B0FD-154AA3A01085}"/>
+                <a16:creationId xmlns:a16="http://schemas.microsoft.com/office/drawing/2014/main" id="{2F5165D5-4135-4209-B1F2-FBB273053C97}"/>
               </a:ext>
             </a:extLst>
           </p:cNvPr>
@@ -16403,7 +16403,7 @@
                 <a:ea typeface="Arial"/>
                 <a:cs typeface="Arial"/>
               </a:rPr>
-              <a:t>Phenom, EpHod and UniStab</a:t>
+              <a:t>PHENOM, EpHod and UniStab</a:t>
             </a:r>
           </a:p>
         </p:txBody>
@@ -16413,7 +16413,7 @@
           <p:cNvPr id="7" name="">
             <a:extLst xmlns:a="http://schemas.openxmlformats.org/drawingml/2006/main">
               <a:ext uri="{FF2B5EF4-FFF2-40B4-BE49-F238E27FC236}">
-                <a16:creationId xmlns:a16="http://schemas.microsoft.com/office/drawing/2014/main" id="{44AF28C3-4955-4E83-BF90-4339CA6A1B41}"/>
+                <a16:creationId xmlns:a16="http://schemas.microsoft.com/office/drawing/2014/main" id="{D3A51FC6-297E-4219-B350-921EBFD73EB9}"/>
               </a:ext>
             </a:extLst>
           </p:cNvPr>
@@ -16469,7 +16469,7 @@
                 <a:ea typeface="Arial"/>
                 <a:cs typeface="Arial"/>
               </a:rPr>
-              <a:t>Phenom predicts log10(kcat) and a Gaussian standard deviation. EpHod predicts optimal pH and reports predictor disagreement. UniStab predicts WT-relative stability change and head-dropout variation.</a:t>
+              <a:t>PHENOM predicts log10(kcat) and a Gaussian standard deviation. EpHod predicts optimal pH and reports predictor disagreement. UniStab predicts WT-relative stability change and head-dropout variation.</a:t>
             </a:r>
           </a:p>
         </p:txBody>
@@ -16479,7 +16479,7 @@
           <p:cNvPr id="8" name="">
             <a:extLst xmlns:a="http://schemas.openxmlformats.org/drawingml/2006/main">
               <a:ext uri="{FF2B5EF4-FFF2-40B4-BE49-F238E27FC236}">
-                <a16:creationId xmlns:a16="http://schemas.microsoft.com/office/drawing/2014/main" id="{9E221CB7-6012-4147-B8F2-63D84BF586D8}"/>
+                <a16:creationId xmlns:a16="http://schemas.microsoft.com/office/drawing/2014/main" id="{5DC5B8B9-ED3C-4554-9126-450D2B01E3C5}"/>
               </a:ext>
             </a:extLst>
           </p:cNvPr>
@@ -16489,7 +16489,7 @@
           <p:nvPr/>
         </p:nvPicPr>
         <p:blipFill>
-          <a:blip xmlns:r="http://schemas.openxmlformats.org/officeDocument/2006/relationships" xmlns:a="http://schemas.openxmlformats.org/drawingml/2006/main" r:embed="R715895ce83cf4491"/>
+          <a:blip xmlns:r="http://schemas.openxmlformats.org/officeDocument/2006/relationships" xmlns:a="http://schemas.openxmlformats.org/drawingml/2006/main" r:embed="R51093e0e035e4801"/>
           <a:stretch xmlns:a="http://schemas.openxmlformats.org/drawingml/2006/main"/>
         </p:blipFill>
         <p:spPr>
@@ -16507,7 +16507,7 @@
           <p:cNvPr id="9" name="">
             <a:extLst xmlns:a="http://schemas.openxmlformats.org/drawingml/2006/main">
               <a:ext uri="{FF2B5EF4-FFF2-40B4-BE49-F238E27FC236}">
-                <a16:creationId xmlns:a16="http://schemas.microsoft.com/office/drawing/2014/main" id="{59F048B2-EB02-4F4D-8924-E87CBA8158DE}"/>
+                <a16:creationId xmlns:a16="http://schemas.microsoft.com/office/drawing/2014/main" id="{BC5319F5-8939-4D86-9C8D-E0E7E42D7DE2}"/>
               </a:ext>
             </a:extLst>
           </p:cNvPr>
@@ -16573,7 +16573,7 @@
           <p:cNvPr id="10" name="">
             <a:extLst xmlns:a="http://schemas.openxmlformats.org/drawingml/2006/main">
               <a:ext uri="{FF2B5EF4-FFF2-40B4-BE49-F238E27FC236}">
-                <a16:creationId xmlns:a16="http://schemas.microsoft.com/office/drawing/2014/main" id="{ADBF2770-D1AA-4814-A977-0FE8A705CE19}"/>
+                <a16:creationId xmlns:a16="http://schemas.microsoft.com/office/drawing/2014/main" id="{26263007-1E2A-4683-8F4A-205EBD83A910}"/>
               </a:ext>
             </a:extLst>
           </p:cNvPr>
@@ -16637,7 +16637,7 @@
     </p:spTree>
     <p:extLst>
       <p:ext uri="{BB962C8B-B14F-4D97-AF65-F5344CB8AC3E}">
-        <p14:creationId xmlns:p14="http://schemas.microsoft.com/office/powerpoint/2010/main" val="691932151"/>
+        <p14:creationId xmlns:p14="http://schemas.microsoft.com/office/powerpoint/2010/main" val="2075024993"/>
       </p:ext>
     </p:extLst>
   </p:cSld>
@@ -16668,7 +16668,7 @@
           <p:cNvPr id="12" name="">
             <a:extLst xmlns:a="http://schemas.openxmlformats.org/drawingml/2006/main">
               <a:ext uri="{FF2B5EF4-FFF2-40B4-BE49-F238E27FC236}">
-                <a16:creationId xmlns:a16="http://schemas.microsoft.com/office/drawing/2014/main" id="{E3160744-85C4-4FEC-9BA6-6AC74BB3023A}"/>
+                <a16:creationId xmlns:a16="http://schemas.microsoft.com/office/drawing/2014/main" id="{1050EC13-1254-42A4-8361-F16AB17D6F2F}"/>
               </a:ext>
             </a:extLst>
           </p:cNvPr>
@@ -16734,7 +16734,7 @@
           <p:cNvPr id="2" name="">
             <a:extLst xmlns:a="http://schemas.openxmlformats.org/drawingml/2006/main">
               <a:ext uri="{FF2B5EF4-FFF2-40B4-BE49-F238E27FC236}">
-                <a16:creationId xmlns:a16="http://schemas.microsoft.com/office/drawing/2014/main" id="{45274590-E3A2-4A1E-98AE-87DFD22F56D5}"/>
+                <a16:creationId xmlns:a16="http://schemas.microsoft.com/office/drawing/2014/main" id="{AFEBFE91-B7F2-4EDC-AEBA-3A075BE6397D}"/>
               </a:ext>
             </a:extLst>
           </p:cNvPr>
@@ -16790,7 +16790,7 @@
                 <a:ea typeface="Arial"/>
                 <a:cs typeface="Arial"/>
               </a:rPr>
-              <a:t>7. Preferences and confidence</a:t>
+              <a:t>7. Candidate score evidence</a:t>
             </a:r>
           </a:p>
         </p:txBody>
@@ -16800,7 +16800,7 @@
           <p:cNvPr id="3" name="">
             <a:extLst xmlns:a="http://schemas.openxmlformats.org/drawingml/2006/main">
               <a:ext uri="{FF2B5EF4-FFF2-40B4-BE49-F238E27FC236}">
-                <a16:creationId xmlns:a16="http://schemas.microsoft.com/office/drawing/2014/main" id="{98A2C411-0C81-4E2E-9DE6-C889E0166C01}"/>
+                <a16:creationId xmlns:a16="http://schemas.microsoft.com/office/drawing/2014/main" id="{7B9BB768-8402-45DA-BB90-52889044180F}"/>
               </a:ext>
             </a:extLst>
           </p:cNvPr>
@@ -16856,7 +16856,7 @@
                 <a:ea typeface="Arial"/>
                 <a:cs typeface="Arial"/>
               </a:rPr>
-              <a:t>The right panel changes how model evidence enters the ranking</a:t>
+              <a:t>Inspect how uncertainty affects each candidate, without fixed percentage controls</a:t>
             </a:r>
           </a:p>
         </p:txBody>
@@ -16866,7 +16866,7 @@
           <p:cNvPr id="4" name="">
             <a:extLst xmlns:a="http://schemas.openxmlformats.org/drawingml/2006/main">
               <a:ext uri="{FF2B5EF4-FFF2-40B4-BE49-F238E27FC236}">
-                <a16:creationId xmlns:a16="http://schemas.microsoft.com/office/drawing/2014/main" id="{E4A05D04-692D-4804-90AB-90501B818393}"/>
+                <a16:creationId xmlns:a16="http://schemas.microsoft.com/office/drawing/2014/main" id="{5AD088C5-84DB-4926-BD77-250FF971EE0A}"/>
               </a:ext>
             </a:extLst>
           </p:cNvPr>
@@ -16932,7 +16932,7 @@
           <p:cNvPr id="5" name="">
             <a:extLst xmlns:a="http://schemas.openxmlformats.org/drawingml/2006/main">
               <a:ext uri="{FF2B5EF4-FFF2-40B4-BE49-F238E27FC236}">
-                <a16:creationId xmlns:a16="http://schemas.microsoft.com/office/drawing/2014/main" id="{B4ACFD58-C478-455D-B1C0-E38E70F64E01}"/>
+                <a16:creationId xmlns:a16="http://schemas.microsoft.com/office/drawing/2014/main" id="{E2427C10-5377-4CA1-9CCE-A637F7B7247B}"/>
               </a:ext>
             </a:extLst>
           </p:cNvPr>
@@ -16998,7 +16998,7 @@
           <p:cNvPr id="6" name="">
             <a:extLst xmlns:a="http://schemas.openxmlformats.org/drawingml/2006/main">
               <a:ext uri="{FF2B5EF4-FFF2-40B4-BE49-F238E27FC236}">
-                <a16:creationId xmlns:a16="http://schemas.microsoft.com/office/drawing/2014/main" id="{59E25F8F-F0BB-4E4F-BAB7-67AC9F4485A8}"/>
+                <a16:creationId xmlns:a16="http://schemas.microsoft.com/office/drawing/2014/main" id="{6C0AAF11-B044-4CA5-ADF1-943DC984609C}"/>
               </a:ext>
             </a:extLst>
           </p:cNvPr>
@@ -17054,7 +17054,7 @@
                 <a:ea typeface="Arial"/>
                 <a:cs typeface="Arial"/>
               </a:rPr>
-              <a:t>Preference sets your priorities</a:t>
+              <a:t>The Assistant sets an evidence-informed policy</a:t>
             </a:r>
           </a:p>
         </p:txBody>
@@ -17064,7 +17064,7 @@
           <p:cNvPr id="7" name="">
             <a:extLst xmlns:a="http://schemas.openxmlformats.org/drawingml/2006/main">
               <a:ext uri="{FF2B5EF4-FFF2-40B4-BE49-F238E27FC236}">
-                <a16:creationId xmlns:a16="http://schemas.microsoft.com/office/drawing/2014/main" id="{EC2336E3-6F8B-465D-917F-52695AC27D5D}"/>
+                <a16:creationId xmlns:a16="http://schemas.microsoft.com/office/drawing/2014/main" id="{72497B0F-5CAD-44BE-B31B-9D64381D5F8B}"/>
               </a:ext>
             </a:extLst>
           </p:cNvPr>
@@ -17076,7 +17076,7 @@
         <p:spPr>
           <a:xfrm xmlns:a="http://schemas.openxmlformats.org/drawingml/2006/main">
             <a:off x="762000" y="4714875"/>
-            <a:ext cx="13716000" cy="1428750"/>
+            <a:ext cx="13716000" cy="1866900"/>
           </a:xfrm>
           <a:prstGeom xmlns:a="http://schemas.openxmlformats.org/drawingml/2006/main" prst="rect">
             <a:avLst/>
@@ -17120,7 +17120,7 @@
                 <a:ea typeface="Arial"/>
                 <a:cs typeface="Arial"/>
               </a:rPr>
-              <a:t>Increase a property’s preference when it matters more to your design. A positive pH weight requires a target pH. Confidence controls how strongly a predictor should influence this run.</a:t>
+              <a:t>Choose a candidate in the right panel. Compare its model predictions, measured uncertainty and actual influence coefficients. The Agent sets a reliability policy; code applies uncertainty using each model’s own scale. Predictions remain unchanged.</a:t>
             </a:r>
           </a:p>
         </p:txBody>
@@ -17130,7 +17130,7 @@
           <p:cNvPr id="8" name="">
             <a:extLst xmlns:a="http://schemas.openxmlformats.org/drawingml/2006/main">
               <a:ext uri="{FF2B5EF4-FFF2-40B4-BE49-F238E27FC236}">
-                <a16:creationId xmlns:a16="http://schemas.microsoft.com/office/drawing/2014/main" id="{DF339DB3-5F2E-4959-9CF6-EC201515C6B9}"/>
+                <a16:creationId xmlns:a16="http://schemas.microsoft.com/office/drawing/2014/main" id="{3F26870C-10EF-4674-82B1-B45E1DE18A4B}"/>
               </a:ext>
             </a:extLst>
           </p:cNvPr>
@@ -17196,7 +17196,7 @@
           <p:cNvPr id="9" name="">
             <a:extLst xmlns:a="http://schemas.openxmlformats.org/drawingml/2006/main">
               <a:ext uri="{FF2B5EF4-FFF2-40B4-BE49-F238E27FC236}">
-                <a16:creationId xmlns:a16="http://schemas.microsoft.com/office/drawing/2014/main" id="{75EBC7E4-8C08-4F94-B465-A9651C5368D0}"/>
+                <a16:creationId xmlns:a16="http://schemas.microsoft.com/office/drawing/2014/main" id="{A00FB2B0-B55A-4D0E-BD05-A1995C6E3142}"/>
               </a:ext>
             </a:extLst>
           </p:cNvPr>
@@ -17208,7 +17208,7 @@
         <p:spPr>
           <a:xfrm xmlns:a="http://schemas.openxmlformats.org/drawingml/2006/main">
             <a:off x="762000" y="8001000"/>
-            <a:ext cx="13716000" cy="1428750"/>
+            <a:ext cx="13716000" cy="1866900"/>
           </a:xfrm>
           <a:prstGeom xmlns:a="http://schemas.openxmlformats.org/drawingml/2006/main" prst="rect">
             <a:avLst/>
@@ -17252,7 +17252,7 @@
                 <a:ea typeface="Arial"/>
                 <a:cs typeface="Arial"/>
               </a:rPr>
-              <a:t>The Assistant reads available predictions and uncertainty, then requests a validated balance_scores tool call. The panel shows normalized effective shares. Apply manual edits and check that the status is Applied.</a:t>
+              <a:t>Open Assistant policy decision to inspect the recorded tool explanation. The chart separates measured prediction evidence from the neutral baseline retained under uncertainty. Continue to Output when scores are ready.</a:t>
             </a:r>
           </a:p>
         </p:txBody>
@@ -17262,7 +17262,7 @@
           <p:cNvPr id="10" name="">
             <a:extLst xmlns:a="http://schemas.openxmlformats.org/drawingml/2006/main">
               <a:ext uri="{FF2B5EF4-FFF2-40B4-BE49-F238E27FC236}">
-                <a16:creationId xmlns:a16="http://schemas.microsoft.com/office/drawing/2014/main" id="{DF9D34A9-D682-43F1-8211-1FA608BCAE87}"/>
+                <a16:creationId xmlns:a16="http://schemas.microsoft.com/office/drawing/2014/main" id="{D7725E3C-0AB8-482A-B19F-3DDF19FE7084}"/>
               </a:ext>
             </a:extLst>
           </p:cNvPr>
@@ -17272,7 +17272,7 @@
           <p:nvPr/>
         </p:nvPicPr>
         <p:blipFill>
-          <a:blip xmlns:r="http://schemas.openxmlformats.org/officeDocument/2006/relationships" xmlns:a="http://schemas.openxmlformats.org/drawingml/2006/main" r:embed="R152e254b1e034b95"/>
+          <a:blip xmlns:r="http://schemas.openxmlformats.org/officeDocument/2006/relationships" xmlns:a="http://schemas.openxmlformats.org/drawingml/2006/main" r:embed="Ra9c1e7a58522419c"/>
           <a:stretch xmlns:a="http://schemas.openxmlformats.org/drawingml/2006/main"/>
         </p:blipFill>
         <p:spPr>
@@ -17290,7 +17290,7 @@
           <p:cNvPr id="11" name="">
             <a:extLst xmlns:a="http://schemas.openxmlformats.org/drawingml/2006/main">
               <a:ext uri="{FF2B5EF4-FFF2-40B4-BE49-F238E27FC236}">
-                <a16:creationId xmlns:a16="http://schemas.microsoft.com/office/drawing/2014/main" id="{92B3371F-2ED6-426C-9FBC-F13008AD5ABD}"/>
+                <a16:creationId xmlns:a16="http://schemas.microsoft.com/office/drawing/2014/main" id="{5682620B-AB34-4C0D-9D10-E08ECD4786A8}"/>
               </a:ext>
             </a:extLst>
           </p:cNvPr>
@@ -17354,7 +17354,7 @@
     </p:spTree>
     <p:extLst>
       <p:ext uri="{BB962C8B-B14F-4D97-AF65-F5344CB8AC3E}">
-        <p14:creationId xmlns:p14="http://schemas.microsoft.com/office/powerpoint/2010/main" val="528872664"/>
+        <p14:creationId xmlns:p14="http://schemas.microsoft.com/office/powerpoint/2010/main" val="1273777084"/>
       </p:ext>
     </p:extLst>
   </p:cSld>
@@ -17385,7 +17385,7 @@
           <p:cNvPr id="11" name="">
             <a:extLst xmlns:a="http://schemas.openxmlformats.org/drawingml/2006/main">
               <a:ext uri="{FF2B5EF4-FFF2-40B4-BE49-F238E27FC236}">
-                <a16:creationId xmlns:a16="http://schemas.microsoft.com/office/drawing/2014/main" id="{7FE11706-D1BA-4782-8C83-89F418C6F920}"/>
+                <a16:creationId xmlns:a16="http://schemas.microsoft.com/office/drawing/2014/main" id="{0B74112F-5DB1-4B80-899D-05072EAB4E3E}"/>
               </a:ext>
             </a:extLst>
           </p:cNvPr>
@@ -17451,7 +17451,7 @@
           <p:cNvPr id="2" name="">
             <a:extLst xmlns:a="http://schemas.openxmlformats.org/drawingml/2006/main">
               <a:ext uri="{FF2B5EF4-FFF2-40B4-BE49-F238E27FC236}">
-                <a16:creationId xmlns:a16="http://schemas.microsoft.com/office/drawing/2014/main" id="{C3C31E5B-01D9-4B73-99A0-8914E3DB947D}"/>
+                <a16:creationId xmlns:a16="http://schemas.microsoft.com/office/drawing/2014/main" id="{BEAF7FE2-7905-4A7F-9B48-F013A14B5AE3}"/>
               </a:ext>
             </a:extLst>
           </p:cNvPr>
@@ -17517,7 +17517,7 @@
           <p:cNvPr id="3" name="">
             <a:extLst xmlns:a="http://schemas.openxmlformats.org/drawingml/2006/main">
               <a:ext uri="{FF2B5EF4-FFF2-40B4-BE49-F238E27FC236}">
-                <a16:creationId xmlns:a16="http://schemas.microsoft.com/office/drawing/2014/main" id="{0F20137D-2E9C-47E5-B791-A643B0E4ED2E}"/>
+                <a16:creationId xmlns:a16="http://schemas.microsoft.com/office/drawing/2014/main" id="{E27D79AA-2BF4-4150-913E-473A1A1C4A41}"/>
               </a:ext>
             </a:extLst>
           </p:cNvPr>
@@ -17583,7 +17583,7 @@
           <p:cNvPr id="4" name="">
             <a:extLst xmlns:a="http://schemas.openxmlformats.org/drawingml/2006/main">
               <a:ext uri="{FF2B5EF4-FFF2-40B4-BE49-F238E27FC236}">
-                <a16:creationId xmlns:a16="http://schemas.microsoft.com/office/drawing/2014/main" id="{B2F3C5D6-19DB-4C13-90FF-CD2DB9543D3F}"/>
+                <a16:creationId xmlns:a16="http://schemas.microsoft.com/office/drawing/2014/main" id="{34AB3D23-C82A-4C45-8302-F500EFF4AFB3}"/>
               </a:ext>
             </a:extLst>
           </p:cNvPr>
@@ -17649,7 +17649,7 @@
           <p:cNvPr id="5" name="">
             <a:extLst xmlns:a="http://schemas.openxmlformats.org/drawingml/2006/main">
               <a:ext uri="{FF2B5EF4-FFF2-40B4-BE49-F238E27FC236}">
-                <a16:creationId xmlns:a16="http://schemas.microsoft.com/office/drawing/2014/main" id="{FB104EF8-83B9-416D-9593-DA481C7DF523}"/>
+                <a16:creationId xmlns:a16="http://schemas.microsoft.com/office/drawing/2014/main" id="{CB08AA8D-2CE8-4736-A672-E06DDD3EEF05}"/>
               </a:ext>
             </a:extLst>
           </p:cNvPr>
@@ -17715,7 +17715,7 @@
           <p:cNvPr id="6" name="">
             <a:extLst xmlns:a="http://schemas.openxmlformats.org/drawingml/2006/main">
               <a:ext uri="{FF2B5EF4-FFF2-40B4-BE49-F238E27FC236}">
-                <a16:creationId xmlns:a16="http://schemas.microsoft.com/office/drawing/2014/main" id="{DF4216F5-53EB-4CC9-A843-F45FF9774E6B}"/>
+                <a16:creationId xmlns:a16="http://schemas.microsoft.com/office/drawing/2014/main" id="{F821DA6E-6C3F-4065-808D-450B8A8E06B8}"/>
               </a:ext>
             </a:extLst>
           </p:cNvPr>
@@ -17725,7 +17725,7 @@
           <p:nvPr/>
         </p:nvPicPr>
         <p:blipFill>
-          <a:blip xmlns:r="http://schemas.openxmlformats.org/officeDocument/2006/relationships" xmlns:a="http://schemas.openxmlformats.org/drawingml/2006/main" r:embed="Ra8f4040ddfa64faa"/>
+          <a:blip xmlns:r="http://schemas.openxmlformats.org/officeDocument/2006/relationships" xmlns:a="http://schemas.openxmlformats.org/drawingml/2006/main" r:embed="R9311044e2d9e4689"/>
           <a:stretch xmlns:a="http://schemas.openxmlformats.org/drawingml/2006/main"/>
         </p:blipFill>
         <p:spPr>
@@ -17743,7 +17743,7 @@
           <p:cNvPr id="7" name="">
             <a:extLst xmlns:a="http://schemas.openxmlformats.org/drawingml/2006/main">
               <a:ext uri="{FF2B5EF4-FFF2-40B4-BE49-F238E27FC236}">
-                <a16:creationId xmlns:a16="http://schemas.microsoft.com/office/drawing/2014/main" id="{42EA9F26-4401-4F7A-AD45-5AAC1ED8E149}"/>
+                <a16:creationId xmlns:a16="http://schemas.microsoft.com/office/drawing/2014/main" id="{ED6E463B-B101-4F49-A293-6EB7EA4AF461}"/>
               </a:ext>
             </a:extLst>
           </p:cNvPr>
@@ -17809,7 +17809,7 @@
           <p:cNvPr id="8" name="">
             <a:extLst xmlns:a="http://schemas.openxmlformats.org/drawingml/2006/main">
               <a:ext uri="{FF2B5EF4-FFF2-40B4-BE49-F238E27FC236}">
-                <a16:creationId xmlns:a16="http://schemas.microsoft.com/office/drawing/2014/main" id="{65248DB0-DA8D-4FA6-A915-A23E09318676}"/>
+                <a16:creationId xmlns:a16="http://schemas.microsoft.com/office/drawing/2014/main" id="{CAC504EC-B88F-495A-A166-3FC07D529D4D}"/>
               </a:ext>
             </a:extLst>
           </p:cNvPr>
@@ -17875,7 +17875,7 @@
           <p:cNvPr id="9" name="">
             <a:extLst xmlns:a="http://schemas.openxmlformats.org/drawingml/2006/main">
               <a:ext uri="{FF2B5EF4-FFF2-40B4-BE49-F238E27FC236}">
-                <a16:creationId xmlns:a16="http://schemas.microsoft.com/office/drawing/2014/main" id="{45814966-9F8F-4FF2-BD29-CA2F73C4A25D}"/>
+                <a16:creationId xmlns:a16="http://schemas.microsoft.com/office/drawing/2014/main" id="{80A10956-EBBD-46FD-8701-E1EC72EF8AA1}"/>
               </a:ext>
             </a:extLst>
           </p:cNvPr>
@@ -17941,7 +17941,7 @@
           <p:cNvPr id="10" name="">
             <a:extLst xmlns:a="http://schemas.openxmlformats.org/drawingml/2006/main">
               <a:ext uri="{FF2B5EF4-FFF2-40B4-BE49-F238E27FC236}">
-                <a16:creationId xmlns:a16="http://schemas.microsoft.com/office/drawing/2014/main" id="{D64D1398-09A7-4D1E-90CD-BA7E7EAFEC81}"/>
+                <a16:creationId xmlns:a16="http://schemas.microsoft.com/office/drawing/2014/main" id="{564D908A-4408-4708-8B94-1281E8CCC9B3}"/>
               </a:ext>
             </a:extLst>
           </p:cNvPr>
@@ -18005,7 +18005,7 @@
     </p:spTree>
     <p:extLst>
       <p:ext uri="{BB962C8B-B14F-4D97-AF65-F5344CB8AC3E}">
-        <p14:creationId xmlns:p14="http://schemas.microsoft.com/office/powerpoint/2010/main" val="1720588959"/>
+        <p14:creationId xmlns:p14="http://schemas.microsoft.com/office/powerpoint/2010/main" val="1891978112"/>
       </p:ext>
     </p:extLst>
   </p:cSld>

</xml_diff>